<commit_message>
Rename product to Delegate and remove audience branding
</commit_message>
<xml_diff>
--- a/apps/about/public/briefings/detailed.pptx
+++ b/apps/about/public/briefings/detailed.pptx
@@ -2,30 +2,30 @@
 <file path=ppt/presentation.xml><?xml version="1.0" encoding="utf-8"?>
 <p:presentation xmlns:p="http://schemas.openxmlformats.org/presentationml/2006/main">
   <p:sldMasterIdLst>
-    <p:sldMasterId xmlns:r="http://schemas.openxmlformats.org/officeDocument/2006/relationships" id="2147483648" r:id="R2fbd933120c54a40"/>
+    <p:sldMasterId xmlns:r="http://schemas.openxmlformats.org/officeDocument/2006/relationships" id="2147483648" r:id="Re944dc31679045c5"/>
   </p:sldMasterIdLst>
   <p:notesMasterIdLst>
-    <p:notesMasterId xmlns:r="http://schemas.openxmlformats.org/officeDocument/2006/relationships" r:id="Rbb85c8b4726d4917"/>
+    <p:notesMasterId xmlns:r="http://schemas.openxmlformats.org/officeDocument/2006/relationships" r:id="Rc58a2bb543b14c7f"/>
   </p:notesMasterIdLst>
   <p:sldIdLst>
-    <p:sldId xmlns:r="http://schemas.openxmlformats.org/officeDocument/2006/relationships" id="256" r:id="R2fe2fe2d0d9348e3"/>
-    <p:sldId xmlns:r="http://schemas.openxmlformats.org/officeDocument/2006/relationships" id="257" r:id="Re3c07f62792242e6"/>
-    <p:sldId xmlns:r="http://schemas.openxmlformats.org/officeDocument/2006/relationships" id="258" r:id="R314185154f48492e"/>
-    <p:sldId xmlns:r="http://schemas.openxmlformats.org/officeDocument/2006/relationships" id="259" r:id="R22a3937837f744d0"/>
-    <p:sldId xmlns:r="http://schemas.openxmlformats.org/officeDocument/2006/relationships" id="260" r:id="Rac0ce43c3fbf4371"/>
-    <p:sldId xmlns:r="http://schemas.openxmlformats.org/officeDocument/2006/relationships" id="261" r:id="Ra6c717994e30498a"/>
-    <p:sldId xmlns:r="http://schemas.openxmlformats.org/officeDocument/2006/relationships" id="262" r:id="Rf41f14c6c49a4298"/>
-    <p:sldId xmlns:r="http://schemas.openxmlformats.org/officeDocument/2006/relationships" id="263" r:id="Rcb4004ec12ce41b9"/>
-    <p:sldId xmlns:r="http://schemas.openxmlformats.org/officeDocument/2006/relationships" id="264" r:id="Ra7d06320f3ee455c"/>
-    <p:sldId xmlns:r="http://schemas.openxmlformats.org/officeDocument/2006/relationships" id="265" r:id="Rcda46ed262014f6d"/>
-    <p:sldId xmlns:r="http://schemas.openxmlformats.org/officeDocument/2006/relationships" id="266" r:id="R9595fe77782c46fd"/>
-    <p:sldId xmlns:r="http://schemas.openxmlformats.org/officeDocument/2006/relationships" id="267" r:id="Rb64b91ea0f8544d5"/>
-    <p:sldId xmlns:r="http://schemas.openxmlformats.org/officeDocument/2006/relationships" id="268" r:id="R2beab8e8e1e54d10"/>
-    <p:sldId xmlns:r="http://schemas.openxmlformats.org/officeDocument/2006/relationships" id="269" r:id="R985aeba2263f402d"/>
-    <p:sldId xmlns:r="http://schemas.openxmlformats.org/officeDocument/2006/relationships" id="270" r:id="R76a3ffebaacb4eab"/>
-    <p:sldId xmlns:r="http://schemas.openxmlformats.org/officeDocument/2006/relationships" id="271" r:id="R178e6bb83a2d4793"/>
-    <p:sldId xmlns:r="http://schemas.openxmlformats.org/officeDocument/2006/relationships" id="272" r:id="R85ac2e701dee463b"/>
-    <p:sldId xmlns:r="http://schemas.openxmlformats.org/officeDocument/2006/relationships" id="273" r:id="R8cd0c1944f294f7a"/>
+    <p:sldId xmlns:r="http://schemas.openxmlformats.org/officeDocument/2006/relationships" id="256" r:id="R6735a13901c44299"/>
+    <p:sldId xmlns:r="http://schemas.openxmlformats.org/officeDocument/2006/relationships" id="257" r:id="R9548e21b3ec54ad1"/>
+    <p:sldId xmlns:r="http://schemas.openxmlformats.org/officeDocument/2006/relationships" id="258" r:id="R6acef588172c45e6"/>
+    <p:sldId xmlns:r="http://schemas.openxmlformats.org/officeDocument/2006/relationships" id="259" r:id="Rf5c8a5e1ebf045ab"/>
+    <p:sldId xmlns:r="http://schemas.openxmlformats.org/officeDocument/2006/relationships" id="260" r:id="Rf218c7a52dea4d48"/>
+    <p:sldId xmlns:r="http://schemas.openxmlformats.org/officeDocument/2006/relationships" id="261" r:id="R8538fa1474b1440b"/>
+    <p:sldId xmlns:r="http://schemas.openxmlformats.org/officeDocument/2006/relationships" id="262" r:id="R4aff35547c874489"/>
+    <p:sldId xmlns:r="http://schemas.openxmlformats.org/officeDocument/2006/relationships" id="263" r:id="Rf8be2dde811c41b1"/>
+    <p:sldId xmlns:r="http://schemas.openxmlformats.org/officeDocument/2006/relationships" id="264" r:id="Ra09ddb8152a7415a"/>
+    <p:sldId xmlns:r="http://schemas.openxmlformats.org/officeDocument/2006/relationships" id="265" r:id="R30544b082a004245"/>
+    <p:sldId xmlns:r="http://schemas.openxmlformats.org/officeDocument/2006/relationships" id="266" r:id="Rc19caeaf7ab84701"/>
+    <p:sldId xmlns:r="http://schemas.openxmlformats.org/officeDocument/2006/relationships" id="267" r:id="R1a93b5e35a474d6f"/>
+    <p:sldId xmlns:r="http://schemas.openxmlformats.org/officeDocument/2006/relationships" id="268" r:id="Rdebed9b021d14475"/>
+    <p:sldId xmlns:r="http://schemas.openxmlformats.org/officeDocument/2006/relationships" id="269" r:id="Rc96f9e6eb50443d2"/>
+    <p:sldId xmlns:r="http://schemas.openxmlformats.org/officeDocument/2006/relationships" id="270" r:id="Rd25554d706c44d3e"/>
+    <p:sldId xmlns:r="http://schemas.openxmlformats.org/officeDocument/2006/relationships" id="271" r:id="R0b5bf189d9e54495"/>
+    <p:sldId xmlns:r="http://schemas.openxmlformats.org/officeDocument/2006/relationships" id="272" r:id="R22c822a0407041c4"/>
+    <p:sldId xmlns:r="http://schemas.openxmlformats.org/officeDocument/2006/relationships" id="273" r:id="R540a4724b4d34257"/>
   </p:sldIdLst>
   <p:sldSz cx="12192000" cy="6858000"/>
   <p:notesSz cx="6858000" cy="9144000"/>
@@ -2241,7 +2241,7 @@
           <p:cNvPr id="3" name="Title">
             <a:extLst xmlns:a="http://schemas.openxmlformats.org/drawingml/2006/main">
               <a:ext uri="{FF2B5EF4-FFF2-40B4-BE49-F238E27FC236}">
-                <a16:creationId xmlns:a16="http://schemas.microsoft.com/office/drawing/2014/main" id="{1D4D5196-DBA2-4401-B5B2-F733429FFE83}"/>
+                <a16:creationId xmlns:a16="http://schemas.microsoft.com/office/drawing/2014/main" id="{68C17EAC-16B1-496A-9E2B-F5A5D78A72DB}"/>
               </a:ext>
             </a:extLst>
           </p:cNvPr>
@@ -2398,7 +2398,7 @@
           <p:cNvPr id="2" name="Subtitle">
             <a:extLst xmlns:a="http://schemas.openxmlformats.org/drawingml/2006/main">
               <a:ext uri="{FF2B5EF4-FFF2-40B4-BE49-F238E27FC236}">
-                <a16:creationId xmlns:a16="http://schemas.microsoft.com/office/drawing/2014/main" id="{4E22BFFD-3AE1-4F7E-8FD0-C1AC68622DDE}"/>
+                <a16:creationId xmlns:a16="http://schemas.microsoft.com/office/drawing/2014/main" id="{F5481D1A-3FB3-49DB-9E46-E0C264C15E1C}"/>
               </a:ext>
             </a:extLst>
           </p:cNvPr>
@@ -2572,7 +2572,7 @@
           <p:cNvPr id="2" name="Section title">
             <a:extLst xmlns:a="http://schemas.openxmlformats.org/drawingml/2006/main">
               <a:ext uri="{FF2B5EF4-FFF2-40B4-BE49-F238E27FC236}">
-                <a16:creationId xmlns:a16="http://schemas.microsoft.com/office/drawing/2014/main" id="{6E6EC222-221F-440C-BBC3-42E6D88AC909}"/>
+                <a16:creationId xmlns:a16="http://schemas.microsoft.com/office/drawing/2014/main" id="{A88597B4-1F4B-4EF1-9263-BD11AB294B34}"/>
               </a:ext>
             </a:extLst>
           </p:cNvPr>
@@ -2746,7 +2746,7 @@
           <p:cNvPr id="3" name="Title">
             <a:extLst xmlns:a="http://schemas.openxmlformats.org/drawingml/2006/main">
               <a:ext uri="{FF2B5EF4-FFF2-40B4-BE49-F238E27FC236}">
-                <a16:creationId xmlns:a16="http://schemas.microsoft.com/office/drawing/2014/main" id="{F51FC321-09B8-420B-9E3E-E3B71DCDF1FC}"/>
+                <a16:creationId xmlns:a16="http://schemas.microsoft.com/office/drawing/2014/main" id="{35E637B2-8FE5-4B79-8796-B2EC10C951FD}"/>
               </a:ext>
             </a:extLst>
           </p:cNvPr>
@@ -2903,7 +2903,7 @@
           <p:cNvPr id="2" name="Body">
             <a:extLst xmlns:a="http://schemas.openxmlformats.org/drawingml/2006/main">
               <a:ext uri="{FF2B5EF4-FFF2-40B4-BE49-F238E27FC236}">
-                <a16:creationId xmlns:a16="http://schemas.microsoft.com/office/drawing/2014/main" id="{A60123D2-92F5-4DE2-AFC0-3A9B21935DAC}"/>
+                <a16:creationId xmlns:a16="http://schemas.microsoft.com/office/drawing/2014/main" id="{3F4A2870-568C-4A4F-9267-54F3B05E27FF}"/>
               </a:ext>
             </a:extLst>
           </p:cNvPr>
@@ -3077,7 +3077,7 @@
           <p:cNvPr id="4" name="Title">
             <a:extLst xmlns:a="http://schemas.openxmlformats.org/drawingml/2006/main">
               <a:ext uri="{FF2B5EF4-FFF2-40B4-BE49-F238E27FC236}">
-                <a16:creationId xmlns:a16="http://schemas.microsoft.com/office/drawing/2014/main" id="{2528F5FB-34C8-40A2-8E11-E8AB69565AA6}"/>
+                <a16:creationId xmlns:a16="http://schemas.microsoft.com/office/drawing/2014/main" id="{E7E48DD3-7149-4B60-9D7B-1C180421E938}"/>
               </a:ext>
             </a:extLst>
           </p:cNvPr>
@@ -3234,7 +3234,7 @@
           <p:cNvPr id="2" name="Left column">
             <a:extLst xmlns:a="http://schemas.openxmlformats.org/drawingml/2006/main">
               <a:ext uri="{FF2B5EF4-FFF2-40B4-BE49-F238E27FC236}">
-                <a16:creationId xmlns:a16="http://schemas.microsoft.com/office/drawing/2014/main" id="{28AA1A51-B572-4488-AA5B-6DBCDAED8510}"/>
+                <a16:creationId xmlns:a16="http://schemas.microsoft.com/office/drawing/2014/main" id="{E8FF1EB6-6213-4085-8ECE-E06E71342D4B}"/>
               </a:ext>
             </a:extLst>
           </p:cNvPr>
@@ -3391,7 +3391,7 @@
           <p:cNvPr id="3" name="Right column">
             <a:extLst xmlns:a="http://schemas.openxmlformats.org/drawingml/2006/main">
               <a:ext uri="{FF2B5EF4-FFF2-40B4-BE49-F238E27FC236}">
-                <a16:creationId xmlns:a16="http://schemas.microsoft.com/office/drawing/2014/main" id="{543DACEF-5839-45E8-979F-49F337868344}"/>
+                <a16:creationId xmlns:a16="http://schemas.microsoft.com/office/drawing/2014/main" id="{464070F4-D796-444D-A60E-61E786013C16}"/>
               </a:ext>
             </a:extLst>
           </p:cNvPr>
@@ -3565,7 +3565,7 @@
           <p:cNvPr id="3" name="Title">
             <a:extLst xmlns:a="http://schemas.openxmlformats.org/drawingml/2006/main">
               <a:ext uri="{FF2B5EF4-FFF2-40B4-BE49-F238E27FC236}">
-                <a16:creationId xmlns:a16="http://schemas.microsoft.com/office/drawing/2014/main" id="{35E70E0F-2464-49A5-A62C-7872DF21B9C0}"/>
+                <a16:creationId xmlns:a16="http://schemas.microsoft.com/office/drawing/2014/main" id="{4B24F260-5D6D-40FB-9E70-2BDF1BAA9189}"/>
               </a:ext>
             </a:extLst>
           </p:cNvPr>
@@ -3722,7 +3722,7 @@
           <p:cNvPr id="2" name="Left column">
             <a:extLst xmlns:a="http://schemas.openxmlformats.org/drawingml/2006/main">
               <a:ext uri="{FF2B5EF4-FFF2-40B4-BE49-F238E27FC236}">
-                <a16:creationId xmlns:a16="http://schemas.microsoft.com/office/drawing/2014/main" id="{9196A9EA-4E4E-482C-92BF-36404BE3B5CC}"/>
+                <a16:creationId xmlns:a16="http://schemas.microsoft.com/office/drawing/2014/main" id="{60B493F8-F97E-4F21-B2F1-2EBF467D932B}"/>
               </a:ext>
             </a:extLst>
           </p:cNvPr>
@@ -3917,12 +3917,12 @@
   </p:cSld>
   <p:clrMap bg1="lt1" tx1="dk1" bg2="lt2" tx2="dk2" accent1="accent1" accent2="accent2" accent3="accent3" accent4="accent4" accent5="accent5" accent6="accent6" hlink="hlink" folHlink="folHlink"/>
   <p:sldLayoutIdLst>
-    <p:sldLayoutId xmlns:r="http://schemas.openxmlformats.org/officeDocument/2006/relationships" id="2147483649" r:id="R31fffb96189e40d0"/>
-    <p:sldLayoutId xmlns:r="http://schemas.openxmlformats.org/officeDocument/2006/relationships" id="2147483650" r:id="R53d4b43bf73849e6"/>
-    <p:sldLayoutId xmlns:r="http://schemas.openxmlformats.org/officeDocument/2006/relationships" id="2147483651" r:id="R0b5234bccc784a96"/>
-    <p:sldLayoutId xmlns:r="http://schemas.openxmlformats.org/officeDocument/2006/relationships" id="2147483652" r:id="R49a4172f474e4571"/>
-    <p:sldLayoutId xmlns:r="http://schemas.openxmlformats.org/officeDocument/2006/relationships" id="2147483653" r:id="R6e0ede46c43d4da3"/>
-    <p:sldLayoutId xmlns:r="http://schemas.openxmlformats.org/officeDocument/2006/relationships" id="2147483654" r:id="R2823a64d82a64d44"/>
+    <p:sldLayoutId xmlns:r="http://schemas.openxmlformats.org/officeDocument/2006/relationships" id="2147483649" r:id="R567989f058414752"/>
+    <p:sldLayoutId xmlns:r="http://schemas.openxmlformats.org/officeDocument/2006/relationships" id="2147483650" r:id="R0acd1aab72aa44d1"/>
+    <p:sldLayoutId xmlns:r="http://schemas.openxmlformats.org/officeDocument/2006/relationships" id="2147483651" r:id="Rb4bff0f103bf4ff5"/>
+    <p:sldLayoutId xmlns:r="http://schemas.openxmlformats.org/officeDocument/2006/relationships" id="2147483652" r:id="R9635061548ec48db"/>
+    <p:sldLayoutId xmlns:r="http://schemas.openxmlformats.org/officeDocument/2006/relationships" id="2147483653" r:id="Rd60479e84459466a"/>
+    <p:sldLayoutId xmlns:r="http://schemas.openxmlformats.org/officeDocument/2006/relationships" id="2147483654" r:id="Ra8c98c7272944798"/>
   </p:sldLayoutIdLst>
   <p:txStyles>
     <p:titleStyle>
@@ -4473,7 +4473,7 @@
           <p:cNvPr id="6" name="title">
             <a:extLst xmlns:a="http://schemas.openxmlformats.org/drawingml/2006/main">
               <a:ext uri="{FF2B5EF4-FFF2-40B4-BE49-F238E27FC236}">
-                <a16:creationId xmlns:a16="http://schemas.microsoft.com/office/drawing/2014/main" id="{C98A6FB8-B97F-4A52-9296-3890B0D7E44A}"/>
+                <a16:creationId xmlns:a16="http://schemas.microsoft.com/office/drawing/2014/main" id="{7585D801-D1C9-4367-9DD0-C30E823F64B3}"/>
               </a:ext>
             </a:extLst>
           </p:cNvPr>
@@ -4529,7 +4529,7 @@
                 <a:ea typeface="Arial"/>
                 <a:cs typeface="Arial"/>
               </a:rPr>
-              <a:t>GOV.UK Delegate: design review</a:t>
+              <a:t>Delegate: design review</a:t>
             </a:r>
           </a:p>
         </p:txBody>
@@ -4539,7 +4539,7 @@
           <p:cNvPr id="2" name="paragraph-0">
             <a:extLst xmlns:a="http://schemas.openxmlformats.org/drawingml/2006/main">
               <a:ext uri="{FF2B5EF4-FFF2-40B4-BE49-F238E27FC236}">
-                <a16:creationId xmlns:a16="http://schemas.microsoft.com/office/drawing/2014/main" id="{5E4A1FE7-411A-4EA3-90AD-14B3388CE032}"/>
+                <a16:creationId xmlns:a16="http://schemas.microsoft.com/office/drawing/2014/main" id="{6F92931E-4073-448A-8D91-E798C78D4AF9}"/>
               </a:ext>
             </a:extLst>
           </p:cNvPr>
@@ -4605,7 +4605,7 @@
           <p:cNvPr id="3" name="paragraph-1">
             <a:extLst xmlns:a="http://schemas.openxmlformats.org/drawingml/2006/main">
               <a:ext uri="{FF2B5EF4-FFF2-40B4-BE49-F238E27FC236}">
-                <a16:creationId xmlns:a16="http://schemas.microsoft.com/office/drawing/2014/main" id="{213FCC9D-49EC-425C-8DD5-9E31DCB8D832}"/>
+                <a16:creationId xmlns:a16="http://schemas.microsoft.com/office/drawing/2014/main" id="{435CE23B-2D6C-4C35-BF63-6B3D4F8D7EE8}"/>
               </a:ext>
             </a:extLst>
           </p:cNvPr>
@@ -4671,7 +4671,7 @@
           <p:cNvPr id="4" name="disclosure">
             <a:extLst xmlns:a="http://schemas.openxmlformats.org/drawingml/2006/main">
               <a:ext uri="{FF2B5EF4-FFF2-40B4-BE49-F238E27FC236}">
-                <a16:creationId xmlns:a16="http://schemas.microsoft.com/office/drawing/2014/main" id="{05B777B4-CC62-4EE0-93C0-15D04706BD1E}"/>
+                <a16:creationId xmlns:a16="http://schemas.microsoft.com/office/drawing/2014/main" id="{BB73B43D-E7C5-432A-AF6F-47E26C632E16}"/>
               </a:ext>
             </a:extLst>
           </p:cNvPr>
@@ -4737,7 +4737,7 @@
           <p:cNvPr id="5" name="page">
             <a:extLst xmlns:a="http://schemas.openxmlformats.org/drawingml/2006/main">
               <a:ext uri="{FF2B5EF4-FFF2-40B4-BE49-F238E27FC236}">
-                <a16:creationId xmlns:a16="http://schemas.microsoft.com/office/drawing/2014/main" id="{6D89CABC-4C9A-4508-8821-0F0684277983}"/>
+                <a16:creationId xmlns:a16="http://schemas.microsoft.com/office/drawing/2014/main" id="{AA922E01-D3E4-43F6-942E-EE7EC9605B50}"/>
               </a:ext>
             </a:extLst>
           </p:cNvPr>
@@ -4801,7 +4801,7 @@
     </p:spTree>
     <p:extLst>
       <p:ext uri="{BB962C8B-B14F-4D97-AF65-F5344CB8AC3E}">
-        <p14:creationId xmlns:p14="http://schemas.microsoft.com/office/powerpoint/2010/main" val="1380073946"/>
+        <p14:creationId xmlns:p14="http://schemas.microsoft.com/office/powerpoint/2010/main" val="749129420"/>
       </p:ext>
     </p:extLst>
   </p:cSld>
@@ -4832,7 +4832,7 @@
           <p:cNvPr id="6" name="title">
             <a:extLst xmlns:a="http://schemas.openxmlformats.org/drawingml/2006/main">
               <a:ext uri="{FF2B5EF4-FFF2-40B4-BE49-F238E27FC236}">
-                <a16:creationId xmlns:a16="http://schemas.microsoft.com/office/drawing/2014/main" id="{0BDBE508-3C78-4012-B00C-DBCC1A7AAB85}"/>
+                <a16:creationId xmlns:a16="http://schemas.microsoft.com/office/drawing/2014/main" id="{33159F14-3D2C-4B23-8788-BBFD2FD266D5}"/>
               </a:ext>
             </a:extLst>
           </p:cNvPr>
@@ -4898,7 +4898,7 @@
           <p:cNvPr id="2" name="paragraph-0">
             <a:extLst xmlns:a="http://schemas.openxmlformats.org/drawingml/2006/main">
               <a:ext uri="{FF2B5EF4-FFF2-40B4-BE49-F238E27FC236}">
-                <a16:creationId xmlns:a16="http://schemas.microsoft.com/office/drawing/2014/main" id="{5BE89609-3ECD-4008-BD9E-CB01426F8F91}"/>
+                <a16:creationId xmlns:a16="http://schemas.microsoft.com/office/drawing/2014/main" id="{C25EE8CB-7677-4B15-9420-B3FEB343FDAB}"/>
               </a:ext>
             </a:extLst>
           </p:cNvPr>
@@ -4964,7 +4964,7 @@
           <p:cNvPr id="3" name="paragraph-1">
             <a:extLst xmlns:a="http://schemas.openxmlformats.org/drawingml/2006/main">
               <a:ext uri="{FF2B5EF4-FFF2-40B4-BE49-F238E27FC236}">
-                <a16:creationId xmlns:a16="http://schemas.microsoft.com/office/drawing/2014/main" id="{15C29C6B-89B7-4FAD-BCF1-558648BB2DFC}"/>
+                <a16:creationId xmlns:a16="http://schemas.microsoft.com/office/drawing/2014/main" id="{7D604054-821C-415B-96D8-4C038D7AD7D1}"/>
               </a:ext>
             </a:extLst>
           </p:cNvPr>
@@ -5030,7 +5030,7 @@
           <p:cNvPr id="4" name="disclosure">
             <a:extLst xmlns:a="http://schemas.openxmlformats.org/drawingml/2006/main">
               <a:ext uri="{FF2B5EF4-FFF2-40B4-BE49-F238E27FC236}">
-                <a16:creationId xmlns:a16="http://schemas.microsoft.com/office/drawing/2014/main" id="{6BC6D8DD-4605-4D77-B683-E18E2B3F5607}"/>
+                <a16:creationId xmlns:a16="http://schemas.microsoft.com/office/drawing/2014/main" id="{AB8E0F85-09EE-45F4-A51D-FEAEDFDDCA4C}"/>
               </a:ext>
             </a:extLst>
           </p:cNvPr>
@@ -5096,7 +5096,7 @@
           <p:cNvPr id="5" name="page">
             <a:extLst xmlns:a="http://schemas.openxmlformats.org/drawingml/2006/main">
               <a:ext uri="{FF2B5EF4-FFF2-40B4-BE49-F238E27FC236}">
-                <a16:creationId xmlns:a16="http://schemas.microsoft.com/office/drawing/2014/main" id="{715A2934-06FE-4139-9379-6D07E0B3499F}"/>
+                <a16:creationId xmlns:a16="http://schemas.microsoft.com/office/drawing/2014/main" id="{58D41FF9-9F22-4844-85F8-42E509F7C694}"/>
               </a:ext>
             </a:extLst>
           </p:cNvPr>
@@ -5160,7 +5160,7 @@
     </p:spTree>
     <p:extLst>
       <p:ext uri="{BB962C8B-B14F-4D97-AF65-F5344CB8AC3E}">
-        <p14:creationId xmlns:p14="http://schemas.microsoft.com/office/powerpoint/2010/main" val="2104366027"/>
+        <p14:creationId xmlns:p14="http://schemas.microsoft.com/office/powerpoint/2010/main" val="1912771001"/>
       </p:ext>
     </p:extLst>
   </p:cSld>
@@ -5191,7 +5191,7 @@
           <p:cNvPr id="5" name="title">
             <a:extLst xmlns:a="http://schemas.openxmlformats.org/drawingml/2006/main">
               <a:ext uri="{FF2B5EF4-FFF2-40B4-BE49-F238E27FC236}">
-                <a16:creationId xmlns:a16="http://schemas.microsoft.com/office/drawing/2014/main" id="{D3D0AD85-987B-4072-8EA8-48939F60CA72}"/>
+                <a16:creationId xmlns:a16="http://schemas.microsoft.com/office/drawing/2014/main" id="{9B61C826-9CB5-4346-A5B7-CB9E64F35BC2}"/>
               </a:ext>
             </a:extLst>
           </p:cNvPr>
@@ -5257,7 +5257,7 @@
           <p:cNvPr id="2" name="">
             <a:extLst xmlns:a="http://schemas.openxmlformats.org/drawingml/2006/main">
               <a:ext uri="{FF2B5EF4-FFF2-40B4-BE49-F238E27FC236}">
-                <a16:creationId xmlns:a16="http://schemas.microsoft.com/office/drawing/2014/main" id="{50B41BB9-2717-427A-8B0B-4B56E0DA84C5}"/>
+                <a16:creationId xmlns:a16="http://schemas.microsoft.com/office/drawing/2014/main" id="{5343C74C-C98B-4701-BC1A-7841FD97B8A6}"/>
               </a:ext>
             </a:extLst>
           </p:cNvPr>
@@ -5585,7 +5585,7 @@
           <p:cNvPr id="3" name="disclosure">
             <a:extLst xmlns:a="http://schemas.openxmlformats.org/drawingml/2006/main">
               <a:ext uri="{FF2B5EF4-FFF2-40B4-BE49-F238E27FC236}">
-                <a16:creationId xmlns:a16="http://schemas.microsoft.com/office/drawing/2014/main" id="{70CD2C73-CC35-45B6-91B2-A5D2F669E597}"/>
+                <a16:creationId xmlns:a16="http://schemas.microsoft.com/office/drawing/2014/main" id="{8AC28157-4E82-4B3A-BE30-248CCC3142E6}"/>
               </a:ext>
             </a:extLst>
           </p:cNvPr>
@@ -5651,7 +5651,7 @@
           <p:cNvPr id="4" name="page">
             <a:extLst xmlns:a="http://schemas.openxmlformats.org/drawingml/2006/main">
               <a:ext uri="{FF2B5EF4-FFF2-40B4-BE49-F238E27FC236}">
-                <a16:creationId xmlns:a16="http://schemas.microsoft.com/office/drawing/2014/main" id="{50DFE4F4-48CC-40F6-9DBD-67EAFF091FFF}"/>
+                <a16:creationId xmlns:a16="http://schemas.microsoft.com/office/drawing/2014/main" id="{8BE26EC7-16E5-4BB8-8454-1F53A1415DAE}"/>
               </a:ext>
             </a:extLst>
           </p:cNvPr>
@@ -5715,7 +5715,7 @@
     </p:spTree>
     <p:extLst>
       <p:ext uri="{BB962C8B-B14F-4D97-AF65-F5344CB8AC3E}">
-        <p14:creationId xmlns:p14="http://schemas.microsoft.com/office/powerpoint/2010/main" val="97182778"/>
+        <p14:creationId xmlns:p14="http://schemas.microsoft.com/office/powerpoint/2010/main" val="2074769525"/>
       </p:ext>
     </p:extLst>
   </p:cSld>
@@ -5746,7 +5746,7 @@
           <p:cNvPr id="6" name="title">
             <a:extLst xmlns:a="http://schemas.openxmlformats.org/drawingml/2006/main">
               <a:ext uri="{FF2B5EF4-FFF2-40B4-BE49-F238E27FC236}">
-                <a16:creationId xmlns:a16="http://schemas.microsoft.com/office/drawing/2014/main" id="{AEA69242-4931-44EC-A41D-04DC1CE316CD}"/>
+                <a16:creationId xmlns:a16="http://schemas.microsoft.com/office/drawing/2014/main" id="{49C00C47-0962-4D0E-97C9-42AB9B2021FA}"/>
               </a:ext>
             </a:extLst>
           </p:cNvPr>
@@ -5812,7 +5812,7 @@
           <p:cNvPr id="2" name="paragraph-0">
             <a:extLst xmlns:a="http://schemas.openxmlformats.org/drawingml/2006/main">
               <a:ext uri="{FF2B5EF4-FFF2-40B4-BE49-F238E27FC236}">
-                <a16:creationId xmlns:a16="http://schemas.microsoft.com/office/drawing/2014/main" id="{4BB214DB-3E8C-4AF2-B3A5-AA458055A302}"/>
+                <a16:creationId xmlns:a16="http://schemas.microsoft.com/office/drawing/2014/main" id="{914C82BE-6BF3-4C8C-99C3-4A020F3BF3AB}"/>
               </a:ext>
             </a:extLst>
           </p:cNvPr>
@@ -5878,7 +5878,7 @@
           <p:cNvPr id="3" name="paragraph-1">
             <a:extLst xmlns:a="http://schemas.openxmlformats.org/drawingml/2006/main">
               <a:ext uri="{FF2B5EF4-FFF2-40B4-BE49-F238E27FC236}">
-                <a16:creationId xmlns:a16="http://schemas.microsoft.com/office/drawing/2014/main" id="{03A1EE5D-878E-4170-9CCB-746981A49E18}"/>
+                <a16:creationId xmlns:a16="http://schemas.microsoft.com/office/drawing/2014/main" id="{3503CAEA-DAA5-4070-B8DD-E2DD5FA419E0}"/>
               </a:ext>
             </a:extLst>
           </p:cNvPr>
@@ -5944,7 +5944,7 @@
           <p:cNvPr id="4" name="disclosure">
             <a:extLst xmlns:a="http://schemas.openxmlformats.org/drawingml/2006/main">
               <a:ext uri="{FF2B5EF4-FFF2-40B4-BE49-F238E27FC236}">
-                <a16:creationId xmlns:a16="http://schemas.microsoft.com/office/drawing/2014/main" id="{245B73F3-5697-491E-BBC8-AEEA3E41EC77}"/>
+                <a16:creationId xmlns:a16="http://schemas.microsoft.com/office/drawing/2014/main" id="{AC6A68AD-D91E-41DE-B06D-6DDF094DF0F4}"/>
               </a:ext>
             </a:extLst>
           </p:cNvPr>
@@ -6010,7 +6010,7 @@
           <p:cNvPr id="5" name="page">
             <a:extLst xmlns:a="http://schemas.openxmlformats.org/drawingml/2006/main">
               <a:ext uri="{FF2B5EF4-FFF2-40B4-BE49-F238E27FC236}">
-                <a16:creationId xmlns:a16="http://schemas.microsoft.com/office/drawing/2014/main" id="{E4E17B04-B8CC-4C6C-A256-3335CC85599C}"/>
+                <a16:creationId xmlns:a16="http://schemas.microsoft.com/office/drawing/2014/main" id="{E5DAA9AC-BD58-404F-8A9C-DF18C85F0069}"/>
               </a:ext>
             </a:extLst>
           </p:cNvPr>
@@ -6074,7 +6074,7 @@
     </p:spTree>
     <p:extLst>
       <p:ext uri="{BB962C8B-B14F-4D97-AF65-F5344CB8AC3E}">
-        <p14:creationId xmlns:p14="http://schemas.microsoft.com/office/powerpoint/2010/main" val="1345309008"/>
+        <p14:creationId xmlns:p14="http://schemas.microsoft.com/office/powerpoint/2010/main" val="96193816"/>
       </p:ext>
     </p:extLst>
   </p:cSld>
@@ -6105,7 +6105,7 @@
           <p:cNvPr id="6" name="title">
             <a:extLst xmlns:a="http://schemas.openxmlformats.org/drawingml/2006/main">
               <a:ext uri="{FF2B5EF4-FFF2-40B4-BE49-F238E27FC236}">
-                <a16:creationId xmlns:a16="http://schemas.microsoft.com/office/drawing/2014/main" id="{7134C97D-22A0-4D02-8712-3442AD77C28C}"/>
+                <a16:creationId xmlns:a16="http://schemas.microsoft.com/office/drawing/2014/main" id="{29F4E924-17EA-4DC3-ADAD-9799675D23A3}"/>
               </a:ext>
             </a:extLst>
           </p:cNvPr>
@@ -6171,7 +6171,7 @@
           <p:cNvPr id="2" name="paragraph-0">
             <a:extLst xmlns:a="http://schemas.openxmlformats.org/drawingml/2006/main">
               <a:ext uri="{FF2B5EF4-FFF2-40B4-BE49-F238E27FC236}">
-                <a16:creationId xmlns:a16="http://schemas.microsoft.com/office/drawing/2014/main" id="{FF309E6B-EBF2-49A4-B9EE-617D5ACE9FBE}"/>
+                <a16:creationId xmlns:a16="http://schemas.microsoft.com/office/drawing/2014/main" id="{2EA249A3-EBB6-40FD-9C0C-3C20E7597398}"/>
               </a:ext>
             </a:extLst>
           </p:cNvPr>
@@ -6237,7 +6237,7 @@
           <p:cNvPr id="3" name="paragraph-1">
             <a:extLst xmlns:a="http://schemas.openxmlformats.org/drawingml/2006/main">
               <a:ext uri="{FF2B5EF4-FFF2-40B4-BE49-F238E27FC236}">
-                <a16:creationId xmlns:a16="http://schemas.microsoft.com/office/drawing/2014/main" id="{22B44BCF-44BF-4846-B5F7-28196CD248C3}"/>
+                <a16:creationId xmlns:a16="http://schemas.microsoft.com/office/drawing/2014/main" id="{42141EA2-D5F2-4231-89A7-95CC020CEE85}"/>
               </a:ext>
             </a:extLst>
           </p:cNvPr>
@@ -6303,7 +6303,7 @@
           <p:cNvPr id="4" name="disclosure">
             <a:extLst xmlns:a="http://schemas.openxmlformats.org/drawingml/2006/main">
               <a:ext uri="{FF2B5EF4-FFF2-40B4-BE49-F238E27FC236}">
-                <a16:creationId xmlns:a16="http://schemas.microsoft.com/office/drawing/2014/main" id="{B0B1BB37-8CA4-4332-B228-9021B617A223}"/>
+                <a16:creationId xmlns:a16="http://schemas.microsoft.com/office/drawing/2014/main" id="{A3930BCC-99E9-4C7A-995F-5947CFB42F3D}"/>
               </a:ext>
             </a:extLst>
           </p:cNvPr>
@@ -6369,7 +6369,7 @@
           <p:cNvPr id="5" name="page">
             <a:extLst xmlns:a="http://schemas.openxmlformats.org/drawingml/2006/main">
               <a:ext uri="{FF2B5EF4-FFF2-40B4-BE49-F238E27FC236}">
-                <a16:creationId xmlns:a16="http://schemas.microsoft.com/office/drawing/2014/main" id="{650B0EAF-5181-47F5-A25C-608404688590}"/>
+                <a16:creationId xmlns:a16="http://schemas.microsoft.com/office/drawing/2014/main" id="{8A339ED0-DE92-42B9-897D-1C390EBCF4AD}"/>
               </a:ext>
             </a:extLst>
           </p:cNvPr>
@@ -6433,7 +6433,7 @@
     </p:spTree>
     <p:extLst>
       <p:ext uri="{BB962C8B-B14F-4D97-AF65-F5344CB8AC3E}">
-        <p14:creationId xmlns:p14="http://schemas.microsoft.com/office/powerpoint/2010/main" val="284676490"/>
+        <p14:creationId xmlns:p14="http://schemas.microsoft.com/office/powerpoint/2010/main" val="421444301"/>
       </p:ext>
     </p:extLst>
   </p:cSld>
@@ -6464,7 +6464,7 @@
           <p:cNvPr id="5" name="title">
             <a:extLst xmlns:a="http://schemas.openxmlformats.org/drawingml/2006/main">
               <a:ext uri="{FF2B5EF4-FFF2-40B4-BE49-F238E27FC236}">
-                <a16:creationId xmlns:a16="http://schemas.microsoft.com/office/drawing/2014/main" id="{156FD4F1-8C04-486D-9CB4-68D7611C1051}"/>
+                <a16:creationId xmlns:a16="http://schemas.microsoft.com/office/drawing/2014/main" id="{DA3BF1C7-74CB-484A-9B95-F907EF0CBB5C}"/>
               </a:ext>
             </a:extLst>
           </p:cNvPr>
@@ -6530,7 +6530,7 @@
           <p:cNvPr id="2" name="">
             <a:extLst xmlns:a="http://schemas.openxmlformats.org/drawingml/2006/main">
               <a:ext uri="{FF2B5EF4-FFF2-40B4-BE49-F238E27FC236}">
-                <a16:creationId xmlns:a16="http://schemas.microsoft.com/office/drawing/2014/main" id="{90AC534D-751E-41C1-B6CC-FD13DB7E7A10}"/>
+                <a16:creationId xmlns:a16="http://schemas.microsoft.com/office/drawing/2014/main" id="{95C59C16-AA15-4770-B490-A7EFD405D922}"/>
               </a:ext>
             </a:extLst>
           </p:cNvPr>
@@ -6808,7 +6808,7 @@
           <p:cNvPr id="3" name="disclosure">
             <a:extLst xmlns:a="http://schemas.openxmlformats.org/drawingml/2006/main">
               <a:ext uri="{FF2B5EF4-FFF2-40B4-BE49-F238E27FC236}">
-                <a16:creationId xmlns:a16="http://schemas.microsoft.com/office/drawing/2014/main" id="{3650834A-2E60-4352-B14D-3B5278FD3E89}"/>
+                <a16:creationId xmlns:a16="http://schemas.microsoft.com/office/drawing/2014/main" id="{12EF9DD4-5475-4693-9AE7-C72BFAED1F9C}"/>
               </a:ext>
             </a:extLst>
           </p:cNvPr>
@@ -6874,7 +6874,7 @@
           <p:cNvPr id="4" name="page">
             <a:extLst xmlns:a="http://schemas.openxmlformats.org/drawingml/2006/main">
               <a:ext uri="{FF2B5EF4-FFF2-40B4-BE49-F238E27FC236}">
-                <a16:creationId xmlns:a16="http://schemas.microsoft.com/office/drawing/2014/main" id="{8FB234FA-B8D7-42E6-BDE5-14138827B2D6}"/>
+                <a16:creationId xmlns:a16="http://schemas.microsoft.com/office/drawing/2014/main" id="{8A3E1965-8E1A-4E62-A39E-033F304A75F9}"/>
               </a:ext>
             </a:extLst>
           </p:cNvPr>
@@ -6938,7 +6938,7 @@
     </p:spTree>
     <p:extLst>
       <p:ext uri="{BB962C8B-B14F-4D97-AF65-F5344CB8AC3E}">
-        <p14:creationId xmlns:p14="http://schemas.microsoft.com/office/powerpoint/2010/main" val="440015541"/>
+        <p14:creationId xmlns:p14="http://schemas.microsoft.com/office/powerpoint/2010/main" val="1928748763"/>
       </p:ext>
     </p:extLst>
   </p:cSld>
@@ -6969,7 +6969,7 @@
           <p:cNvPr id="6" name="title">
             <a:extLst xmlns:a="http://schemas.openxmlformats.org/drawingml/2006/main">
               <a:ext uri="{FF2B5EF4-FFF2-40B4-BE49-F238E27FC236}">
-                <a16:creationId xmlns:a16="http://schemas.microsoft.com/office/drawing/2014/main" id="{A5C70F49-0279-40B3-91CC-7B5602A81DAC}"/>
+                <a16:creationId xmlns:a16="http://schemas.microsoft.com/office/drawing/2014/main" id="{B10C843F-AE93-473F-ABB8-D92A19EE0021}"/>
               </a:ext>
             </a:extLst>
           </p:cNvPr>
@@ -7035,7 +7035,7 @@
           <p:cNvPr id="2" name="paragraph-0">
             <a:extLst xmlns:a="http://schemas.openxmlformats.org/drawingml/2006/main">
               <a:ext uri="{FF2B5EF4-FFF2-40B4-BE49-F238E27FC236}">
-                <a16:creationId xmlns:a16="http://schemas.microsoft.com/office/drawing/2014/main" id="{D2130516-7206-428D-88F4-CCEEF2F0028E}"/>
+                <a16:creationId xmlns:a16="http://schemas.microsoft.com/office/drawing/2014/main" id="{C2DDB330-FAC7-4B12-8FFD-3E87E5926899}"/>
               </a:ext>
             </a:extLst>
           </p:cNvPr>
@@ -7101,7 +7101,7 @@
           <p:cNvPr id="3" name="paragraph-1">
             <a:extLst xmlns:a="http://schemas.openxmlformats.org/drawingml/2006/main">
               <a:ext uri="{FF2B5EF4-FFF2-40B4-BE49-F238E27FC236}">
-                <a16:creationId xmlns:a16="http://schemas.microsoft.com/office/drawing/2014/main" id="{F4ED54BA-6BB4-4217-9C0B-4446803644F6}"/>
+                <a16:creationId xmlns:a16="http://schemas.microsoft.com/office/drawing/2014/main" id="{BEF10A19-CE3D-4F9C-8760-EB122B969469}"/>
               </a:ext>
             </a:extLst>
           </p:cNvPr>
@@ -7167,7 +7167,7 @@
           <p:cNvPr id="4" name="disclosure">
             <a:extLst xmlns:a="http://schemas.openxmlformats.org/drawingml/2006/main">
               <a:ext uri="{FF2B5EF4-FFF2-40B4-BE49-F238E27FC236}">
-                <a16:creationId xmlns:a16="http://schemas.microsoft.com/office/drawing/2014/main" id="{0D0D9992-8FFD-40D5-B925-655FECE2C8CD}"/>
+                <a16:creationId xmlns:a16="http://schemas.microsoft.com/office/drawing/2014/main" id="{2732A04C-D7E6-4213-B300-551A928347C8}"/>
               </a:ext>
             </a:extLst>
           </p:cNvPr>
@@ -7233,7 +7233,7 @@
           <p:cNvPr id="5" name="page">
             <a:extLst xmlns:a="http://schemas.openxmlformats.org/drawingml/2006/main">
               <a:ext uri="{FF2B5EF4-FFF2-40B4-BE49-F238E27FC236}">
-                <a16:creationId xmlns:a16="http://schemas.microsoft.com/office/drawing/2014/main" id="{412008B7-28DC-4192-BBCA-59AF2607BA2F}"/>
+                <a16:creationId xmlns:a16="http://schemas.microsoft.com/office/drawing/2014/main" id="{DCFB79CE-6EAF-4D9B-849D-8275F960E821}"/>
               </a:ext>
             </a:extLst>
           </p:cNvPr>
@@ -7297,7 +7297,7 @@
     </p:spTree>
     <p:extLst>
       <p:ext uri="{BB962C8B-B14F-4D97-AF65-F5344CB8AC3E}">
-        <p14:creationId xmlns:p14="http://schemas.microsoft.com/office/powerpoint/2010/main" val="2139795177"/>
+        <p14:creationId xmlns:p14="http://schemas.microsoft.com/office/powerpoint/2010/main" val="1298993996"/>
       </p:ext>
     </p:extLst>
   </p:cSld>
@@ -7328,7 +7328,7 @@
           <p:cNvPr id="5" name="title">
             <a:extLst xmlns:a="http://schemas.openxmlformats.org/drawingml/2006/main">
               <a:ext uri="{FF2B5EF4-FFF2-40B4-BE49-F238E27FC236}">
-                <a16:creationId xmlns:a16="http://schemas.microsoft.com/office/drawing/2014/main" id="{126E473A-37E3-41B8-8DBC-3DDACAAC2C15}"/>
+                <a16:creationId xmlns:a16="http://schemas.microsoft.com/office/drawing/2014/main" id="{A58F8667-4131-43EB-BFD3-B40E0502AEF5}"/>
               </a:ext>
             </a:extLst>
           </p:cNvPr>
@@ -7394,7 +7394,7 @@
           <p:cNvPr id="2" name="">
             <a:extLst xmlns:a="http://schemas.openxmlformats.org/drawingml/2006/main">
               <a:ext uri="{FF2B5EF4-FFF2-40B4-BE49-F238E27FC236}">
-                <a16:creationId xmlns:a16="http://schemas.microsoft.com/office/drawing/2014/main" id="{CEFD148A-39EE-45B3-A367-AE878C694BE0}"/>
+                <a16:creationId xmlns:a16="http://schemas.microsoft.com/office/drawing/2014/main" id="{2E99A7AF-7BD4-43A7-A6EC-05D3251624F8}"/>
               </a:ext>
             </a:extLst>
           </p:cNvPr>
@@ -7722,7 +7722,7 @@
           <p:cNvPr id="3" name="disclosure">
             <a:extLst xmlns:a="http://schemas.openxmlformats.org/drawingml/2006/main">
               <a:ext uri="{FF2B5EF4-FFF2-40B4-BE49-F238E27FC236}">
-                <a16:creationId xmlns:a16="http://schemas.microsoft.com/office/drawing/2014/main" id="{133BF00D-D619-45AA-82EA-F827D44EB9CD}"/>
+                <a16:creationId xmlns:a16="http://schemas.microsoft.com/office/drawing/2014/main" id="{AABB7608-B6EC-4650-960E-366D8D4F9AA5}"/>
               </a:ext>
             </a:extLst>
           </p:cNvPr>
@@ -7788,7 +7788,7 @@
           <p:cNvPr id="4" name="page">
             <a:extLst xmlns:a="http://schemas.openxmlformats.org/drawingml/2006/main">
               <a:ext uri="{FF2B5EF4-FFF2-40B4-BE49-F238E27FC236}">
-                <a16:creationId xmlns:a16="http://schemas.microsoft.com/office/drawing/2014/main" id="{BB519C63-3A09-4102-AFEC-DFDC61B15714}"/>
+                <a16:creationId xmlns:a16="http://schemas.microsoft.com/office/drawing/2014/main" id="{9E8A2E90-726B-4578-91FF-008B94D0B726}"/>
               </a:ext>
             </a:extLst>
           </p:cNvPr>
@@ -7852,7 +7852,7 @@
     </p:spTree>
     <p:extLst>
       <p:ext uri="{BB962C8B-B14F-4D97-AF65-F5344CB8AC3E}">
-        <p14:creationId xmlns:p14="http://schemas.microsoft.com/office/powerpoint/2010/main" val="65664972"/>
+        <p14:creationId xmlns:p14="http://schemas.microsoft.com/office/powerpoint/2010/main" val="865125911"/>
       </p:ext>
     </p:extLst>
   </p:cSld>
@@ -7883,7 +7883,7 @@
           <p:cNvPr id="6" name="title">
             <a:extLst xmlns:a="http://schemas.openxmlformats.org/drawingml/2006/main">
               <a:ext uri="{FF2B5EF4-FFF2-40B4-BE49-F238E27FC236}">
-                <a16:creationId xmlns:a16="http://schemas.microsoft.com/office/drawing/2014/main" id="{F5F82F52-2169-427E-9072-90F52FD155BF}"/>
+                <a16:creationId xmlns:a16="http://schemas.microsoft.com/office/drawing/2014/main" id="{B0F5FF6C-658F-4E33-BE5E-767892F62B4B}"/>
               </a:ext>
             </a:extLst>
           </p:cNvPr>
@@ -7949,7 +7949,7 @@
           <p:cNvPr id="2" name="paragraph-0">
             <a:extLst xmlns:a="http://schemas.openxmlformats.org/drawingml/2006/main">
               <a:ext uri="{FF2B5EF4-FFF2-40B4-BE49-F238E27FC236}">
-                <a16:creationId xmlns:a16="http://schemas.microsoft.com/office/drawing/2014/main" id="{5F77C514-A8C6-4C1D-8EF5-B2109B1B5625}"/>
+                <a16:creationId xmlns:a16="http://schemas.microsoft.com/office/drawing/2014/main" id="{594F7785-0DE3-4262-B139-11CF02347A68}"/>
               </a:ext>
             </a:extLst>
           </p:cNvPr>
@@ -8015,7 +8015,7 @@
           <p:cNvPr id="3" name="paragraph-1">
             <a:extLst xmlns:a="http://schemas.openxmlformats.org/drawingml/2006/main">
               <a:ext uri="{FF2B5EF4-FFF2-40B4-BE49-F238E27FC236}">
-                <a16:creationId xmlns:a16="http://schemas.microsoft.com/office/drawing/2014/main" id="{1D3C83BD-A46D-4F4B-A0DE-831BE352D493}"/>
+                <a16:creationId xmlns:a16="http://schemas.microsoft.com/office/drawing/2014/main" id="{7C87B84B-EA9C-40CA-9788-81B0D35FAA02}"/>
               </a:ext>
             </a:extLst>
           </p:cNvPr>
@@ -8081,7 +8081,7 @@
           <p:cNvPr id="4" name="disclosure">
             <a:extLst xmlns:a="http://schemas.openxmlformats.org/drawingml/2006/main">
               <a:ext uri="{FF2B5EF4-FFF2-40B4-BE49-F238E27FC236}">
-                <a16:creationId xmlns:a16="http://schemas.microsoft.com/office/drawing/2014/main" id="{E3235BAE-2871-4EFD-A1AA-E1035BC07ED0}"/>
+                <a16:creationId xmlns:a16="http://schemas.microsoft.com/office/drawing/2014/main" id="{FFDE583E-5EE3-4F11-9337-94CFC981BF6B}"/>
               </a:ext>
             </a:extLst>
           </p:cNvPr>
@@ -8147,7 +8147,7 @@
           <p:cNvPr id="5" name="page">
             <a:extLst xmlns:a="http://schemas.openxmlformats.org/drawingml/2006/main">
               <a:ext uri="{FF2B5EF4-FFF2-40B4-BE49-F238E27FC236}">
-                <a16:creationId xmlns:a16="http://schemas.microsoft.com/office/drawing/2014/main" id="{B80A448F-DDD8-405A-9E9F-502DA3D2A5FC}"/>
+                <a16:creationId xmlns:a16="http://schemas.microsoft.com/office/drawing/2014/main" id="{696DF8CA-B1ED-46FC-BABE-740DF424539C}"/>
               </a:ext>
             </a:extLst>
           </p:cNvPr>
@@ -8211,7 +8211,7 @@
     </p:spTree>
     <p:extLst>
       <p:ext uri="{BB962C8B-B14F-4D97-AF65-F5344CB8AC3E}">
-        <p14:creationId xmlns:p14="http://schemas.microsoft.com/office/powerpoint/2010/main" val="352816594"/>
+        <p14:creationId xmlns:p14="http://schemas.microsoft.com/office/powerpoint/2010/main" val="492604871"/>
       </p:ext>
     </p:extLst>
   </p:cSld>
@@ -8242,7 +8242,7 @@
           <p:cNvPr id="7" name="title">
             <a:extLst xmlns:a="http://schemas.openxmlformats.org/drawingml/2006/main">
               <a:ext uri="{FF2B5EF4-FFF2-40B4-BE49-F238E27FC236}">
-                <a16:creationId xmlns:a16="http://schemas.microsoft.com/office/drawing/2014/main" id="{469B8F9C-7067-42B0-9506-57124B52DBB9}"/>
+                <a16:creationId xmlns:a16="http://schemas.microsoft.com/office/drawing/2014/main" id="{900897DF-C0E7-4BB2-9611-9DB6B5B91B63}"/>
               </a:ext>
             </a:extLst>
           </p:cNvPr>
@@ -8308,7 +8308,7 @@
           <p:cNvPr id="2" name="paragraph-0">
             <a:extLst xmlns:a="http://schemas.openxmlformats.org/drawingml/2006/main">
               <a:ext uri="{FF2B5EF4-FFF2-40B4-BE49-F238E27FC236}">
-                <a16:creationId xmlns:a16="http://schemas.microsoft.com/office/drawing/2014/main" id="{AC0B0219-EAE4-4374-AD01-62243D7C1F49}"/>
+                <a16:creationId xmlns:a16="http://schemas.microsoft.com/office/drawing/2014/main" id="{7403DA04-C869-40CE-ACDC-EDB5B1554F91}"/>
               </a:ext>
             </a:extLst>
           </p:cNvPr>
@@ -8374,7 +8374,7 @@
           <p:cNvPr id="3" name="paragraph-1">
             <a:extLst xmlns:a="http://schemas.openxmlformats.org/drawingml/2006/main">
               <a:ext uri="{FF2B5EF4-FFF2-40B4-BE49-F238E27FC236}">
-                <a16:creationId xmlns:a16="http://schemas.microsoft.com/office/drawing/2014/main" id="{4DE7EB3A-166C-4115-B298-1B58CFF86A3A}"/>
+                <a16:creationId xmlns:a16="http://schemas.microsoft.com/office/drawing/2014/main" id="{6CB47771-8C20-48D2-8041-9C4E863A91BC}"/>
               </a:ext>
             </a:extLst>
           </p:cNvPr>
@@ -8440,7 +8440,7 @@
           <p:cNvPr id="4" name="paragraph-2">
             <a:extLst xmlns:a="http://schemas.openxmlformats.org/drawingml/2006/main">
               <a:ext uri="{FF2B5EF4-FFF2-40B4-BE49-F238E27FC236}">
-                <a16:creationId xmlns:a16="http://schemas.microsoft.com/office/drawing/2014/main" id="{B6638645-0B0E-4780-8FD2-84CBDAD15661}"/>
+                <a16:creationId xmlns:a16="http://schemas.microsoft.com/office/drawing/2014/main" id="{A9A31F17-54B5-4E3E-BBEC-C16BB63BC6CB}"/>
               </a:ext>
             </a:extLst>
           </p:cNvPr>
@@ -8506,7 +8506,7 @@
           <p:cNvPr id="5" name="disclosure">
             <a:extLst xmlns:a="http://schemas.openxmlformats.org/drawingml/2006/main">
               <a:ext uri="{FF2B5EF4-FFF2-40B4-BE49-F238E27FC236}">
-                <a16:creationId xmlns:a16="http://schemas.microsoft.com/office/drawing/2014/main" id="{8C96A5FB-9B80-408A-AD75-4AE8216E5C4D}"/>
+                <a16:creationId xmlns:a16="http://schemas.microsoft.com/office/drawing/2014/main" id="{8C3F7545-1DAE-486B-94B6-86A3905CC3D8}"/>
               </a:ext>
             </a:extLst>
           </p:cNvPr>
@@ -8572,7 +8572,7 @@
           <p:cNvPr id="6" name="page">
             <a:extLst xmlns:a="http://schemas.openxmlformats.org/drawingml/2006/main">
               <a:ext uri="{FF2B5EF4-FFF2-40B4-BE49-F238E27FC236}">
-                <a16:creationId xmlns:a16="http://schemas.microsoft.com/office/drawing/2014/main" id="{3DB48AC5-B95A-47F7-9358-5D6A29E2684B}"/>
+                <a16:creationId xmlns:a16="http://schemas.microsoft.com/office/drawing/2014/main" id="{7B57F6AB-2121-4275-86F1-9BC2C0B09CF2}"/>
               </a:ext>
             </a:extLst>
           </p:cNvPr>
@@ -8636,7 +8636,7 @@
     </p:spTree>
     <p:extLst>
       <p:ext uri="{BB962C8B-B14F-4D97-AF65-F5344CB8AC3E}">
-        <p14:creationId xmlns:p14="http://schemas.microsoft.com/office/powerpoint/2010/main" val="897400902"/>
+        <p14:creationId xmlns:p14="http://schemas.microsoft.com/office/powerpoint/2010/main" val="868135226"/>
       </p:ext>
     </p:extLst>
   </p:cSld>
@@ -8667,7 +8667,7 @@
           <p:cNvPr id="5" name="title">
             <a:extLst xmlns:a="http://schemas.openxmlformats.org/drawingml/2006/main">
               <a:ext uri="{FF2B5EF4-FFF2-40B4-BE49-F238E27FC236}">
-                <a16:creationId xmlns:a16="http://schemas.microsoft.com/office/drawing/2014/main" id="{669A7DC1-B5A0-4D49-B582-75D064C837BA}"/>
+                <a16:creationId xmlns:a16="http://schemas.microsoft.com/office/drawing/2014/main" id="{F9627987-531D-421C-A177-4005D744A731}"/>
               </a:ext>
             </a:extLst>
           </p:cNvPr>
@@ -8733,7 +8733,7 @@
           <p:cNvPr id="2" name="">
             <a:extLst xmlns:a="http://schemas.openxmlformats.org/drawingml/2006/main">
               <a:ext uri="{FF2B5EF4-FFF2-40B4-BE49-F238E27FC236}">
-                <a16:creationId xmlns:a16="http://schemas.microsoft.com/office/drawing/2014/main" id="{427EF926-52C0-4BB5-8965-B13C1AC8C822}"/>
+                <a16:creationId xmlns:a16="http://schemas.microsoft.com/office/drawing/2014/main" id="{D025CB52-CF56-43DA-8AE9-8C81E951AD19}"/>
               </a:ext>
             </a:extLst>
           </p:cNvPr>
@@ -9061,7 +9061,7 @@
           <p:cNvPr id="3" name="disclosure">
             <a:extLst xmlns:a="http://schemas.openxmlformats.org/drawingml/2006/main">
               <a:ext uri="{FF2B5EF4-FFF2-40B4-BE49-F238E27FC236}">
-                <a16:creationId xmlns:a16="http://schemas.microsoft.com/office/drawing/2014/main" id="{5480C5BE-9FD3-4122-805D-6624A9B7D46B}"/>
+                <a16:creationId xmlns:a16="http://schemas.microsoft.com/office/drawing/2014/main" id="{F50CCBA7-B519-4545-B7F8-DBAE3FA27B1C}"/>
               </a:ext>
             </a:extLst>
           </p:cNvPr>
@@ -9127,7 +9127,7 @@
           <p:cNvPr id="4" name="page">
             <a:extLst xmlns:a="http://schemas.openxmlformats.org/drawingml/2006/main">
               <a:ext uri="{FF2B5EF4-FFF2-40B4-BE49-F238E27FC236}">
-                <a16:creationId xmlns:a16="http://schemas.microsoft.com/office/drawing/2014/main" id="{0F9E9882-718E-4F98-9D94-D17CE7BEE967}"/>
+                <a16:creationId xmlns:a16="http://schemas.microsoft.com/office/drawing/2014/main" id="{410E11F3-4D41-4F62-A20F-6CFD20C963F6}"/>
               </a:ext>
             </a:extLst>
           </p:cNvPr>
@@ -9191,7 +9191,7 @@
     </p:spTree>
     <p:extLst>
       <p:ext uri="{BB962C8B-B14F-4D97-AF65-F5344CB8AC3E}">
-        <p14:creationId xmlns:p14="http://schemas.microsoft.com/office/powerpoint/2010/main" val="19090557"/>
+        <p14:creationId xmlns:p14="http://schemas.microsoft.com/office/powerpoint/2010/main" val="1867979891"/>
       </p:ext>
     </p:extLst>
   </p:cSld>
@@ -9222,7 +9222,7 @@
           <p:cNvPr id="6" name="title">
             <a:extLst xmlns:a="http://schemas.openxmlformats.org/drawingml/2006/main">
               <a:ext uri="{FF2B5EF4-FFF2-40B4-BE49-F238E27FC236}">
-                <a16:creationId xmlns:a16="http://schemas.microsoft.com/office/drawing/2014/main" id="{7FD54F32-A00D-4584-A1E9-DCBFD8BB2A83}"/>
+                <a16:creationId xmlns:a16="http://schemas.microsoft.com/office/drawing/2014/main" id="{5C051568-C577-40CC-9294-88983617A038}"/>
               </a:ext>
             </a:extLst>
           </p:cNvPr>
@@ -9288,7 +9288,7 @@
           <p:cNvPr id="2" name="paragraph-0">
             <a:extLst xmlns:a="http://schemas.openxmlformats.org/drawingml/2006/main">
               <a:ext uri="{FF2B5EF4-FFF2-40B4-BE49-F238E27FC236}">
-                <a16:creationId xmlns:a16="http://schemas.microsoft.com/office/drawing/2014/main" id="{AB4366F3-1342-4E52-B256-D8E74F181706}"/>
+                <a16:creationId xmlns:a16="http://schemas.microsoft.com/office/drawing/2014/main" id="{3C1BFE94-B9D1-48FD-9509-CACABDDDF94A}"/>
               </a:ext>
             </a:extLst>
           </p:cNvPr>
@@ -9354,7 +9354,7 @@
           <p:cNvPr id="3" name="paragraph-1">
             <a:extLst xmlns:a="http://schemas.openxmlformats.org/drawingml/2006/main">
               <a:ext uri="{FF2B5EF4-FFF2-40B4-BE49-F238E27FC236}">
-                <a16:creationId xmlns:a16="http://schemas.microsoft.com/office/drawing/2014/main" id="{67A8F810-5E09-419F-8AEB-21C681C08B79}"/>
+                <a16:creationId xmlns:a16="http://schemas.microsoft.com/office/drawing/2014/main" id="{04A191F2-10EC-443E-953E-E83C6A9A37F3}"/>
               </a:ext>
             </a:extLst>
           </p:cNvPr>
@@ -9420,7 +9420,7 @@
           <p:cNvPr id="4" name="disclosure">
             <a:extLst xmlns:a="http://schemas.openxmlformats.org/drawingml/2006/main">
               <a:ext uri="{FF2B5EF4-FFF2-40B4-BE49-F238E27FC236}">
-                <a16:creationId xmlns:a16="http://schemas.microsoft.com/office/drawing/2014/main" id="{F6B7288F-FEAF-407A-8403-20C39CBA354F}"/>
+                <a16:creationId xmlns:a16="http://schemas.microsoft.com/office/drawing/2014/main" id="{13AE2923-79E1-409A-928B-1CCED60C01F0}"/>
               </a:ext>
             </a:extLst>
           </p:cNvPr>
@@ -9486,7 +9486,7 @@
           <p:cNvPr id="5" name="page">
             <a:extLst xmlns:a="http://schemas.openxmlformats.org/drawingml/2006/main">
               <a:ext uri="{FF2B5EF4-FFF2-40B4-BE49-F238E27FC236}">
-                <a16:creationId xmlns:a16="http://schemas.microsoft.com/office/drawing/2014/main" id="{69F0B6BD-33EF-45AB-89CA-555E1102DC96}"/>
+                <a16:creationId xmlns:a16="http://schemas.microsoft.com/office/drawing/2014/main" id="{0EB5D30B-BA05-41A5-BCC2-F21C19F3E90A}"/>
               </a:ext>
             </a:extLst>
           </p:cNvPr>
@@ -9550,7 +9550,7 @@
     </p:spTree>
     <p:extLst>
       <p:ext uri="{BB962C8B-B14F-4D97-AF65-F5344CB8AC3E}">
-        <p14:creationId xmlns:p14="http://schemas.microsoft.com/office/powerpoint/2010/main" val="2019981909"/>
+        <p14:creationId xmlns:p14="http://schemas.microsoft.com/office/powerpoint/2010/main" val="2104267900"/>
       </p:ext>
     </p:extLst>
   </p:cSld>
@@ -9581,7 +9581,7 @@
           <p:cNvPr id="6" name="title">
             <a:extLst xmlns:a="http://schemas.openxmlformats.org/drawingml/2006/main">
               <a:ext uri="{FF2B5EF4-FFF2-40B4-BE49-F238E27FC236}">
-                <a16:creationId xmlns:a16="http://schemas.microsoft.com/office/drawing/2014/main" id="{579E38E3-A108-45B8-A035-83A602E1B9BC}"/>
+                <a16:creationId xmlns:a16="http://schemas.microsoft.com/office/drawing/2014/main" id="{EF2141E8-7163-447B-B612-5A913614E114}"/>
               </a:ext>
             </a:extLst>
           </p:cNvPr>
@@ -9647,7 +9647,7 @@
           <p:cNvPr id="2" name="paragraph-0">
             <a:extLst xmlns:a="http://schemas.openxmlformats.org/drawingml/2006/main">
               <a:ext uri="{FF2B5EF4-FFF2-40B4-BE49-F238E27FC236}">
-                <a16:creationId xmlns:a16="http://schemas.microsoft.com/office/drawing/2014/main" id="{1568C293-A407-4AD1-A2BC-23CA9125CF7B}"/>
+                <a16:creationId xmlns:a16="http://schemas.microsoft.com/office/drawing/2014/main" id="{42182328-A21C-4B4F-BFD6-BC5384DD7A07}"/>
               </a:ext>
             </a:extLst>
           </p:cNvPr>
@@ -9713,7 +9713,7 @@
           <p:cNvPr id="3" name="paragraph-1">
             <a:extLst xmlns:a="http://schemas.openxmlformats.org/drawingml/2006/main">
               <a:ext uri="{FF2B5EF4-FFF2-40B4-BE49-F238E27FC236}">
-                <a16:creationId xmlns:a16="http://schemas.microsoft.com/office/drawing/2014/main" id="{993D1FB9-E7B7-466D-B5AF-B03C50E4C348}"/>
+                <a16:creationId xmlns:a16="http://schemas.microsoft.com/office/drawing/2014/main" id="{7E14474F-74B0-4FEF-97C7-FB8C1DC96A8B}"/>
               </a:ext>
             </a:extLst>
           </p:cNvPr>
@@ -9779,7 +9779,7 @@
           <p:cNvPr id="4" name="disclosure">
             <a:extLst xmlns:a="http://schemas.openxmlformats.org/drawingml/2006/main">
               <a:ext uri="{FF2B5EF4-FFF2-40B4-BE49-F238E27FC236}">
-                <a16:creationId xmlns:a16="http://schemas.microsoft.com/office/drawing/2014/main" id="{217398C3-F60E-4E74-89A1-8EFD9A8F227C}"/>
+                <a16:creationId xmlns:a16="http://schemas.microsoft.com/office/drawing/2014/main" id="{F0BB4B32-00B8-4CCC-AC16-B4F70BE3E45D}"/>
               </a:ext>
             </a:extLst>
           </p:cNvPr>
@@ -9845,7 +9845,7 @@
           <p:cNvPr id="5" name="page">
             <a:extLst xmlns:a="http://schemas.openxmlformats.org/drawingml/2006/main">
               <a:ext uri="{FF2B5EF4-FFF2-40B4-BE49-F238E27FC236}">
-                <a16:creationId xmlns:a16="http://schemas.microsoft.com/office/drawing/2014/main" id="{673B7D84-9AC0-4756-82A4-38402C9A7D17}"/>
+                <a16:creationId xmlns:a16="http://schemas.microsoft.com/office/drawing/2014/main" id="{EAB70EF7-6F90-4D72-BFC2-B3AEE65E7268}"/>
               </a:ext>
             </a:extLst>
           </p:cNvPr>
@@ -9909,7 +9909,7 @@
     </p:spTree>
     <p:extLst>
       <p:ext uri="{BB962C8B-B14F-4D97-AF65-F5344CB8AC3E}">
-        <p14:creationId xmlns:p14="http://schemas.microsoft.com/office/powerpoint/2010/main" val="159262944"/>
+        <p14:creationId xmlns:p14="http://schemas.microsoft.com/office/powerpoint/2010/main" val="967767638"/>
       </p:ext>
     </p:extLst>
   </p:cSld>
@@ -9940,7 +9940,7 @@
           <p:cNvPr id="6" name="title">
             <a:extLst xmlns:a="http://schemas.openxmlformats.org/drawingml/2006/main">
               <a:ext uri="{FF2B5EF4-FFF2-40B4-BE49-F238E27FC236}">
-                <a16:creationId xmlns:a16="http://schemas.microsoft.com/office/drawing/2014/main" id="{F9A432E4-40E6-43BF-9D18-D9F4148573A3}"/>
+                <a16:creationId xmlns:a16="http://schemas.microsoft.com/office/drawing/2014/main" id="{64D1DA3A-B01C-4660-9376-6C9A3A09585F}"/>
               </a:ext>
             </a:extLst>
           </p:cNvPr>
@@ -10006,7 +10006,7 @@
           <p:cNvPr id="2" name="paragraph-0">
             <a:extLst xmlns:a="http://schemas.openxmlformats.org/drawingml/2006/main">
               <a:ext uri="{FF2B5EF4-FFF2-40B4-BE49-F238E27FC236}">
-                <a16:creationId xmlns:a16="http://schemas.microsoft.com/office/drawing/2014/main" id="{955418C7-BE98-42B1-A0F2-C0D4D9698B40}"/>
+                <a16:creationId xmlns:a16="http://schemas.microsoft.com/office/drawing/2014/main" id="{2D75815E-9039-4B1F-B78B-2FD4F3A40F7A}"/>
               </a:ext>
             </a:extLst>
           </p:cNvPr>
@@ -10072,7 +10072,7 @@
           <p:cNvPr id="3" name="paragraph-1">
             <a:extLst xmlns:a="http://schemas.openxmlformats.org/drawingml/2006/main">
               <a:ext uri="{FF2B5EF4-FFF2-40B4-BE49-F238E27FC236}">
-                <a16:creationId xmlns:a16="http://schemas.microsoft.com/office/drawing/2014/main" id="{5A05D914-AD5D-4CFE-AA65-6093919A5849}"/>
+                <a16:creationId xmlns:a16="http://schemas.microsoft.com/office/drawing/2014/main" id="{10A5D74E-D45D-480F-B1AF-AF8076574FCA}"/>
               </a:ext>
             </a:extLst>
           </p:cNvPr>
@@ -10138,7 +10138,7 @@
           <p:cNvPr id="4" name="disclosure">
             <a:extLst xmlns:a="http://schemas.openxmlformats.org/drawingml/2006/main">
               <a:ext uri="{FF2B5EF4-FFF2-40B4-BE49-F238E27FC236}">
-                <a16:creationId xmlns:a16="http://schemas.microsoft.com/office/drawing/2014/main" id="{D5560295-CCC0-410A-9279-40A1A0943729}"/>
+                <a16:creationId xmlns:a16="http://schemas.microsoft.com/office/drawing/2014/main" id="{E9E6902B-F6FE-4662-B1B2-DACAD8A17D92}"/>
               </a:ext>
             </a:extLst>
           </p:cNvPr>
@@ -10204,7 +10204,7 @@
           <p:cNvPr id="5" name="page">
             <a:extLst xmlns:a="http://schemas.openxmlformats.org/drawingml/2006/main">
               <a:ext uri="{FF2B5EF4-FFF2-40B4-BE49-F238E27FC236}">
-                <a16:creationId xmlns:a16="http://schemas.microsoft.com/office/drawing/2014/main" id="{F3E9731A-A04D-4C3F-8F78-CB2DE20ECB33}"/>
+                <a16:creationId xmlns:a16="http://schemas.microsoft.com/office/drawing/2014/main" id="{6234D84C-8DCB-4F11-B795-20CA2C0886DC}"/>
               </a:ext>
             </a:extLst>
           </p:cNvPr>
@@ -10268,7 +10268,7 @@
     </p:spTree>
     <p:extLst>
       <p:ext uri="{BB962C8B-B14F-4D97-AF65-F5344CB8AC3E}">
-        <p14:creationId xmlns:p14="http://schemas.microsoft.com/office/powerpoint/2010/main" val="2130989574"/>
+        <p14:creationId xmlns:p14="http://schemas.microsoft.com/office/powerpoint/2010/main" val="402397853"/>
       </p:ext>
     </p:extLst>
   </p:cSld>
@@ -10299,7 +10299,7 @@
           <p:cNvPr id="6" name="title">
             <a:extLst xmlns:a="http://schemas.openxmlformats.org/drawingml/2006/main">
               <a:ext uri="{FF2B5EF4-FFF2-40B4-BE49-F238E27FC236}">
-                <a16:creationId xmlns:a16="http://schemas.microsoft.com/office/drawing/2014/main" id="{CEAD0A74-B777-476E-8AAF-D8ECED1FA147}"/>
+                <a16:creationId xmlns:a16="http://schemas.microsoft.com/office/drawing/2014/main" id="{7803692B-CB12-4A44-8782-776A8FCCFBAF}"/>
               </a:ext>
             </a:extLst>
           </p:cNvPr>
@@ -10365,7 +10365,7 @@
           <p:cNvPr id="2" name="paragraph-0">
             <a:extLst xmlns:a="http://schemas.openxmlformats.org/drawingml/2006/main">
               <a:ext uri="{FF2B5EF4-FFF2-40B4-BE49-F238E27FC236}">
-                <a16:creationId xmlns:a16="http://schemas.microsoft.com/office/drawing/2014/main" id="{72ADD7FB-B8FC-4F90-9912-870E88323C27}"/>
+                <a16:creationId xmlns:a16="http://schemas.microsoft.com/office/drawing/2014/main" id="{FFD0F9A2-6859-4494-9656-9FCF8D930C84}"/>
               </a:ext>
             </a:extLst>
           </p:cNvPr>
@@ -10431,7 +10431,7 @@
           <p:cNvPr id="3" name="paragraph-1">
             <a:extLst xmlns:a="http://schemas.openxmlformats.org/drawingml/2006/main">
               <a:ext uri="{FF2B5EF4-FFF2-40B4-BE49-F238E27FC236}">
-                <a16:creationId xmlns:a16="http://schemas.microsoft.com/office/drawing/2014/main" id="{FBBA10A3-DAEE-4769-8965-56A09A4F7C4A}"/>
+                <a16:creationId xmlns:a16="http://schemas.microsoft.com/office/drawing/2014/main" id="{0C2F2BC6-AFD1-473C-B162-57A9AF68BF83}"/>
               </a:ext>
             </a:extLst>
           </p:cNvPr>
@@ -10497,7 +10497,7 @@
           <p:cNvPr id="4" name="disclosure">
             <a:extLst xmlns:a="http://schemas.openxmlformats.org/drawingml/2006/main">
               <a:ext uri="{FF2B5EF4-FFF2-40B4-BE49-F238E27FC236}">
-                <a16:creationId xmlns:a16="http://schemas.microsoft.com/office/drawing/2014/main" id="{2B187E89-56D3-41E4-A61E-0CA6C0B2620B}"/>
+                <a16:creationId xmlns:a16="http://schemas.microsoft.com/office/drawing/2014/main" id="{FDE0C100-CD68-4D2F-97B4-30EAF5AD887F}"/>
               </a:ext>
             </a:extLst>
           </p:cNvPr>
@@ -10563,7 +10563,7 @@
           <p:cNvPr id="5" name="page">
             <a:extLst xmlns:a="http://schemas.openxmlformats.org/drawingml/2006/main">
               <a:ext uri="{FF2B5EF4-FFF2-40B4-BE49-F238E27FC236}">
-                <a16:creationId xmlns:a16="http://schemas.microsoft.com/office/drawing/2014/main" id="{5020292B-5E8F-4C4F-8698-5E1ABC01E745}"/>
+                <a16:creationId xmlns:a16="http://schemas.microsoft.com/office/drawing/2014/main" id="{9B488156-5258-42C4-BAAA-1C6086CEEC97}"/>
               </a:ext>
             </a:extLst>
           </p:cNvPr>
@@ -10627,7 +10627,7 @@
     </p:spTree>
     <p:extLst>
       <p:ext uri="{BB962C8B-B14F-4D97-AF65-F5344CB8AC3E}">
-        <p14:creationId xmlns:p14="http://schemas.microsoft.com/office/powerpoint/2010/main" val="277333689"/>
+        <p14:creationId xmlns:p14="http://schemas.microsoft.com/office/powerpoint/2010/main" val="158332202"/>
       </p:ext>
     </p:extLst>
   </p:cSld>
@@ -10658,7 +10658,7 @@
           <p:cNvPr id="6" name="title">
             <a:extLst xmlns:a="http://schemas.openxmlformats.org/drawingml/2006/main">
               <a:ext uri="{FF2B5EF4-FFF2-40B4-BE49-F238E27FC236}">
-                <a16:creationId xmlns:a16="http://schemas.microsoft.com/office/drawing/2014/main" id="{A1795132-E447-49AE-813E-E046D0597186}"/>
+                <a16:creationId xmlns:a16="http://schemas.microsoft.com/office/drawing/2014/main" id="{6739CEBE-FEB7-4F9C-8516-3CA60971F7A8}"/>
               </a:ext>
             </a:extLst>
           </p:cNvPr>
@@ -10724,7 +10724,7 @@
           <p:cNvPr id="2" name="paragraph-0">
             <a:extLst xmlns:a="http://schemas.openxmlformats.org/drawingml/2006/main">
               <a:ext uri="{FF2B5EF4-FFF2-40B4-BE49-F238E27FC236}">
-                <a16:creationId xmlns:a16="http://schemas.microsoft.com/office/drawing/2014/main" id="{E393812D-F883-408E-B585-C52497DCD157}"/>
+                <a16:creationId xmlns:a16="http://schemas.microsoft.com/office/drawing/2014/main" id="{E17C1B41-4613-44C0-AA1D-16F1802BEAFC}"/>
               </a:ext>
             </a:extLst>
           </p:cNvPr>
@@ -10790,7 +10790,7 @@
           <p:cNvPr id="3" name="paragraph-1">
             <a:extLst xmlns:a="http://schemas.openxmlformats.org/drawingml/2006/main">
               <a:ext uri="{FF2B5EF4-FFF2-40B4-BE49-F238E27FC236}">
-                <a16:creationId xmlns:a16="http://schemas.microsoft.com/office/drawing/2014/main" id="{1A9871DA-76B3-498C-9893-042EFAA6A0D4}"/>
+                <a16:creationId xmlns:a16="http://schemas.microsoft.com/office/drawing/2014/main" id="{D116EBC7-6E33-4A7C-9FC2-8F81E5387BA5}"/>
               </a:ext>
             </a:extLst>
           </p:cNvPr>
@@ -10856,7 +10856,7 @@
           <p:cNvPr id="4" name="disclosure">
             <a:extLst xmlns:a="http://schemas.openxmlformats.org/drawingml/2006/main">
               <a:ext uri="{FF2B5EF4-FFF2-40B4-BE49-F238E27FC236}">
-                <a16:creationId xmlns:a16="http://schemas.microsoft.com/office/drawing/2014/main" id="{81F6E2DA-76E7-4B2F-9740-E5C8759621FF}"/>
+                <a16:creationId xmlns:a16="http://schemas.microsoft.com/office/drawing/2014/main" id="{4DDF73D3-3239-4AAA-826A-3BD57EDFEFC1}"/>
               </a:ext>
             </a:extLst>
           </p:cNvPr>
@@ -10922,7 +10922,7 @@
           <p:cNvPr id="5" name="page">
             <a:extLst xmlns:a="http://schemas.openxmlformats.org/drawingml/2006/main">
               <a:ext uri="{FF2B5EF4-FFF2-40B4-BE49-F238E27FC236}">
-                <a16:creationId xmlns:a16="http://schemas.microsoft.com/office/drawing/2014/main" id="{A4D0E81B-EBF1-4505-A83D-905BDFEF812C}"/>
+                <a16:creationId xmlns:a16="http://schemas.microsoft.com/office/drawing/2014/main" id="{00DF35E9-B97A-4E85-8F22-AFBA9EC8010C}"/>
               </a:ext>
             </a:extLst>
           </p:cNvPr>
@@ -10986,7 +10986,7 @@
     </p:spTree>
     <p:extLst>
       <p:ext uri="{BB962C8B-B14F-4D97-AF65-F5344CB8AC3E}">
-        <p14:creationId xmlns:p14="http://schemas.microsoft.com/office/powerpoint/2010/main" val="38109659"/>
+        <p14:creationId xmlns:p14="http://schemas.microsoft.com/office/powerpoint/2010/main" val="377406481"/>
       </p:ext>
     </p:extLst>
   </p:cSld>
@@ -11017,7 +11017,7 @@
           <p:cNvPr id="6" name="title">
             <a:extLst xmlns:a="http://schemas.openxmlformats.org/drawingml/2006/main">
               <a:ext uri="{FF2B5EF4-FFF2-40B4-BE49-F238E27FC236}">
-                <a16:creationId xmlns:a16="http://schemas.microsoft.com/office/drawing/2014/main" id="{AFDB65CC-1784-4D50-AA2F-838D24267FB0}"/>
+                <a16:creationId xmlns:a16="http://schemas.microsoft.com/office/drawing/2014/main" id="{7FF79744-3DAE-4EE9-B06D-B38C4209A98F}"/>
               </a:ext>
             </a:extLst>
           </p:cNvPr>
@@ -11083,7 +11083,7 @@
           <p:cNvPr id="2" name="paragraph-0">
             <a:extLst xmlns:a="http://schemas.openxmlformats.org/drawingml/2006/main">
               <a:ext uri="{FF2B5EF4-FFF2-40B4-BE49-F238E27FC236}">
-                <a16:creationId xmlns:a16="http://schemas.microsoft.com/office/drawing/2014/main" id="{9FE5F0DD-7DE0-4C28-80CC-50EB6827FA84}"/>
+                <a16:creationId xmlns:a16="http://schemas.microsoft.com/office/drawing/2014/main" id="{8A3EB54F-D8D8-460E-8289-28D3D426D488}"/>
               </a:ext>
             </a:extLst>
           </p:cNvPr>
@@ -11149,7 +11149,7 @@
           <p:cNvPr id="3" name="paragraph-1">
             <a:extLst xmlns:a="http://schemas.openxmlformats.org/drawingml/2006/main">
               <a:ext uri="{FF2B5EF4-FFF2-40B4-BE49-F238E27FC236}">
-                <a16:creationId xmlns:a16="http://schemas.microsoft.com/office/drawing/2014/main" id="{2EAA495C-596B-4664-9506-075A4F4FAEC6}"/>
+                <a16:creationId xmlns:a16="http://schemas.microsoft.com/office/drawing/2014/main" id="{4E66DD04-0EB5-46A5-B5CC-F9429D554CC8}"/>
               </a:ext>
             </a:extLst>
           </p:cNvPr>
@@ -11215,7 +11215,7 @@
           <p:cNvPr id="4" name="disclosure">
             <a:extLst xmlns:a="http://schemas.openxmlformats.org/drawingml/2006/main">
               <a:ext uri="{FF2B5EF4-FFF2-40B4-BE49-F238E27FC236}">
-                <a16:creationId xmlns:a16="http://schemas.microsoft.com/office/drawing/2014/main" id="{09E69907-75CB-49E1-AC26-C4164B72F5BD}"/>
+                <a16:creationId xmlns:a16="http://schemas.microsoft.com/office/drawing/2014/main" id="{FC1310BD-6168-4427-96B5-84A7C1DFBA62}"/>
               </a:ext>
             </a:extLst>
           </p:cNvPr>
@@ -11281,7 +11281,7 @@
           <p:cNvPr id="5" name="page">
             <a:extLst xmlns:a="http://schemas.openxmlformats.org/drawingml/2006/main">
               <a:ext uri="{FF2B5EF4-FFF2-40B4-BE49-F238E27FC236}">
-                <a16:creationId xmlns:a16="http://schemas.microsoft.com/office/drawing/2014/main" id="{E51F2FD3-B3AE-44CC-94E2-5E991F19F373}"/>
+                <a16:creationId xmlns:a16="http://schemas.microsoft.com/office/drawing/2014/main" id="{36B5E9D7-B39E-474C-B7E4-C6C776DFF1D5}"/>
               </a:ext>
             </a:extLst>
           </p:cNvPr>
@@ -11345,7 +11345,7 @@
     </p:spTree>
     <p:extLst>
       <p:ext uri="{BB962C8B-B14F-4D97-AF65-F5344CB8AC3E}">
-        <p14:creationId xmlns:p14="http://schemas.microsoft.com/office/powerpoint/2010/main" val="2130686679"/>
+        <p14:creationId xmlns:p14="http://schemas.microsoft.com/office/powerpoint/2010/main" val="498000133"/>
       </p:ext>
     </p:extLst>
   </p:cSld>
@@ -11376,7 +11376,7 @@
           <p:cNvPr id="6" name="title">
             <a:extLst xmlns:a="http://schemas.openxmlformats.org/drawingml/2006/main">
               <a:ext uri="{FF2B5EF4-FFF2-40B4-BE49-F238E27FC236}">
-                <a16:creationId xmlns:a16="http://schemas.microsoft.com/office/drawing/2014/main" id="{478A7DB1-46A5-4DF6-8B3C-5319D7775A74}"/>
+                <a16:creationId xmlns:a16="http://schemas.microsoft.com/office/drawing/2014/main" id="{5808B7F0-E13D-48B8-870A-8C62A73B60E9}"/>
               </a:ext>
             </a:extLst>
           </p:cNvPr>
@@ -11442,7 +11442,7 @@
           <p:cNvPr id="2" name="paragraph-0">
             <a:extLst xmlns:a="http://schemas.openxmlformats.org/drawingml/2006/main">
               <a:ext uri="{FF2B5EF4-FFF2-40B4-BE49-F238E27FC236}">
-                <a16:creationId xmlns:a16="http://schemas.microsoft.com/office/drawing/2014/main" id="{5A2CE6BA-9BF8-4A33-B361-E7CE19497646}"/>
+                <a16:creationId xmlns:a16="http://schemas.microsoft.com/office/drawing/2014/main" id="{1ABCE30F-50DB-4BA3-A047-1A2B60854A2C}"/>
               </a:ext>
             </a:extLst>
           </p:cNvPr>
@@ -11508,7 +11508,7 @@
           <p:cNvPr id="3" name="paragraph-1">
             <a:extLst xmlns:a="http://schemas.openxmlformats.org/drawingml/2006/main">
               <a:ext uri="{FF2B5EF4-FFF2-40B4-BE49-F238E27FC236}">
-                <a16:creationId xmlns:a16="http://schemas.microsoft.com/office/drawing/2014/main" id="{BCBE8FAA-B548-4B94-A208-1D8BE8D0D2FA}"/>
+                <a16:creationId xmlns:a16="http://schemas.microsoft.com/office/drawing/2014/main" id="{A25BA201-B2BC-4B1C-BEFF-2E7D68ED8A4F}"/>
               </a:ext>
             </a:extLst>
           </p:cNvPr>
@@ -11574,7 +11574,7 @@
           <p:cNvPr id="4" name="disclosure">
             <a:extLst xmlns:a="http://schemas.openxmlformats.org/drawingml/2006/main">
               <a:ext uri="{FF2B5EF4-FFF2-40B4-BE49-F238E27FC236}">
-                <a16:creationId xmlns:a16="http://schemas.microsoft.com/office/drawing/2014/main" id="{99E92BD5-1894-401F-B81F-A19E1F11C056}"/>
+                <a16:creationId xmlns:a16="http://schemas.microsoft.com/office/drawing/2014/main" id="{581AD79C-C1A5-43DB-AE08-B3644D75243F}"/>
               </a:ext>
             </a:extLst>
           </p:cNvPr>
@@ -11640,7 +11640,7 @@
           <p:cNvPr id="5" name="page">
             <a:extLst xmlns:a="http://schemas.openxmlformats.org/drawingml/2006/main">
               <a:ext uri="{FF2B5EF4-FFF2-40B4-BE49-F238E27FC236}">
-                <a16:creationId xmlns:a16="http://schemas.microsoft.com/office/drawing/2014/main" id="{8AFB401A-020E-49D2-8B59-E3F5AA0D85EC}"/>
+                <a16:creationId xmlns:a16="http://schemas.microsoft.com/office/drawing/2014/main" id="{2CB8E65F-A7E5-4EBE-A463-82102A102040}"/>
               </a:ext>
             </a:extLst>
           </p:cNvPr>
@@ -11704,7 +11704,7 @@
     </p:spTree>
     <p:extLst>
       <p:ext uri="{BB962C8B-B14F-4D97-AF65-F5344CB8AC3E}">
-        <p14:creationId xmlns:p14="http://schemas.microsoft.com/office/powerpoint/2010/main" val="1707423026"/>
+        <p14:creationId xmlns:p14="http://schemas.microsoft.com/office/powerpoint/2010/main" val="847386994"/>
       </p:ext>
     </p:extLst>
   </p:cSld>

</xml_diff>

<commit_message>
Rename GOV.UK Delegate to Delegate and remove Public Digital references (#138)
* Rename product to Delegate and remove audience branding

* Record branding asset and isolated journey verification
</commit_message>
<xml_diff>
--- a/apps/about/public/briefings/detailed.pptx
+++ b/apps/about/public/briefings/detailed.pptx
@@ -2,30 +2,30 @@
 <file path=ppt/presentation.xml><?xml version="1.0" encoding="utf-8"?>
 <p:presentation xmlns:p="http://schemas.openxmlformats.org/presentationml/2006/main">
   <p:sldMasterIdLst>
-    <p:sldMasterId xmlns:r="http://schemas.openxmlformats.org/officeDocument/2006/relationships" id="2147483648" r:id="R2fbd933120c54a40"/>
+    <p:sldMasterId xmlns:r="http://schemas.openxmlformats.org/officeDocument/2006/relationships" id="2147483648" r:id="Re944dc31679045c5"/>
   </p:sldMasterIdLst>
   <p:notesMasterIdLst>
-    <p:notesMasterId xmlns:r="http://schemas.openxmlformats.org/officeDocument/2006/relationships" r:id="Rbb85c8b4726d4917"/>
+    <p:notesMasterId xmlns:r="http://schemas.openxmlformats.org/officeDocument/2006/relationships" r:id="Rc58a2bb543b14c7f"/>
   </p:notesMasterIdLst>
   <p:sldIdLst>
-    <p:sldId xmlns:r="http://schemas.openxmlformats.org/officeDocument/2006/relationships" id="256" r:id="R2fe2fe2d0d9348e3"/>
-    <p:sldId xmlns:r="http://schemas.openxmlformats.org/officeDocument/2006/relationships" id="257" r:id="Re3c07f62792242e6"/>
-    <p:sldId xmlns:r="http://schemas.openxmlformats.org/officeDocument/2006/relationships" id="258" r:id="R314185154f48492e"/>
-    <p:sldId xmlns:r="http://schemas.openxmlformats.org/officeDocument/2006/relationships" id="259" r:id="R22a3937837f744d0"/>
-    <p:sldId xmlns:r="http://schemas.openxmlformats.org/officeDocument/2006/relationships" id="260" r:id="Rac0ce43c3fbf4371"/>
-    <p:sldId xmlns:r="http://schemas.openxmlformats.org/officeDocument/2006/relationships" id="261" r:id="Ra6c717994e30498a"/>
-    <p:sldId xmlns:r="http://schemas.openxmlformats.org/officeDocument/2006/relationships" id="262" r:id="Rf41f14c6c49a4298"/>
-    <p:sldId xmlns:r="http://schemas.openxmlformats.org/officeDocument/2006/relationships" id="263" r:id="Rcb4004ec12ce41b9"/>
-    <p:sldId xmlns:r="http://schemas.openxmlformats.org/officeDocument/2006/relationships" id="264" r:id="Ra7d06320f3ee455c"/>
-    <p:sldId xmlns:r="http://schemas.openxmlformats.org/officeDocument/2006/relationships" id="265" r:id="Rcda46ed262014f6d"/>
-    <p:sldId xmlns:r="http://schemas.openxmlformats.org/officeDocument/2006/relationships" id="266" r:id="R9595fe77782c46fd"/>
-    <p:sldId xmlns:r="http://schemas.openxmlformats.org/officeDocument/2006/relationships" id="267" r:id="Rb64b91ea0f8544d5"/>
-    <p:sldId xmlns:r="http://schemas.openxmlformats.org/officeDocument/2006/relationships" id="268" r:id="R2beab8e8e1e54d10"/>
-    <p:sldId xmlns:r="http://schemas.openxmlformats.org/officeDocument/2006/relationships" id="269" r:id="R985aeba2263f402d"/>
-    <p:sldId xmlns:r="http://schemas.openxmlformats.org/officeDocument/2006/relationships" id="270" r:id="R76a3ffebaacb4eab"/>
-    <p:sldId xmlns:r="http://schemas.openxmlformats.org/officeDocument/2006/relationships" id="271" r:id="R178e6bb83a2d4793"/>
-    <p:sldId xmlns:r="http://schemas.openxmlformats.org/officeDocument/2006/relationships" id="272" r:id="R85ac2e701dee463b"/>
-    <p:sldId xmlns:r="http://schemas.openxmlformats.org/officeDocument/2006/relationships" id="273" r:id="R8cd0c1944f294f7a"/>
+    <p:sldId xmlns:r="http://schemas.openxmlformats.org/officeDocument/2006/relationships" id="256" r:id="R6735a13901c44299"/>
+    <p:sldId xmlns:r="http://schemas.openxmlformats.org/officeDocument/2006/relationships" id="257" r:id="R9548e21b3ec54ad1"/>
+    <p:sldId xmlns:r="http://schemas.openxmlformats.org/officeDocument/2006/relationships" id="258" r:id="R6acef588172c45e6"/>
+    <p:sldId xmlns:r="http://schemas.openxmlformats.org/officeDocument/2006/relationships" id="259" r:id="Rf5c8a5e1ebf045ab"/>
+    <p:sldId xmlns:r="http://schemas.openxmlformats.org/officeDocument/2006/relationships" id="260" r:id="Rf218c7a52dea4d48"/>
+    <p:sldId xmlns:r="http://schemas.openxmlformats.org/officeDocument/2006/relationships" id="261" r:id="R8538fa1474b1440b"/>
+    <p:sldId xmlns:r="http://schemas.openxmlformats.org/officeDocument/2006/relationships" id="262" r:id="R4aff35547c874489"/>
+    <p:sldId xmlns:r="http://schemas.openxmlformats.org/officeDocument/2006/relationships" id="263" r:id="Rf8be2dde811c41b1"/>
+    <p:sldId xmlns:r="http://schemas.openxmlformats.org/officeDocument/2006/relationships" id="264" r:id="Ra09ddb8152a7415a"/>
+    <p:sldId xmlns:r="http://schemas.openxmlformats.org/officeDocument/2006/relationships" id="265" r:id="R30544b082a004245"/>
+    <p:sldId xmlns:r="http://schemas.openxmlformats.org/officeDocument/2006/relationships" id="266" r:id="Rc19caeaf7ab84701"/>
+    <p:sldId xmlns:r="http://schemas.openxmlformats.org/officeDocument/2006/relationships" id="267" r:id="R1a93b5e35a474d6f"/>
+    <p:sldId xmlns:r="http://schemas.openxmlformats.org/officeDocument/2006/relationships" id="268" r:id="Rdebed9b021d14475"/>
+    <p:sldId xmlns:r="http://schemas.openxmlformats.org/officeDocument/2006/relationships" id="269" r:id="Rc96f9e6eb50443d2"/>
+    <p:sldId xmlns:r="http://schemas.openxmlformats.org/officeDocument/2006/relationships" id="270" r:id="Rd25554d706c44d3e"/>
+    <p:sldId xmlns:r="http://schemas.openxmlformats.org/officeDocument/2006/relationships" id="271" r:id="R0b5bf189d9e54495"/>
+    <p:sldId xmlns:r="http://schemas.openxmlformats.org/officeDocument/2006/relationships" id="272" r:id="R22c822a0407041c4"/>
+    <p:sldId xmlns:r="http://schemas.openxmlformats.org/officeDocument/2006/relationships" id="273" r:id="R540a4724b4d34257"/>
   </p:sldIdLst>
   <p:sldSz cx="12192000" cy="6858000"/>
   <p:notesSz cx="6858000" cy="9144000"/>
@@ -2241,7 +2241,7 @@
           <p:cNvPr id="3" name="Title">
             <a:extLst xmlns:a="http://schemas.openxmlformats.org/drawingml/2006/main">
               <a:ext uri="{FF2B5EF4-FFF2-40B4-BE49-F238E27FC236}">
-                <a16:creationId xmlns:a16="http://schemas.microsoft.com/office/drawing/2014/main" id="{1D4D5196-DBA2-4401-B5B2-F733429FFE83}"/>
+                <a16:creationId xmlns:a16="http://schemas.microsoft.com/office/drawing/2014/main" id="{68C17EAC-16B1-496A-9E2B-F5A5D78A72DB}"/>
               </a:ext>
             </a:extLst>
           </p:cNvPr>
@@ -2398,7 +2398,7 @@
           <p:cNvPr id="2" name="Subtitle">
             <a:extLst xmlns:a="http://schemas.openxmlformats.org/drawingml/2006/main">
               <a:ext uri="{FF2B5EF4-FFF2-40B4-BE49-F238E27FC236}">
-                <a16:creationId xmlns:a16="http://schemas.microsoft.com/office/drawing/2014/main" id="{4E22BFFD-3AE1-4F7E-8FD0-C1AC68622DDE}"/>
+                <a16:creationId xmlns:a16="http://schemas.microsoft.com/office/drawing/2014/main" id="{F5481D1A-3FB3-49DB-9E46-E0C264C15E1C}"/>
               </a:ext>
             </a:extLst>
           </p:cNvPr>
@@ -2572,7 +2572,7 @@
           <p:cNvPr id="2" name="Section title">
             <a:extLst xmlns:a="http://schemas.openxmlformats.org/drawingml/2006/main">
               <a:ext uri="{FF2B5EF4-FFF2-40B4-BE49-F238E27FC236}">
-                <a16:creationId xmlns:a16="http://schemas.microsoft.com/office/drawing/2014/main" id="{6E6EC222-221F-440C-BBC3-42E6D88AC909}"/>
+                <a16:creationId xmlns:a16="http://schemas.microsoft.com/office/drawing/2014/main" id="{A88597B4-1F4B-4EF1-9263-BD11AB294B34}"/>
               </a:ext>
             </a:extLst>
           </p:cNvPr>
@@ -2746,7 +2746,7 @@
           <p:cNvPr id="3" name="Title">
             <a:extLst xmlns:a="http://schemas.openxmlformats.org/drawingml/2006/main">
               <a:ext uri="{FF2B5EF4-FFF2-40B4-BE49-F238E27FC236}">
-                <a16:creationId xmlns:a16="http://schemas.microsoft.com/office/drawing/2014/main" id="{F51FC321-09B8-420B-9E3E-E3B71DCDF1FC}"/>
+                <a16:creationId xmlns:a16="http://schemas.microsoft.com/office/drawing/2014/main" id="{35E637B2-8FE5-4B79-8796-B2EC10C951FD}"/>
               </a:ext>
             </a:extLst>
           </p:cNvPr>
@@ -2903,7 +2903,7 @@
           <p:cNvPr id="2" name="Body">
             <a:extLst xmlns:a="http://schemas.openxmlformats.org/drawingml/2006/main">
               <a:ext uri="{FF2B5EF4-FFF2-40B4-BE49-F238E27FC236}">
-                <a16:creationId xmlns:a16="http://schemas.microsoft.com/office/drawing/2014/main" id="{A60123D2-92F5-4DE2-AFC0-3A9B21935DAC}"/>
+                <a16:creationId xmlns:a16="http://schemas.microsoft.com/office/drawing/2014/main" id="{3F4A2870-568C-4A4F-9267-54F3B05E27FF}"/>
               </a:ext>
             </a:extLst>
           </p:cNvPr>
@@ -3077,7 +3077,7 @@
           <p:cNvPr id="4" name="Title">
             <a:extLst xmlns:a="http://schemas.openxmlformats.org/drawingml/2006/main">
               <a:ext uri="{FF2B5EF4-FFF2-40B4-BE49-F238E27FC236}">
-                <a16:creationId xmlns:a16="http://schemas.microsoft.com/office/drawing/2014/main" id="{2528F5FB-34C8-40A2-8E11-E8AB69565AA6}"/>
+                <a16:creationId xmlns:a16="http://schemas.microsoft.com/office/drawing/2014/main" id="{E7E48DD3-7149-4B60-9D7B-1C180421E938}"/>
               </a:ext>
             </a:extLst>
           </p:cNvPr>
@@ -3234,7 +3234,7 @@
           <p:cNvPr id="2" name="Left column">
             <a:extLst xmlns:a="http://schemas.openxmlformats.org/drawingml/2006/main">
               <a:ext uri="{FF2B5EF4-FFF2-40B4-BE49-F238E27FC236}">
-                <a16:creationId xmlns:a16="http://schemas.microsoft.com/office/drawing/2014/main" id="{28AA1A51-B572-4488-AA5B-6DBCDAED8510}"/>
+                <a16:creationId xmlns:a16="http://schemas.microsoft.com/office/drawing/2014/main" id="{E8FF1EB6-6213-4085-8ECE-E06E71342D4B}"/>
               </a:ext>
             </a:extLst>
           </p:cNvPr>
@@ -3391,7 +3391,7 @@
           <p:cNvPr id="3" name="Right column">
             <a:extLst xmlns:a="http://schemas.openxmlformats.org/drawingml/2006/main">
               <a:ext uri="{FF2B5EF4-FFF2-40B4-BE49-F238E27FC236}">
-                <a16:creationId xmlns:a16="http://schemas.microsoft.com/office/drawing/2014/main" id="{543DACEF-5839-45E8-979F-49F337868344}"/>
+                <a16:creationId xmlns:a16="http://schemas.microsoft.com/office/drawing/2014/main" id="{464070F4-D796-444D-A60E-61E786013C16}"/>
               </a:ext>
             </a:extLst>
           </p:cNvPr>
@@ -3565,7 +3565,7 @@
           <p:cNvPr id="3" name="Title">
             <a:extLst xmlns:a="http://schemas.openxmlformats.org/drawingml/2006/main">
               <a:ext uri="{FF2B5EF4-FFF2-40B4-BE49-F238E27FC236}">
-                <a16:creationId xmlns:a16="http://schemas.microsoft.com/office/drawing/2014/main" id="{35E70E0F-2464-49A5-A62C-7872DF21B9C0}"/>
+                <a16:creationId xmlns:a16="http://schemas.microsoft.com/office/drawing/2014/main" id="{4B24F260-5D6D-40FB-9E70-2BDF1BAA9189}"/>
               </a:ext>
             </a:extLst>
           </p:cNvPr>
@@ -3722,7 +3722,7 @@
           <p:cNvPr id="2" name="Left column">
             <a:extLst xmlns:a="http://schemas.openxmlformats.org/drawingml/2006/main">
               <a:ext uri="{FF2B5EF4-FFF2-40B4-BE49-F238E27FC236}">
-                <a16:creationId xmlns:a16="http://schemas.microsoft.com/office/drawing/2014/main" id="{9196A9EA-4E4E-482C-92BF-36404BE3B5CC}"/>
+                <a16:creationId xmlns:a16="http://schemas.microsoft.com/office/drawing/2014/main" id="{60B493F8-F97E-4F21-B2F1-2EBF467D932B}"/>
               </a:ext>
             </a:extLst>
           </p:cNvPr>
@@ -3917,12 +3917,12 @@
   </p:cSld>
   <p:clrMap bg1="lt1" tx1="dk1" bg2="lt2" tx2="dk2" accent1="accent1" accent2="accent2" accent3="accent3" accent4="accent4" accent5="accent5" accent6="accent6" hlink="hlink" folHlink="folHlink"/>
   <p:sldLayoutIdLst>
-    <p:sldLayoutId xmlns:r="http://schemas.openxmlformats.org/officeDocument/2006/relationships" id="2147483649" r:id="R31fffb96189e40d0"/>
-    <p:sldLayoutId xmlns:r="http://schemas.openxmlformats.org/officeDocument/2006/relationships" id="2147483650" r:id="R53d4b43bf73849e6"/>
-    <p:sldLayoutId xmlns:r="http://schemas.openxmlformats.org/officeDocument/2006/relationships" id="2147483651" r:id="R0b5234bccc784a96"/>
-    <p:sldLayoutId xmlns:r="http://schemas.openxmlformats.org/officeDocument/2006/relationships" id="2147483652" r:id="R49a4172f474e4571"/>
-    <p:sldLayoutId xmlns:r="http://schemas.openxmlformats.org/officeDocument/2006/relationships" id="2147483653" r:id="R6e0ede46c43d4da3"/>
-    <p:sldLayoutId xmlns:r="http://schemas.openxmlformats.org/officeDocument/2006/relationships" id="2147483654" r:id="R2823a64d82a64d44"/>
+    <p:sldLayoutId xmlns:r="http://schemas.openxmlformats.org/officeDocument/2006/relationships" id="2147483649" r:id="R567989f058414752"/>
+    <p:sldLayoutId xmlns:r="http://schemas.openxmlformats.org/officeDocument/2006/relationships" id="2147483650" r:id="R0acd1aab72aa44d1"/>
+    <p:sldLayoutId xmlns:r="http://schemas.openxmlformats.org/officeDocument/2006/relationships" id="2147483651" r:id="Rb4bff0f103bf4ff5"/>
+    <p:sldLayoutId xmlns:r="http://schemas.openxmlformats.org/officeDocument/2006/relationships" id="2147483652" r:id="R9635061548ec48db"/>
+    <p:sldLayoutId xmlns:r="http://schemas.openxmlformats.org/officeDocument/2006/relationships" id="2147483653" r:id="Rd60479e84459466a"/>
+    <p:sldLayoutId xmlns:r="http://schemas.openxmlformats.org/officeDocument/2006/relationships" id="2147483654" r:id="Ra8c98c7272944798"/>
   </p:sldLayoutIdLst>
   <p:txStyles>
     <p:titleStyle>
@@ -4473,7 +4473,7 @@
           <p:cNvPr id="6" name="title">
             <a:extLst xmlns:a="http://schemas.openxmlformats.org/drawingml/2006/main">
               <a:ext uri="{FF2B5EF4-FFF2-40B4-BE49-F238E27FC236}">
-                <a16:creationId xmlns:a16="http://schemas.microsoft.com/office/drawing/2014/main" id="{C98A6FB8-B97F-4A52-9296-3890B0D7E44A}"/>
+                <a16:creationId xmlns:a16="http://schemas.microsoft.com/office/drawing/2014/main" id="{7585D801-D1C9-4367-9DD0-C30E823F64B3}"/>
               </a:ext>
             </a:extLst>
           </p:cNvPr>
@@ -4529,7 +4529,7 @@
                 <a:ea typeface="Arial"/>
                 <a:cs typeface="Arial"/>
               </a:rPr>
-              <a:t>GOV.UK Delegate: design review</a:t>
+              <a:t>Delegate: design review</a:t>
             </a:r>
           </a:p>
         </p:txBody>
@@ -4539,7 +4539,7 @@
           <p:cNvPr id="2" name="paragraph-0">
             <a:extLst xmlns:a="http://schemas.openxmlformats.org/drawingml/2006/main">
               <a:ext uri="{FF2B5EF4-FFF2-40B4-BE49-F238E27FC236}">
-                <a16:creationId xmlns:a16="http://schemas.microsoft.com/office/drawing/2014/main" id="{5E4A1FE7-411A-4EA3-90AD-14B3388CE032}"/>
+                <a16:creationId xmlns:a16="http://schemas.microsoft.com/office/drawing/2014/main" id="{6F92931E-4073-448A-8D91-E798C78D4AF9}"/>
               </a:ext>
             </a:extLst>
           </p:cNvPr>
@@ -4605,7 +4605,7 @@
           <p:cNvPr id="3" name="paragraph-1">
             <a:extLst xmlns:a="http://schemas.openxmlformats.org/drawingml/2006/main">
               <a:ext uri="{FF2B5EF4-FFF2-40B4-BE49-F238E27FC236}">
-                <a16:creationId xmlns:a16="http://schemas.microsoft.com/office/drawing/2014/main" id="{213FCC9D-49EC-425C-8DD5-9E31DCB8D832}"/>
+                <a16:creationId xmlns:a16="http://schemas.microsoft.com/office/drawing/2014/main" id="{435CE23B-2D6C-4C35-BF63-6B3D4F8D7EE8}"/>
               </a:ext>
             </a:extLst>
           </p:cNvPr>
@@ -4671,7 +4671,7 @@
           <p:cNvPr id="4" name="disclosure">
             <a:extLst xmlns:a="http://schemas.openxmlformats.org/drawingml/2006/main">
               <a:ext uri="{FF2B5EF4-FFF2-40B4-BE49-F238E27FC236}">
-                <a16:creationId xmlns:a16="http://schemas.microsoft.com/office/drawing/2014/main" id="{05B777B4-CC62-4EE0-93C0-15D04706BD1E}"/>
+                <a16:creationId xmlns:a16="http://schemas.microsoft.com/office/drawing/2014/main" id="{BB73B43D-E7C5-432A-AF6F-47E26C632E16}"/>
               </a:ext>
             </a:extLst>
           </p:cNvPr>
@@ -4737,7 +4737,7 @@
           <p:cNvPr id="5" name="page">
             <a:extLst xmlns:a="http://schemas.openxmlformats.org/drawingml/2006/main">
               <a:ext uri="{FF2B5EF4-FFF2-40B4-BE49-F238E27FC236}">
-                <a16:creationId xmlns:a16="http://schemas.microsoft.com/office/drawing/2014/main" id="{6D89CABC-4C9A-4508-8821-0F0684277983}"/>
+                <a16:creationId xmlns:a16="http://schemas.microsoft.com/office/drawing/2014/main" id="{AA922E01-D3E4-43F6-942E-EE7EC9605B50}"/>
               </a:ext>
             </a:extLst>
           </p:cNvPr>
@@ -4801,7 +4801,7 @@
     </p:spTree>
     <p:extLst>
       <p:ext uri="{BB962C8B-B14F-4D97-AF65-F5344CB8AC3E}">
-        <p14:creationId xmlns:p14="http://schemas.microsoft.com/office/powerpoint/2010/main" val="1380073946"/>
+        <p14:creationId xmlns:p14="http://schemas.microsoft.com/office/powerpoint/2010/main" val="749129420"/>
       </p:ext>
     </p:extLst>
   </p:cSld>
@@ -4832,7 +4832,7 @@
           <p:cNvPr id="6" name="title">
             <a:extLst xmlns:a="http://schemas.openxmlformats.org/drawingml/2006/main">
               <a:ext uri="{FF2B5EF4-FFF2-40B4-BE49-F238E27FC236}">
-                <a16:creationId xmlns:a16="http://schemas.microsoft.com/office/drawing/2014/main" id="{0BDBE508-3C78-4012-B00C-DBCC1A7AAB85}"/>
+                <a16:creationId xmlns:a16="http://schemas.microsoft.com/office/drawing/2014/main" id="{33159F14-3D2C-4B23-8788-BBFD2FD266D5}"/>
               </a:ext>
             </a:extLst>
           </p:cNvPr>
@@ -4898,7 +4898,7 @@
           <p:cNvPr id="2" name="paragraph-0">
             <a:extLst xmlns:a="http://schemas.openxmlformats.org/drawingml/2006/main">
               <a:ext uri="{FF2B5EF4-FFF2-40B4-BE49-F238E27FC236}">
-                <a16:creationId xmlns:a16="http://schemas.microsoft.com/office/drawing/2014/main" id="{5BE89609-3ECD-4008-BD9E-CB01426F8F91}"/>
+                <a16:creationId xmlns:a16="http://schemas.microsoft.com/office/drawing/2014/main" id="{C25EE8CB-7677-4B15-9420-B3FEB343FDAB}"/>
               </a:ext>
             </a:extLst>
           </p:cNvPr>
@@ -4964,7 +4964,7 @@
           <p:cNvPr id="3" name="paragraph-1">
             <a:extLst xmlns:a="http://schemas.openxmlformats.org/drawingml/2006/main">
               <a:ext uri="{FF2B5EF4-FFF2-40B4-BE49-F238E27FC236}">
-                <a16:creationId xmlns:a16="http://schemas.microsoft.com/office/drawing/2014/main" id="{15C29C6B-89B7-4FAD-BCF1-558648BB2DFC}"/>
+                <a16:creationId xmlns:a16="http://schemas.microsoft.com/office/drawing/2014/main" id="{7D604054-821C-415B-96D8-4C038D7AD7D1}"/>
               </a:ext>
             </a:extLst>
           </p:cNvPr>
@@ -5030,7 +5030,7 @@
           <p:cNvPr id="4" name="disclosure">
             <a:extLst xmlns:a="http://schemas.openxmlformats.org/drawingml/2006/main">
               <a:ext uri="{FF2B5EF4-FFF2-40B4-BE49-F238E27FC236}">
-                <a16:creationId xmlns:a16="http://schemas.microsoft.com/office/drawing/2014/main" id="{6BC6D8DD-4605-4D77-B683-E18E2B3F5607}"/>
+                <a16:creationId xmlns:a16="http://schemas.microsoft.com/office/drawing/2014/main" id="{AB8E0F85-09EE-45F4-A51D-FEAEDFDDCA4C}"/>
               </a:ext>
             </a:extLst>
           </p:cNvPr>
@@ -5096,7 +5096,7 @@
           <p:cNvPr id="5" name="page">
             <a:extLst xmlns:a="http://schemas.openxmlformats.org/drawingml/2006/main">
               <a:ext uri="{FF2B5EF4-FFF2-40B4-BE49-F238E27FC236}">
-                <a16:creationId xmlns:a16="http://schemas.microsoft.com/office/drawing/2014/main" id="{715A2934-06FE-4139-9379-6D07E0B3499F}"/>
+                <a16:creationId xmlns:a16="http://schemas.microsoft.com/office/drawing/2014/main" id="{58D41FF9-9F22-4844-85F8-42E509F7C694}"/>
               </a:ext>
             </a:extLst>
           </p:cNvPr>
@@ -5160,7 +5160,7 @@
     </p:spTree>
     <p:extLst>
       <p:ext uri="{BB962C8B-B14F-4D97-AF65-F5344CB8AC3E}">
-        <p14:creationId xmlns:p14="http://schemas.microsoft.com/office/powerpoint/2010/main" val="2104366027"/>
+        <p14:creationId xmlns:p14="http://schemas.microsoft.com/office/powerpoint/2010/main" val="1912771001"/>
       </p:ext>
     </p:extLst>
   </p:cSld>
@@ -5191,7 +5191,7 @@
           <p:cNvPr id="5" name="title">
             <a:extLst xmlns:a="http://schemas.openxmlformats.org/drawingml/2006/main">
               <a:ext uri="{FF2B5EF4-FFF2-40B4-BE49-F238E27FC236}">
-                <a16:creationId xmlns:a16="http://schemas.microsoft.com/office/drawing/2014/main" id="{D3D0AD85-987B-4072-8EA8-48939F60CA72}"/>
+                <a16:creationId xmlns:a16="http://schemas.microsoft.com/office/drawing/2014/main" id="{9B61C826-9CB5-4346-A5B7-CB9E64F35BC2}"/>
               </a:ext>
             </a:extLst>
           </p:cNvPr>
@@ -5257,7 +5257,7 @@
           <p:cNvPr id="2" name="">
             <a:extLst xmlns:a="http://schemas.openxmlformats.org/drawingml/2006/main">
               <a:ext uri="{FF2B5EF4-FFF2-40B4-BE49-F238E27FC236}">
-                <a16:creationId xmlns:a16="http://schemas.microsoft.com/office/drawing/2014/main" id="{50B41BB9-2717-427A-8B0B-4B56E0DA84C5}"/>
+                <a16:creationId xmlns:a16="http://schemas.microsoft.com/office/drawing/2014/main" id="{5343C74C-C98B-4701-BC1A-7841FD97B8A6}"/>
               </a:ext>
             </a:extLst>
           </p:cNvPr>
@@ -5585,7 +5585,7 @@
           <p:cNvPr id="3" name="disclosure">
             <a:extLst xmlns:a="http://schemas.openxmlformats.org/drawingml/2006/main">
               <a:ext uri="{FF2B5EF4-FFF2-40B4-BE49-F238E27FC236}">
-                <a16:creationId xmlns:a16="http://schemas.microsoft.com/office/drawing/2014/main" id="{70CD2C73-CC35-45B6-91B2-A5D2F669E597}"/>
+                <a16:creationId xmlns:a16="http://schemas.microsoft.com/office/drawing/2014/main" id="{8AC28157-4E82-4B3A-BE30-248CCC3142E6}"/>
               </a:ext>
             </a:extLst>
           </p:cNvPr>
@@ -5651,7 +5651,7 @@
           <p:cNvPr id="4" name="page">
             <a:extLst xmlns:a="http://schemas.openxmlformats.org/drawingml/2006/main">
               <a:ext uri="{FF2B5EF4-FFF2-40B4-BE49-F238E27FC236}">
-                <a16:creationId xmlns:a16="http://schemas.microsoft.com/office/drawing/2014/main" id="{50DFE4F4-48CC-40F6-9DBD-67EAFF091FFF}"/>
+                <a16:creationId xmlns:a16="http://schemas.microsoft.com/office/drawing/2014/main" id="{8BE26EC7-16E5-4BB8-8454-1F53A1415DAE}"/>
               </a:ext>
             </a:extLst>
           </p:cNvPr>
@@ -5715,7 +5715,7 @@
     </p:spTree>
     <p:extLst>
       <p:ext uri="{BB962C8B-B14F-4D97-AF65-F5344CB8AC3E}">
-        <p14:creationId xmlns:p14="http://schemas.microsoft.com/office/powerpoint/2010/main" val="97182778"/>
+        <p14:creationId xmlns:p14="http://schemas.microsoft.com/office/powerpoint/2010/main" val="2074769525"/>
       </p:ext>
     </p:extLst>
   </p:cSld>
@@ -5746,7 +5746,7 @@
           <p:cNvPr id="6" name="title">
             <a:extLst xmlns:a="http://schemas.openxmlformats.org/drawingml/2006/main">
               <a:ext uri="{FF2B5EF4-FFF2-40B4-BE49-F238E27FC236}">
-                <a16:creationId xmlns:a16="http://schemas.microsoft.com/office/drawing/2014/main" id="{AEA69242-4931-44EC-A41D-04DC1CE316CD}"/>
+                <a16:creationId xmlns:a16="http://schemas.microsoft.com/office/drawing/2014/main" id="{49C00C47-0962-4D0E-97C9-42AB9B2021FA}"/>
               </a:ext>
             </a:extLst>
           </p:cNvPr>
@@ -5812,7 +5812,7 @@
           <p:cNvPr id="2" name="paragraph-0">
             <a:extLst xmlns:a="http://schemas.openxmlformats.org/drawingml/2006/main">
               <a:ext uri="{FF2B5EF4-FFF2-40B4-BE49-F238E27FC236}">
-                <a16:creationId xmlns:a16="http://schemas.microsoft.com/office/drawing/2014/main" id="{4BB214DB-3E8C-4AF2-B3A5-AA458055A302}"/>
+                <a16:creationId xmlns:a16="http://schemas.microsoft.com/office/drawing/2014/main" id="{914C82BE-6BF3-4C8C-99C3-4A020F3BF3AB}"/>
               </a:ext>
             </a:extLst>
           </p:cNvPr>
@@ -5878,7 +5878,7 @@
           <p:cNvPr id="3" name="paragraph-1">
             <a:extLst xmlns:a="http://schemas.openxmlformats.org/drawingml/2006/main">
               <a:ext uri="{FF2B5EF4-FFF2-40B4-BE49-F238E27FC236}">
-                <a16:creationId xmlns:a16="http://schemas.microsoft.com/office/drawing/2014/main" id="{03A1EE5D-878E-4170-9CCB-746981A49E18}"/>
+                <a16:creationId xmlns:a16="http://schemas.microsoft.com/office/drawing/2014/main" id="{3503CAEA-DAA5-4070-B8DD-E2DD5FA419E0}"/>
               </a:ext>
             </a:extLst>
           </p:cNvPr>
@@ -5944,7 +5944,7 @@
           <p:cNvPr id="4" name="disclosure">
             <a:extLst xmlns:a="http://schemas.openxmlformats.org/drawingml/2006/main">
               <a:ext uri="{FF2B5EF4-FFF2-40B4-BE49-F238E27FC236}">
-                <a16:creationId xmlns:a16="http://schemas.microsoft.com/office/drawing/2014/main" id="{245B73F3-5697-491E-BBC8-AEEA3E41EC77}"/>
+                <a16:creationId xmlns:a16="http://schemas.microsoft.com/office/drawing/2014/main" id="{AC6A68AD-D91E-41DE-B06D-6DDF094DF0F4}"/>
               </a:ext>
             </a:extLst>
           </p:cNvPr>
@@ -6010,7 +6010,7 @@
           <p:cNvPr id="5" name="page">
             <a:extLst xmlns:a="http://schemas.openxmlformats.org/drawingml/2006/main">
               <a:ext uri="{FF2B5EF4-FFF2-40B4-BE49-F238E27FC236}">
-                <a16:creationId xmlns:a16="http://schemas.microsoft.com/office/drawing/2014/main" id="{E4E17B04-B8CC-4C6C-A256-3335CC85599C}"/>
+                <a16:creationId xmlns:a16="http://schemas.microsoft.com/office/drawing/2014/main" id="{E5DAA9AC-BD58-404F-8A9C-DF18C85F0069}"/>
               </a:ext>
             </a:extLst>
           </p:cNvPr>
@@ -6074,7 +6074,7 @@
     </p:spTree>
     <p:extLst>
       <p:ext uri="{BB962C8B-B14F-4D97-AF65-F5344CB8AC3E}">
-        <p14:creationId xmlns:p14="http://schemas.microsoft.com/office/powerpoint/2010/main" val="1345309008"/>
+        <p14:creationId xmlns:p14="http://schemas.microsoft.com/office/powerpoint/2010/main" val="96193816"/>
       </p:ext>
     </p:extLst>
   </p:cSld>
@@ -6105,7 +6105,7 @@
           <p:cNvPr id="6" name="title">
             <a:extLst xmlns:a="http://schemas.openxmlformats.org/drawingml/2006/main">
               <a:ext uri="{FF2B5EF4-FFF2-40B4-BE49-F238E27FC236}">
-                <a16:creationId xmlns:a16="http://schemas.microsoft.com/office/drawing/2014/main" id="{7134C97D-22A0-4D02-8712-3442AD77C28C}"/>
+                <a16:creationId xmlns:a16="http://schemas.microsoft.com/office/drawing/2014/main" id="{29F4E924-17EA-4DC3-ADAD-9799675D23A3}"/>
               </a:ext>
             </a:extLst>
           </p:cNvPr>
@@ -6171,7 +6171,7 @@
           <p:cNvPr id="2" name="paragraph-0">
             <a:extLst xmlns:a="http://schemas.openxmlformats.org/drawingml/2006/main">
               <a:ext uri="{FF2B5EF4-FFF2-40B4-BE49-F238E27FC236}">
-                <a16:creationId xmlns:a16="http://schemas.microsoft.com/office/drawing/2014/main" id="{FF309E6B-EBF2-49A4-B9EE-617D5ACE9FBE}"/>
+                <a16:creationId xmlns:a16="http://schemas.microsoft.com/office/drawing/2014/main" id="{2EA249A3-EBB6-40FD-9C0C-3C20E7597398}"/>
               </a:ext>
             </a:extLst>
           </p:cNvPr>
@@ -6237,7 +6237,7 @@
           <p:cNvPr id="3" name="paragraph-1">
             <a:extLst xmlns:a="http://schemas.openxmlformats.org/drawingml/2006/main">
               <a:ext uri="{FF2B5EF4-FFF2-40B4-BE49-F238E27FC236}">
-                <a16:creationId xmlns:a16="http://schemas.microsoft.com/office/drawing/2014/main" id="{22B44BCF-44BF-4846-B5F7-28196CD248C3}"/>
+                <a16:creationId xmlns:a16="http://schemas.microsoft.com/office/drawing/2014/main" id="{42141EA2-D5F2-4231-89A7-95CC020CEE85}"/>
               </a:ext>
             </a:extLst>
           </p:cNvPr>
@@ -6303,7 +6303,7 @@
           <p:cNvPr id="4" name="disclosure">
             <a:extLst xmlns:a="http://schemas.openxmlformats.org/drawingml/2006/main">
               <a:ext uri="{FF2B5EF4-FFF2-40B4-BE49-F238E27FC236}">
-                <a16:creationId xmlns:a16="http://schemas.microsoft.com/office/drawing/2014/main" id="{B0B1BB37-8CA4-4332-B228-9021B617A223}"/>
+                <a16:creationId xmlns:a16="http://schemas.microsoft.com/office/drawing/2014/main" id="{A3930BCC-99E9-4C7A-995F-5947CFB42F3D}"/>
               </a:ext>
             </a:extLst>
           </p:cNvPr>
@@ -6369,7 +6369,7 @@
           <p:cNvPr id="5" name="page">
             <a:extLst xmlns:a="http://schemas.openxmlformats.org/drawingml/2006/main">
               <a:ext uri="{FF2B5EF4-FFF2-40B4-BE49-F238E27FC236}">
-                <a16:creationId xmlns:a16="http://schemas.microsoft.com/office/drawing/2014/main" id="{650B0EAF-5181-47F5-A25C-608404688590}"/>
+                <a16:creationId xmlns:a16="http://schemas.microsoft.com/office/drawing/2014/main" id="{8A339ED0-DE92-42B9-897D-1C390EBCF4AD}"/>
               </a:ext>
             </a:extLst>
           </p:cNvPr>
@@ -6433,7 +6433,7 @@
     </p:spTree>
     <p:extLst>
       <p:ext uri="{BB962C8B-B14F-4D97-AF65-F5344CB8AC3E}">
-        <p14:creationId xmlns:p14="http://schemas.microsoft.com/office/powerpoint/2010/main" val="284676490"/>
+        <p14:creationId xmlns:p14="http://schemas.microsoft.com/office/powerpoint/2010/main" val="421444301"/>
       </p:ext>
     </p:extLst>
   </p:cSld>
@@ -6464,7 +6464,7 @@
           <p:cNvPr id="5" name="title">
             <a:extLst xmlns:a="http://schemas.openxmlformats.org/drawingml/2006/main">
               <a:ext uri="{FF2B5EF4-FFF2-40B4-BE49-F238E27FC236}">
-                <a16:creationId xmlns:a16="http://schemas.microsoft.com/office/drawing/2014/main" id="{156FD4F1-8C04-486D-9CB4-68D7611C1051}"/>
+                <a16:creationId xmlns:a16="http://schemas.microsoft.com/office/drawing/2014/main" id="{DA3BF1C7-74CB-484A-9B95-F907EF0CBB5C}"/>
               </a:ext>
             </a:extLst>
           </p:cNvPr>
@@ -6530,7 +6530,7 @@
           <p:cNvPr id="2" name="">
             <a:extLst xmlns:a="http://schemas.openxmlformats.org/drawingml/2006/main">
               <a:ext uri="{FF2B5EF4-FFF2-40B4-BE49-F238E27FC236}">
-                <a16:creationId xmlns:a16="http://schemas.microsoft.com/office/drawing/2014/main" id="{90AC534D-751E-41C1-B6CC-FD13DB7E7A10}"/>
+                <a16:creationId xmlns:a16="http://schemas.microsoft.com/office/drawing/2014/main" id="{95C59C16-AA15-4770-B490-A7EFD405D922}"/>
               </a:ext>
             </a:extLst>
           </p:cNvPr>
@@ -6808,7 +6808,7 @@
           <p:cNvPr id="3" name="disclosure">
             <a:extLst xmlns:a="http://schemas.openxmlformats.org/drawingml/2006/main">
               <a:ext uri="{FF2B5EF4-FFF2-40B4-BE49-F238E27FC236}">
-                <a16:creationId xmlns:a16="http://schemas.microsoft.com/office/drawing/2014/main" id="{3650834A-2E60-4352-B14D-3B5278FD3E89}"/>
+                <a16:creationId xmlns:a16="http://schemas.microsoft.com/office/drawing/2014/main" id="{12EF9DD4-5475-4693-9AE7-C72BFAED1F9C}"/>
               </a:ext>
             </a:extLst>
           </p:cNvPr>
@@ -6874,7 +6874,7 @@
           <p:cNvPr id="4" name="page">
             <a:extLst xmlns:a="http://schemas.openxmlformats.org/drawingml/2006/main">
               <a:ext uri="{FF2B5EF4-FFF2-40B4-BE49-F238E27FC236}">
-                <a16:creationId xmlns:a16="http://schemas.microsoft.com/office/drawing/2014/main" id="{8FB234FA-B8D7-42E6-BDE5-14138827B2D6}"/>
+                <a16:creationId xmlns:a16="http://schemas.microsoft.com/office/drawing/2014/main" id="{8A3E1965-8E1A-4E62-A39E-033F304A75F9}"/>
               </a:ext>
             </a:extLst>
           </p:cNvPr>
@@ -6938,7 +6938,7 @@
     </p:spTree>
     <p:extLst>
       <p:ext uri="{BB962C8B-B14F-4D97-AF65-F5344CB8AC3E}">
-        <p14:creationId xmlns:p14="http://schemas.microsoft.com/office/powerpoint/2010/main" val="440015541"/>
+        <p14:creationId xmlns:p14="http://schemas.microsoft.com/office/powerpoint/2010/main" val="1928748763"/>
       </p:ext>
     </p:extLst>
   </p:cSld>
@@ -6969,7 +6969,7 @@
           <p:cNvPr id="6" name="title">
             <a:extLst xmlns:a="http://schemas.openxmlformats.org/drawingml/2006/main">
               <a:ext uri="{FF2B5EF4-FFF2-40B4-BE49-F238E27FC236}">
-                <a16:creationId xmlns:a16="http://schemas.microsoft.com/office/drawing/2014/main" id="{A5C70F49-0279-40B3-91CC-7B5602A81DAC}"/>
+                <a16:creationId xmlns:a16="http://schemas.microsoft.com/office/drawing/2014/main" id="{B10C843F-AE93-473F-ABB8-D92A19EE0021}"/>
               </a:ext>
             </a:extLst>
           </p:cNvPr>
@@ -7035,7 +7035,7 @@
           <p:cNvPr id="2" name="paragraph-0">
             <a:extLst xmlns:a="http://schemas.openxmlformats.org/drawingml/2006/main">
               <a:ext uri="{FF2B5EF4-FFF2-40B4-BE49-F238E27FC236}">
-                <a16:creationId xmlns:a16="http://schemas.microsoft.com/office/drawing/2014/main" id="{D2130516-7206-428D-88F4-CCEEF2F0028E}"/>
+                <a16:creationId xmlns:a16="http://schemas.microsoft.com/office/drawing/2014/main" id="{C2DDB330-FAC7-4B12-8FFD-3E87E5926899}"/>
               </a:ext>
             </a:extLst>
           </p:cNvPr>
@@ -7101,7 +7101,7 @@
           <p:cNvPr id="3" name="paragraph-1">
             <a:extLst xmlns:a="http://schemas.openxmlformats.org/drawingml/2006/main">
               <a:ext uri="{FF2B5EF4-FFF2-40B4-BE49-F238E27FC236}">
-                <a16:creationId xmlns:a16="http://schemas.microsoft.com/office/drawing/2014/main" id="{F4ED54BA-6BB4-4217-9C0B-4446803644F6}"/>
+                <a16:creationId xmlns:a16="http://schemas.microsoft.com/office/drawing/2014/main" id="{BEF10A19-CE3D-4F9C-8760-EB122B969469}"/>
               </a:ext>
             </a:extLst>
           </p:cNvPr>
@@ -7167,7 +7167,7 @@
           <p:cNvPr id="4" name="disclosure">
             <a:extLst xmlns:a="http://schemas.openxmlformats.org/drawingml/2006/main">
               <a:ext uri="{FF2B5EF4-FFF2-40B4-BE49-F238E27FC236}">
-                <a16:creationId xmlns:a16="http://schemas.microsoft.com/office/drawing/2014/main" id="{0D0D9992-8FFD-40D5-B925-655FECE2C8CD}"/>
+                <a16:creationId xmlns:a16="http://schemas.microsoft.com/office/drawing/2014/main" id="{2732A04C-D7E6-4213-B300-551A928347C8}"/>
               </a:ext>
             </a:extLst>
           </p:cNvPr>
@@ -7233,7 +7233,7 @@
           <p:cNvPr id="5" name="page">
             <a:extLst xmlns:a="http://schemas.openxmlformats.org/drawingml/2006/main">
               <a:ext uri="{FF2B5EF4-FFF2-40B4-BE49-F238E27FC236}">
-                <a16:creationId xmlns:a16="http://schemas.microsoft.com/office/drawing/2014/main" id="{412008B7-28DC-4192-BBCA-59AF2607BA2F}"/>
+                <a16:creationId xmlns:a16="http://schemas.microsoft.com/office/drawing/2014/main" id="{DCFB79CE-6EAF-4D9B-849D-8275F960E821}"/>
               </a:ext>
             </a:extLst>
           </p:cNvPr>
@@ -7297,7 +7297,7 @@
     </p:spTree>
     <p:extLst>
       <p:ext uri="{BB962C8B-B14F-4D97-AF65-F5344CB8AC3E}">
-        <p14:creationId xmlns:p14="http://schemas.microsoft.com/office/powerpoint/2010/main" val="2139795177"/>
+        <p14:creationId xmlns:p14="http://schemas.microsoft.com/office/powerpoint/2010/main" val="1298993996"/>
       </p:ext>
     </p:extLst>
   </p:cSld>
@@ -7328,7 +7328,7 @@
           <p:cNvPr id="5" name="title">
             <a:extLst xmlns:a="http://schemas.openxmlformats.org/drawingml/2006/main">
               <a:ext uri="{FF2B5EF4-FFF2-40B4-BE49-F238E27FC236}">
-                <a16:creationId xmlns:a16="http://schemas.microsoft.com/office/drawing/2014/main" id="{126E473A-37E3-41B8-8DBC-3DDACAAC2C15}"/>
+                <a16:creationId xmlns:a16="http://schemas.microsoft.com/office/drawing/2014/main" id="{A58F8667-4131-43EB-BFD3-B40E0502AEF5}"/>
               </a:ext>
             </a:extLst>
           </p:cNvPr>
@@ -7394,7 +7394,7 @@
           <p:cNvPr id="2" name="">
             <a:extLst xmlns:a="http://schemas.openxmlformats.org/drawingml/2006/main">
               <a:ext uri="{FF2B5EF4-FFF2-40B4-BE49-F238E27FC236}">
-                <a16:creationId xmlns:a16="http://schemas.microsoft.com/office/drawing/2014/main" id="{CEFD148A-39EE-45B3-A367-AE878C694BE0}"/>
+                <a16:creationId xmlns:a16="http://schemas.microsoft.com/office/drawing/2014/main" id="{2E99A7AF-7BD4-43A7-A6EC-05D3251624F8}"/>
               </a:ext>
             </a:extLst>
           </p:cNvPr>
@@ -7722,7 +7722,7 @@
           <p:cNvPr id="3" name="disclosure">
             <a:extLst xmlns:a="http://schemas.openxmlformats.org/drawingml/2006/main">
               <a:ext uri="{FF2B5EF4-FFF2-40B4-BE49-F238E27FC236}">
-                <a16:creationId xmlns:a16="http://schemas.microsoft.com/office/drawing/2014/main" id="{133BF00D-D619-45AA-82EA-F827D44EB9CD}"/>
+                <a16:creationId xmlns:a16="http://schemas.microsoft.com/office/drawing/2014/main" id="{AABB7608-B6EC-4650-960E-366D8D4F9AA5}"/>
               </a:ext>
             </a:extLst>
           </p:cNvPr>
@@ -7788,7 +7788,7 @@
           <p:cNvPr id="4" name="page">
             <a:extLst xmlns:a="http://schemas.openxmlformats.org/drawingml/2006/main">
               <a:ext uri="{FF2B5EF4-FFF2-40B4-BE49-F238E27FC236}">
-                <a16:creationId xmlns:a16="http://schemas.microsoft.com/office/drawing/2014/main" id="{BB519C63-3A09-4102-AFEC-DFDC61B15714}"/>
+                <a16:creationId xmlns:a16="http://schemas.microsoft.com/office/drawing/2014/main" id="{9E8A2E90-726B-4578-91FF-008B94D0B726}"/>
               </a:ext>
             </a:extLst>
           </p:cNvPr>
@@ -7852,7 +7852,7 @@
     </p:spTree>
     <p:extLst>
       <p:ext uri="{BB962C8B-B14F-4D97-AF65-F5344CB8AC3E}">
-        <p14:creationId xmlns:p14="http://schemas.microsoft.com/office/powerpoint/2010/main" val="65664972"/>
+        <p14:creationId xmlns:p14="http://schemas.microsoft.com/office/powerpoint/2010/main" val="865125911"/>
       </p:ext>
     </p:extLst>
   </p:cSld>
@@ -7883,7 +7883,7 @@
           <p:cNvPr id="6" name="title">
             <a:extLst xmlns:a="http://schemas.openxmlformats.org/drawingml/2006/main">
               <a:ext uri="{FF2B5EF4-FFF2-40B4-BE49-F238E27FC236}">
-                <a16:creationId xmlns:a16="http://schemas.microsoft.com/office/drawing/2014/main" id="{F5F82F52-2169-427E-9072-90F52FD155BF}"/>
+                <a16:creationId xmlns:a16="http://schemas.microsoft.com/office/drawing/2014/main" id="{B0F5FF6C-658F-4E33-BE5E-767892F62B4B}"/>
               </a:ext>
             </a:extLst>
           </p:cNvPr>
@@ -7949,7 +7949,7 @@
           <p:cNvPr id="2" name="paragraph-0">
             <a:extLst xmlns:a="http://schemas.openxmlformats.org/drawingml/2006/main">
               <a:ext uri="{FF2B5EF4-FFF2-40B4-BE49-F238E27FC236}">
-                <a16:creationId xmlns:a16="http://schemas.microsoft.com/office/drawing/2014/main" id="{5F77C514-A8C6-4C1D-8EF5-B2109B1B5625}"/>
+                <a16:creationId xmlns:a16="http://schemas.microsoft.com/office/drawing/2014/main" id="{594F7785-0DE3-4262-B139-11CF02347A68}"/>
               </a:ext>
             </a:extLst>
           </p:cNvPr>
@@ -8015,7 +8015,7 @@
           <p:cNvPr id="3" name="paragraph-1">
             <a:extLst xmlns:a="http://schemas.openxmlformats.org/drawingml/2006/main">
               <a:ext uri="{FF2B5EF4-FFF2-40B4-BE49-F238E27FC236}">
-                <a16:creationId xmlns:a16="http://schemas.microsoft.com/office/drawing/2014/main" id="{1D3C83BD-A46D-4F4B-A0DE-831BE352D493}"/>
+                <a16:creationId xmlns:a16="http://schemas.microsoft.com/office/drawing/2014/main" id="{7C87B84B-EA9C-40CA-9788-81B0D35FAA02}"/>
               </a:ext>
             </a:extLst>
           </p:cNvPr>
@@ -8081,7 +8081,7 @@
           <p:cNvPr id="4" name="disclosure">
             <a:extLst xmlns:a="http://schemas.openxmlformats.org/drawingml/2006/main">
               <a:ext uri="{FF2B5EF4-FFF2-40B4-BE49-F238E27FC236}">
-                <a16:creationId xmlns:a16="http://schemas.microsoft.com/office/drawing/2014/main" id="{E3235BAE-2871-4EFD-A1AA-E1035BC07ED0}"/>
+                <a16:creationId xmlns:a16="http://schemas.microsoft.com/office/drawing/2014/main" id="{FFDE583E-5EE3-4F11-9337-94CFC981BF6B}"/>
               </a:ext>
             </a:extLst>
           </p:cNvPr>
@@ -8147,7 +8147,7 @@
           <p:cNvPr id="5" name="page">
             <a:extLst xmlns:a="http://schemas.openxmlformats.org/drawingml/2006/main">
               <a:ext uri="{FF2B5EF4-FFF2-40B4-BE49-F238E27FC236}">
-                <a16:creationId xmlns:a16="http://schemas.microsoft.com/office/drawing/2014/main" id="{B80A448F-DDD8-405A-9E9F-502DA3D2A5FC}"/>
+                <a16:creationId xmlns:a16="http://schemas.microsoft.com/office/drawing/2014/main" id="{696DF8CA-B1ED-46FC-BABE-740DF424539C}"/>
               </a:ext>
             </a:extLst>
           </p:cNvPr>
@@ -8211,7 +8211,7 @@
     </p:spTree>
     <p:extLst>
       <p:ext uri="{BB962C8B-B14F-4D97-AF65-F5344CB8AC3E}">
-        <p14:creationId xmlns:p14="http://schemas.microsoft.com/office/powerpoint/2010/main" val="352816594"/>
+        <p14:creationId xmlns:p14="http://schemas.microsoft.com/office/powerpoint/2010/main" val="492604871"/>
       </p:ext>
     </p:extLst>
   </p:cSld>
@@ -8242,7 +8242,7 @@
           <p:cNvPr id="7" name="title">
             <a:extLst xmlns:a="http://schemas.openxmlformats.org/drawingml/2006/main">
               <a:ext uri="{FF2B5EF4-FFF2-40B4-BE49-F238E27FC236}">
-                <a16:creationId xmlns:a16="http://schemas.microsoft.com/office/drawing/2014/main" id="{469B8F9C-7067-42B0-9506-57124B52DBB9}"/>
+                <a16:creationId xmlns:a16="http://schemas.microsoft.com/office/drawing/2014/main" id="{900897DF-C0E7-4BB2-9611-9DB6B5B91B63}"/>
               </a:ext>
             </a:extLst>
           </p:cNvPr>
@@ -8308,7 +8308,7 @@
           <p:cNvPr id="2" name="paragraph-0">
             <a:extLst xmlns:a="http://schemas.openxmlformats.org/drawingml/2006/main">
               <a:ext uri="{FF2B5EF4-FFF2-40B4-BE49-F238E27FC236}">
-                <a16:creationId xmlns:a16="http://schemas.microsoft.com/office/drawing/2014/main" id="{AC0B0219-EAE4-4374-AD01-62243D7C1F49}"/>
+                <a16:creationId xmlns:a16="http://schemas.microsoft.com/office/drawing/2014/main" id="{7403DA04-C869-40CE-ACDC-EDB5B1554F91}"/>
               </a:ext>
             </a:extLst>
           </p:cNvPr>
@@ -8374,7 +8374,7 @@
           <p:cNvPr id="3" name="paragraph-1">
             <a:extLst xmlns:a="http://schemas.openxmlformats.org/drawingml/2006/main">
               <a:ext uri="{FF2B5EF4-FFF2-40B4-BE49-F238E27FC236}">
-                <a16:creationId xmlns:a16="http://schemas.microsoft.com/office/drawing/2014/main" id="{4DE7EB3A-166C-4115-B298-1B58CFF86A3A}"/>
+                <a16:creationId xmlns:a16="http://schemas.microsoft.com/office/drawing/2014/main" id="{6CB47771-8C20-48D2-8041-9C4E863A91BC}"/>
               </a:ext>
             </a:extLst>
           </p:cNvPr>
@@ -8440,7 +8440,7 @@
           <p:cNvPr id="4" name="paragraph-2">
             <a:extLst xmlns:a="http://schemas.openxmlformats.org/drawingml/2006/main">
               <a:ext uri="{FF2B5EF4-FFF2-40B4-BE49-F238E27FC236}">
-                <a16:creationId xmlns:a16="http://schemas.microsoft.com/office/drawing/2014/main" id="{B6638645-0B0E-4780-8FD2-84CBDAD15661}"/>
+                <a16:creationId xmlns:a16="http://schemas.microsoft.com/office/drawing/2014/main" id="{A9A31F17-54B5-4E3E-BBEC-C16BB63BC6CB}"/>
               </a:ext>
             </a:extLst>
           </p:cNvPr>
@@ -8506,7 +8506,7 @@
           <p:cNvPr id="5" name="disclosure">
             <a:extLst xmlns:a="http://schemas.openxmlformats.org/drawingml/2006/main">
               <a:ext uri="{FF2B5EF4-FFF2-40B4-BE49-F238E27FC236}">
-                <a16:creationId xmlns:a16="http://schemas.microsoft.com/office/drawing/2014/main" id="{8C96A5FB-9B80-408A-AD75-4AE8216E5C4D}"/>
+                <a16:creationId xmlns:a16="http://schemas.microsoft.com/office/drawing/2014/main" id="{8C3F7545-1DAE-486B-94B6-86A3905CC3D8}"/>
               </a:ext>
             </a:extLst>
           </p:cNvPr>
@@ -8572,7 +8572,7 @@
           <p:cNvPr id="6" name="page">
             <a:extLst xmlns:a="http://schemas.openxmlformats.org/drawingml/2006/main">
               <a:ext uri="{FF2B5EF4-FFF2-40B4-BE49-F238E27FC236}">
-                <a16:creationId xmlns:a16="http://schemas.microsoft.com/office/drawing/2014/main" id="{3DB48AC5-B95A-47F7-9358-5D6A29E2684B}"/>
+                <a16:creationId xmlns:a16="http://schemas.microsoft.com/office/drawing/2014/main" id="{7B57F6AB-2121-4275-86F1-9BC2C0B09CF2}"/>
               </a:ext>
             </a:extLst>
           </p:cNvPr>
@@ -8636,7 +8636,7 @@
     </p:spTree>
     <p:extLst>
       <p:ext uri="{BB962C8B-B14F-4D97-AF65-F5344CB8AC3E}">
-        <p14:creationId xmlns:p14="http://schemas.microsoft.com/office/powerpoint/2010/main" val="897400902"/>
+        <p14:creationId xmlns:p14="http://schemas.microsoft.com/office/powerpoint/2010/main" val="868135226"/>
       </p:ext>
     </p:extLst>
   </p:cSld>
@@ -8667,7 +8667,7 @@
           <p:cNvPr id="5" name="title">
             <a:extLst xmlns:a="http://schemas.openxmlformats.org/drawingml/2006/main">
               <a:ext uri="{FF2B5EF4-FFF2-40B4-BE49-F238E27FC236}">
-                <a16:creationId xmlns:a16="http://schemas.microsoft.com/office/drawing/2014/main" id="{669A7DC1-B5A0-4D49-B582-75D064C837BA}"/>
+                <a16:creationId xmlns:a16="http://schemas.microsoft.com/office/drawing/2014/main" id="{F9627987-531D-421C-A177-4005D744A731}"/>
               </a:ext>
             </a:extLst>
           </p:cNvPr>
@@ -8733,7 +8733,7 @@
           <p:cNvPr id="2" name="">
             <a:extLst xmlns:a="http://schemas.openxmlformats.org/drawingml/2006/main">
               <a:ext uri="{FF2B5EF4-FFF2-40B4-BE49-F238E27FC236}">
-                <a16:creationId xmlns:a16="http://schemas.microsoft.com/office/drawing/2014/main" id="{427EF926-52C0-4BB5-8965-B13C1AC8C822}"/>
+                <a16:creationId xmlns:a16="http://schemas.microsoft.com/office/drawing/2014/main" id="{D025CB52-CF56-43DA-8AE9-8C81E951AD19}"/>
               </a:ext>
             </a:extLst>
           </p:cNvPr>
@@ -9061,7 +9061,7 @@
           <p:cNvPr id="3" name="disclosure">
             <a:extLst xmlns:a="http://schemas.openxmlformats.org/drawingml/2006/main">
               <a:ext uri="{FF2B5EF4-FFF2-40B4-BE49-F238E27FC236}">
-                <a16:creationId xmlns:a16="http://schemas.microsoft.com/office/drawing/2014/main" id="{5480C5BE-9FD3-4122-805D-6624A9B7D46B}"/>
+                <a16:creationId xmlns:a16="http://schemas.microsoft.com/office/drawing/2014/main" id="{F50CCBA7-B519-4545-B7F8-DBAE3FA27B1C}"/>
               </a:ext>
             </a:extLst>
           </p:cNvPr>
@@ -9127,7 +9127,7 @@
           <p:cNvPr id="4" name="page">
             <a:extLst xmlns:a="http://schemas.openxmlformats.org/drawingml/2006/main">
               <a:ext uri="{FF2B5EF4-FFF2-40B4-BE49-F238E27FC236}">
-                <a16:creationId xmlns:a16="http://schemas.microsoft.com/office/drawing/2014/main" id="{0F9E9882-718E-4F98-9D94-D17CE7BEE967}"/>
+                <a16:creationId xmlns:a16="http://schemas.microsoft.com/office/drawing/2014/main" id="{410E11F3-4D41-4F62-A20F-6CFD20C963F6}"/>
               </a:ext>
             </a:extLst>
           </p:cNvPr>
@@ -9191,7 +9191,7 @@
     </p:spTree>
     <p:extLst>
       <p:ext uri="{BB962C8B-B14F-4D97-AF65-F5344CB8AC3E}">
-        <p14:creationId xmlns:p14="http://schemas.microsoft.com/office/powerpoint/2010/main" val="19090557"/>
+        <p14:creationId xmlns:p14="http://schemas.microsoft.com/office/powerpoint/2010/main" val="1867979891"/>
       </p:ext>
     </p:extLst>
   </p:cSld>
@@ -9222,7 +9222,7 @@
           <p:cNvPr id="6" name="title">
             <a:extLst xmlns:a="http://schemas.openxmlformats.org/drawingml/2006/main">
               <a:ext uri="{FF2B5EF4-FFF2-40B4-BE49-F238E27FC236}">
-                <a16:creationId xmlns:a16="http://schemas.microsoft.com/office/drawing/2014/main" id="{7FD54F32-A00D-4584-A1E9-DCBFD8BB2A83}"/>
+                <a16:creationId xmlns:a16="http://schemas.microsoft.com/office/drawing/2014/main" id="{5C051568-C577-40CC-9294-88983617A038}"/>
               </a:ext>
             </a:extLst>
           </p:cNvPr>
@@ -9288,7 +9288,7 @@
           <p:cNvPr id="2" name="paragraph-0">
             <a:extLst xmlns:a="http://schemas.openxmlformats.org/drawingml/2006/main">
               <a:ext uri="{FF2B5EF4-FFF2-40B4-BE49-F238E27FC236}">
-                <a16:creationId xmlns:a16="http://schemas.microsoft.com/office/drawing/2014/main" id="{AB4366F3-1342-4E52-B256-D8E74F181706}"/>
+                <a16:creationId xmlns:a16="http://schemas.microsoft.com/office/drawing/2014/main" id="{3C1BFE94-B9D1-48FD-9509-CACABDDDF94A}"/>
               </a:ext>
             </a:extLst>
           </p:cNvPr>
@@ -9354,7 +9354,7 @@
           <p:cNvPr id="3" name="paragraph-1">
             <a:extLst xmlns:a="http://schemas.openxmlformats.org/drawingml/2006/main">
               <a:ext uri="{FF2B5EF4-FFF2-40B4-BE49-F238E27FC236}">
-                <a16:creationId xmlns:a16="http://schemas.microsoft.com/office/drawing/2014/main" id="{67A8F810-5E09-419F-8AEB-21C681C08B79}"/>
+                <a16:creationId xmlns:a16="http://schemas.microsoft.com/office/drawing/2014/main" id="{04A191F2-10EC-443E-953E-E83C6A9A37F3}"/>
               </a:ext>
             </a:extLst>
           </p:cNvPr>
@@ -9420,7 +9420,7 @@
           <p:cNvPr id="4" name="disclosure">
             <a:extLst xmlns:a="http://schemas.openxmlformats.org/drawingml/2006/main">
               <a:ext uri="{FF2B5EF4-FFF2-40B4-BE49-F238E27FC236}">
-                <a16:creationId xmlns:a16="http://schemas.microsoft.com/office/drawing/2014/main" id="{F6B7288F-FEAF-407A-8403-20C39CBA354F}"/>
+                <a16:creationId xmlns:a16="http://schemas.microsoft.com/office/drawing/2014/main" id="{13AE2923-79E1-409A-928B-1CCED60C01F0}"/>
               </a:ext>
             </a:extLst>
           </p:cNvPr>
@@ -9486,7 +9486,7 @@
           <p:cNvPr id="5" name="page">
             <a:extLst xmlns:a="http://schemas.openxmlformats.org/drawingml/2006/main">
               <a:ext uri="{FF2B5EF4-FFF2-40B4-BE49-F238E27FC236}">
-                <a16:creationId xmlns:a16="http://schemas.microsoft.com/office/drawing/2014/main" id="{69F0B6BD-33EF-45AB-89CA-555E1102DC96}"/>
+                <a16:creationId xmlns:a16="http://schemas.microsoft.com/office/drawing/2014/main" id="{0EB5D30B-BA05-41A5-BCC2-F21C19F3E90A}"/>
               </a:ext>
             </a:extLst>
           </p:cNvPr>
@@ -9550,7 +9550,7 @@
     </p:spTree>
     <p:extLst>
       <p:ext uri="{BB962C8B-B14F-4D97-AF65-F5344CB8AC3E}">
-        <p14:creationId xmlns:p14="http://schemas.microsoft.com/office/powerpoint/2010/main" val="2019981909"/>
+        <p14:creationId xmlns:p14="http://schemas.microsoft.com/office/powerpoint/2010/main" val="2104267900"/>
       </p:ext>
     </p:extLst>
   </p:cSld>
@@ -9581,7 +9581,7 @@
           <p:cNvPr id="6" name="title">
             <a:extLst xmlns:a="http://schemas.openxmlformats.org/drawingml/2006/main">
               <a:ext uri="{FF2B5EF4-FFF2-40B4-BE49-F238E27FC236}">
-                <a16:creationId xmlns:a16="http://schemas.microsoft.com/office/drawing/2014/main" id="{579E38E3-A108-45B8-A035-83A602E1B9BC}"/>
+                <a16:creationId xmlns:a16="http://schemas.microsoft.com/office/drawing/2014/main" id="{EF2141E8-7163-447B-B612-5A913614E114}"/>
               </a:ext>
             </a:extLst>
           </p:cNvPr>
@@ -9647,7 +9647,7 @@
           <p:cNvPr id="2" name="paragraph-0">
             <a:extLst xmlns:a="http://schemas.openxmlformats.org/drawingml/2006/main">
               <a:ext uri="{FF2B5EF4-FFF2-40B4-BE49-F238E27FC236}">
-                <a16:creationId xmlns:a16="http://schemas.microsoft.com/office/drawing/2014/main" id="{1568C293-A407-4AD1-A2BC-23CA9125CF7B}"/>
+                <a16:creationId xmlns:a16="http://schemas.microsoft.com/office/drawing/2014/main" id="{42182328-A21C-4B4F-BFD6-BC5384DD7A07}"/>
               </a:ext>
             </a:extLst>
           </p:cNvPr>
@@ -9713,7 +9713,7 @@
           <p:cNvPr id="3" name="paragraph-1">
             <a:extLst xmlns:a="http://schemas.openxmlformats.org/drawingml/2006/main">
               <a:ext uri="{FF2B5EF4-FFF2-40B4-BE49-F238E27FC236}">
-                <a16:creationId xmlns:a16="http://schemas.microsoft.com/office/drawing/2014/main" id="{993D1FB9-E7B7-466D-B5AF-B03C50E4C348}"/>
+                <a16:creationId xmlns:a16="http://schemas.microsoft.com/office/drawing/2014/main" id="{7E14474F-74B0-4FEF-97C7-FB8C1DC96A8B}"/>
               </a:ext>
             </a:extLst>
           </p:cNvPr>
@@ -9779,7 +9779,7 @@
           <p:cNvPr id="4" name="disclosure">
             <a:extLst xmlns:a="http://schemas.openxmlformats.org/drawingml/2006/main">
               <a:ext uri="{FF2B5EF4-FFF2-40B4-BE49-F238E27FC236}">
-                <a16:creationId xmlns:a16="http://schemas.microsoft.com/office/drawing/2014/main" id="{217398C3-F60E-4E74-89A1-8EFD9A8F227C}"/>
+                <a16:creationId xmlns:a16="http://schemas.microsoft.com/office/drawing/2014/main" id="{F0BB4B32-00B8-4CCC-AC16-B4F70BE3E45D}"/>
               </a:ext>
             </a:extLst>
           </p:cNvPr>
@@ -9845,7 +9845,7 @@
           <p:cNvPr id="5" name="page">
             <a:extLst xmlns:a="http://schemas.openxmlformats.org/drawingml/2006/main">
               <a:ext uri="{FF2B5EF4-FFF2-40B4-BE49-F238E27FC236}">
-                <a16:creationId xmlns:a16="http://schemas.microsoft.com/office/drawing/2014/main" id="{673B7D84-9AC0-4756-82A4-38402C9A7D17}"/>
+                <a16:creationId xmlns:a16="http://schemas.microsoft.com/office/drawing/2014/main" id="{EAB70EF7-6F90-4D72-BFC2-B3AEE65E7268}"/>
               </a:ext>
             </a:extLst>
           </p:cNvPr>
@@ -9909,7 +9909,7 @@
     </p:spTree>
     <p:extLst>
       <p:ext uri="{BB962C8B-B14F-4D97-AF65-F5344CB8AC3E}">
-        <p14:creationId xmlns:p14="http://schemas.microsoft.com/office/powerpoint/2010/main" val="159262944"/>
+        <p14:creationId xmlns:p14="http://schemas.microsoft.com/office/powerpoint/2010/main" val="967767638"/>
       </p:ext>
     </p:extLst>
   </p:cSld>
@@ -9940,7 +9940,7 @@
           <p:cNvPr id="6" name="title">
             <a:extLst xmlns:a="http://schemas.openxmlformats.org/drawingml/2006/main">
               <a:ext uri="{FF2B5EF4-FFF2-40B4-BE49-F238E27FC236}">
-                <a16:creationId xmlns:a16="http://schemas.microsoft.com/office/drawing/2014/main" id="{F9A432E4-40E6-43BF-9D18-D9F4148573A3}"/>
+                <a16:creationId xmlns:a16="http://schemas.microsoft.com/office/drawing/2014/main" id="{64D1DA3A-B01C-4660-9376-6C9A3A09585F}"/>
               </a:ext>
             </a:extLst>
           </p:cNvPr>
@@ -10006,7 +10006,7 @@
           <p:cNvPr id="2" name="paragraph-0">
             <a:extLst xmlns:a="http://schemas.openxmlformats.org/drawingml/2006/main">
               <a:ext uri="{FF2B5EF4-FFF2-40B4-BE49-F238E27FC236}">
-                <a16:creationId xmlns:a16="http://schemas.microsoft.com/office/drawing/2014/main" id="{955418C7-BE98-42B1-A0F2-C0D4D9698B40}"/>
+                <a16:creationId xmlns:a16="http://schemas.microsoft.com/office/drawing/2014/main" id="{2D75815E-9039-4B1F-B78B-2FD4F3A40F7A}"/>
               </a:ext>
             </a:extLst>
           </p:cNvPr>
@@ -10072,7 +10072,7 @@
           <p:cNvPr id="3" name="paragraph-1">
             <a:extLst xmlns:a="http://schemas.openxmlformats.org/drawingml/2006/main">
               <a:ext uri="{FF2B5EF4-FFF2-40B4-BE49-F238E27FC236}">
-                <a16:creationId xmlns:a16="http://schemas.microsoft.com/office/drawing/2014/main" id="{5A05D914-AD5D-4CFE-AA65-6093919A5849}"/>
+                <a16:creationId xmlns:a16="http://schemas.microsoft.com/office/drawing/2014/main" id="{10A5D74E-D45D-480F-B1AF-AF8076574FCA}"/>
               </a:ext>
             </a:extLst>
           </p:cNvPr>
@@ -10138,7 +10138,7 @@
           <p:cNvPr id="4" name="disclosure">
             <a:extLst xmlns:a="http://schemas.openxmlformats.org/drawingml/2006/main">
               <a:ext uri="{FF2B5EF4-FFF2-40B4-BE49-F238E27FC236}">
-                <a16:creationId xmlns:a16="http://schemas.microsoft.com/office/drawing/2014/main" id="{D5560295-CCC0-410A-9279-40A1A0943729}"/>
+                <a16:creationId xmlns:a16="http://schemas.microsoft.com/office/drawing/2014/main" id="{E9E6902B-F6FE-4662-B1B2-DACAD8A17D92}"/>
               </a:ext>
             </a:extLst>
           </p:cNvPr>
@@ -10204,7 +10204,7 @@
           <p:cNvPr id="5" name="page">
             <a:extLst xmlns:a="http://schemas.openxmlformats.org/drawingml/2006/main">
               <a:ext uri="{FF2B5EF4-FFF2-40B4-BE49-F238E27FC236}">
-                <a16:creationId xmlns:a16="http://schemas.microsoft.com/office/drawing/2014/main" id="{F3E9731A-A04D-4C3F-8F78-CB2DE20ECB33}"/>
+                <a16:creationId xmlns:a16="http://schemas.microsoft.com/office/drawing/2014/main" id="{6234D84C-8DCB-4F11-B795-20CA2C0886DC}"/>
               </a:ext>
             </a:extLst>
           </p:cNvPr>
@@ -10268,7 +10268,7 @@
     </p:spTree>
     <p:extLst>
       <p:ext uri="{BB962C8B-B14F-4D97-AF65-F5344CB8AC3E}">
-        <p14:creationId xmlns:p14="http://schemas.microsoft.com/office/powerpoint/2010/main" val="2130989574"/>
+        <p14:creationId xmlns:p14="http://schemas.microsoft.com/office/powerpoint/2010/main" val="402397853"/>
       </p:ext>
     </p:extLst>
   </p:cSld>
@@ -10299,7 +10299,7 @@
           <p:cNvPr id="6" name="title">
             <a:extLst xmlns:a="http://schemas.openxmlformats.org/drawingml/2006/main">
               <a:ext uri="{FF2B5EF4-FFF2-40B4-BE49-F238E27FC236}">
-                <a16:creationId xmlns:a16="http://schemas.microsoft.com/office/drawing/2014/main" id="{CEAD0A74-B777-476E-8AAF-D8ECED1FA147}"/>
+                <a16:creationId xmlns:a16="http://schemas.microsoft.com/office/drawing/2014/main" id="{7803692B-CB12-4A44-8782-776A8FCCFBAF}"/>
               </a:ext>
             </a:extLst>
           </p:cNvPr>
@@ -10365,7 +10365,7 @@
           <p:cNvPr id="2" name="paragraph-0">
             <a:extLst xmlns:a="http://schemas.openxmlformats.org/drawingml/2006/main">
               <a:ext uri="{FF2B5EF4-FFF2-40B4-BE49-F238E27FC236}">
-                <a16:creationId xmlns:a16="http://schemas.microsoft.com/office/drawing/2014/main" id="{72ADD7FB-B8FC-4F90-9912-870E88323C27}"/>
+                <a16:creationId xmlns:a16="http://schemas.microsoft.com/office/drawing/2014/main" id="{FFD0F9A2-6859-4494-9656-9FCF8D930C84}"/>
               </a:ext>
             </a:extLst>
           </p:cNvPr>
@@ -10431,7 +10431,7 @@
           <p:cNvPr id="3" name="paragraph-1">
             <a:extLst xmlns:a="http://schemas.openxmlformats.org/drawingml/2006/main">
               <a:ext uri="{FF2B5EF4-FFF2-40B4-BE49-F238E27FC236}">
-                <a16:creationId xmlns:a16="http://schemas.microsoft.com/office/drawing/2014/main" id="{FBBA10A3-DAEE-4769-8965-56A09A4F7C4A}"/>
+                <a16:creationId xmlns:a16="http://schemas.microsoft.com/office/drawing/2014/main" id="{0C2F2BC6-AFD1-473C-B162-57A9AF68BF83}"/>
               </a:ext>
             </a:extLst>
           </p:cNvPr>
@@ -10497,7 +10497,7 @@
           <p:cNvPr id="4" name="disclosure">
             <a:extLst xmlns:a="http://schemas.openxmlformats.org/drawingml/2006/main">
               <a:ext uri="{FF2B5EF4-FFF2-40B4-BE49-F238E27FC236}">
-                <a16:creationId xmlns:a16="http://schemas.microsoft.com/office/drawing/2014/main" id="{2B187E89-56D3-41E4-A61E-0CA6C0B2620B}"/>
+                <a16:creationId xmlns:a16="http://schemas.microsoft.com/office/drawing/2014/main" id="{FDE0C100-CD68-4D2F-97B4-30EAF5AD887F}"/>
               </a:ext>
             </a:extLst>
           </p:cNvPr>
@@ -10563,7 +10563,7 @@
           <p:cNvPr id="5" name="page">
             <a:extLst xmlns:a="http://schemas.openxmlformats.org/drawingml/2006/main">
               <a:ext uri="{FF2B5EF4-FFF2-40B4-BE49-F238E27FC236}">
-                <a16:creationId xmlns:a16="http://schemas.microsoft.com/office/drawing/2014/main" id="{5020292B-5E8F-4C4F-8698-5E1ABC01E745}"/>
+                <a16:creationId xmlns:a16="http://schemas.microsoft.com/office/drawing/2014/main" id="{9B488156-5258-42C4-BAAA-1C6086CEEC97}"/>
               </a:ext>
             </a:extLst>
           </p:cNvPr>
@@ -10627,7 +10627,7 @@
     </p:spTree>
     <p:extLst>
       <p:ext uri="{BB962C8B-B14F-4D97-AF65-F5344CB8AC3E}">
-        <p14:creationId xmlns:p14="http://schemas.microsoft.com/office/powerpoint/2010/main" val="277333689"/>
+        <p14:creationId xmlns:p14="http://schemas.microsoft.com/office/powerpoint/2010/main" val="158332202"/>
       </p:ext>
     </p:extLst>
   </p:cSld>
@@ -10658,7 +10658,7 @@
           <p:cNvPr id="6" name="title">
             <a:extLst xmlns:a="http://schemas.openxmlformats.org/drawingml/2006/main">
               <a:ext uri="{FF2B5EF4-FFF2-40B4-BE49-F238E27FC236}">
-                <a16:creationId xmlns:a16="http://schemas.microsoft.com/office/drawing/2014/main" id="{A1795132-E447-49AE-813E-E046D0597186}"/>
+                <a16:creationId xmlns:a16="http://schemas.microsoft.com/office/drawing/2014/main" id="{6739CEBE-FEB7-4F9C-8516-3CA60971F7A8}"/>
               </a:ext>
             </a:extLst>
           </p:cNvPr>
@@ -10724,7 +10724,7 @@
           <p:cNvPr id="2" name="paragraph-0">
             <a:extLst xmlns:a="http://schemas.openxmlformats.org/drawingml/2006/main">
               <a:ext uri="{FF2B5EF4-FFF2-40B4-BE49-F238E27FC236}">
-                <a16:creationId xmlns:a16="http://schemas.microsoft.com/office/drawing/2014/main" id="{E393812D-F883-408E-B585-C52497DCD157}"/>
+                <a16:creationId xmlns:a16="http://schemas.microsoft.com/office/drawing/2014/main" id="{E17C1B41-4613-44C0-AA1D-16F1802BEAFC}"/>
               </a:ext>
             </a:extLst>
           </p:cNvPr>
@@ -10790,7 +10790,7 @@
           <p:cNvPr id="3" name="paragraph-1">
             <a:extLst xmlns:a="http://schemas.openxmlformats.org/drawingml/2006/main">
               <a:ext uri="{FF2B5EF4-FFF2-40B4-BE49-F238E27FC236}">
-                <a16:creationId xmlns:a16="http://schemas.microsoft.com/office/drawing/2014/main" id="{1A9871DA-76B3-498C-9893-042EFAA6A0D4}"/>
+                <a16:creationId xmlns:a16="http://schemas.microsoft.com/office/drawing/2014/main" id="{D116EBC7-6E33-4A7C-9FC2-8F81E5387BA5}"/>
               </a:ext>
             </a:extLst>
           </p:cNvPr>
@@ -10856,7 +10856,7 @@
           <p:cNvPr id="4" name="disclosure">
             <a:extLst xmlns:a="http://schemas.openxmlformats.org/drawingml/2006/main">
               <a:ext uri="{FF2B5EF4-FFF2-40B4-BE49-F238E27FC236}">
-                <a16:creationId xmlns:a16="http://schemas.microsoft.com/office/drawing/2014/main" id="{81F6E2DA-76E7-4B2F-9740-E5C8759621FF}"/>
+                <a16:creationId xmlns:a16="http://schemas.microsoft.com/office/drawing/2014/main" id="{4DDF73D3-3239-4AAA-826A-3BD57EDFEFC1}"/>
               </a:ext>
             </a:extLst>
           </p:cNvPr>
@@ -10922,7 +10922,7 @@
           <p:cNvPr id="5" name="page">
             <a:extLst xmlns:a="http://schemas.openxmlformats.org/drawingml/2006/main">
               <a:ext uri="{FF2B5EF4-FFF2-40B4-BE49-F238E27FC236}">
-                <a16:creationId xmlns:a16="http://schemas.microsoft.com/office/drawing/2014/main" id="{A4D0E81B-EBF1-4505-A83D-905BDFEF812C}"/>
+                <a16:creationId xmlns:a16="http://schemas.microsoft.com/office/drawing/2014/main" id="{00DF35E9-B97A-4E85-8F22-AFBA9EC8010C}"/>
               </a:ext>
             </a:extLst>
           </p:cNvPr>
@@ -10986,7 +10986,7 @@
     </p:spTree>
     <p:extLst>
       <p:ext uri="{BB962C8B-B14F-4D97-AF65-F5344CB8AC3E}">
-        <p14:creationId xmlns:p14="http://schemas.microsoft.com/office/powerpoint/2010/main" val="38109659"/>
+        <p14:creationId xmlns:p14="http://schemas.microsoft.com/office/powerpoint/2010/main" val="377406481"/>
       </p:ext>
     </p:extLst>
   </p:cSld>
@@ -11017,7 +11017,7 @@
           <p:cNvPr id="6" name="title">
             <a:extLst xmlns:a="http://schemas.openxmlformats.org/drawingml/2006/main">
               <a:ext uri="{FF2B5EF4-FFF2-40B4-BE49-F238E27FC236}">
-                <a16:creationId xmlns:a16="http://schemas.microsoft.com/office/drawing/2014/main" id="{AFDB65CC-1784-4D50-AA2F-838D24267FB0}"/>
+                <a16:creationId xmlns:a16="http://schemas.microsoft.com/office/drawing/2014/main" id="{7FF79744-3DAE-4EE9-B06D-B38C4209A98F}"/>
               </a:ext>
             </a:extLst>
           </p:cNvPr>
@@ -11083,7 +11083,7 @@
           <p:cNvPr id="2" name="paragraph-0">
             <a:extLst xmlns:a="http://schemas.openxmlformats.org/drawingml/2006/main">
               <a:ext uri="{FF2B5EF4-FFF2-40B4-BE49-F238E27FC236}">
-                <a16:creationId xmlns:a16="http://schemas.microsoft.com/office/drawing/2014/main" id="{9FE5F0DD-7DE0-4C28-80CC-50EB6827FA84}"/>
+                <a16:creationId xmlns:a16="http://schemas.microsoft.com/office/drawing/2014/main" id="{8A3EB54F-D8D8-460E-8289-28D3D426D488}"/>
               </a:ext>
             </a:extLst>
           </p:cNvPr>
@@ -11149,7 +11149,7 @@
           <p:cNvPr id="3" name="paragraph-1">
             <a:extLst xmlns:a="http://schemas.openxmlformats.org/drawingml/2006/main">
               <a:ext uri="{FF2B5EF4-FFF2-40B4-BE49-F238E27FC236}">
-                <a16:creationId xmlns:a16="http://schemas.microsoft.com/office/drawing/2014/main" id="{2EAA495C-596B-4664-9506-075A4F4FAEC6}"/>
+                <a16:creationId xmlns:a16="http://schemas.microsoft.com/office/drawing/2014/main" id="{4E66DD04-0EB5-46A5-B5CC-F9429D554CC8}"/>
               </a:ext>
             </a:extLst>
           </p:cNvPr>
@@ -11215,7 +11215,7 @@
           <p:cNvPr id="4" name="disclosure">
             <a:extLst xmlns:a="http://schemas.openxmlformats.org/drawingml/2006/main">
               <a:ext uri="{FF2B5EF4-FFF2-40B4-BE49-F238E27FC236}">
-                <a16:creationId xmlns:a16="http://schemas.microsoft.com/office/drawing/2014/main" id="{09E69907-75CB-49E1-AC26-C4164B72F5BD}"/>
+                <a16:creationId xmlns:a16="http://schemas.microsoft.com/office/drawing/2014/main" id="{FC1310BD-6168-4427-96B5-84A7C1DFBA62}"/>
               </a:ext>
             </a:extLst>
           </p:cNvPr>
@@ -11281,7 +11281,7 @@
           <p:cNvPr id="5" name="page">
             <a:extLst xmlns:a="http://schemas.openxmlformats.org/drawingml/2006/main">
               <a:ext uri="{FF2B5EF4-FFF2-40B4-BE49-F238E27FC236}">
-                <a16:creationId xmlns:a16="http://schemas.microsoft.com/office/drawing/2014/main" id="{E51F2FD3-B3AE-44CC-94E2-5E991F19F373}"/>
+                <a16:creationId xmlns:a16="http://schemas.microsoft.com/office/drawing/2014/main" id="{36B5E9D7-B39E-474C-B7E4-C6C776DFF1D5}"/>
               </a:ext>
             </a:extLst>
           </p:cNvPr>
@@ -11345,7 +11345,7 @@
     </p:spTree>
     <p:extLst>
       <p:ext uri="{BB962C8B-B14F-4D97-AF65-F5344CB8AC3E}">
-        <p14:creationId xmlns:p14="http://schemas.microsoft.com/office/powerpoint/2010/main" val="2130686679"/>
+        <p14:creationId xmlns:p14="http://schemas.microsoft.com/office/powerpoint/2010/main" val="498000133"/>
       </p:ext>
     </p:extLst>
   </p:cSld>
@@ -11376,7 +11376,7 @@
           <p:cNvPr id="6" name="title">
             <a:extLst xmlns:a="http://schemas.openxmlformats.org/drawingml/2006/main">
               <a:ext uri="{FF2B5EF4-FFF2-40B4-BE49-F238E27FC236}">
-                <a16:creationId xmlns:a16="http://schemas.microsoft.com/office/drawing/2014/main" id="{478A7DB1-46A5-4DF6-8B3C-5319D7775A74}"/>
+                <a16:creationId xmlns:a16="http://schemas.microsoft.com/office/drawing/2014/main" id="{5808B7F0-E13D-48B8-870A-8C62A73B60E9}"/>
               </a:ext>
             </a:extLst>
           </p:cNvPr>
@@ -11442,7 +11442,7 @@
           <p:cNvPr id="2" name="paragraph-0">
             <a:extLst xmlns:a="http://schemas.openxmlformats.org/drawingml/2006/main">
               <a:ext uri="{FF2B5EF4-FFF2-40B4-BE49-F238E27FC236}">
-                <a16:creationId xmlns:a16="http://schemas.microsoft.com/office/drawing/2014/main" id="{5A2CE6BA-9BF8-4A33-B361-E7CE19497646}"/>
+                <a16:creationId xmlns:a16="http://schemas.microsoft.com/office/drawing/2014/main" id="{1ABCE30F-50DB-4BA3-A047-1A2B60854A2C}"/>
               </a:ext>
             </a:extLst>
           </p:cNvPr>
@@ -11508,7 +11508,7 @@
           <p:cNvPr id="3" name="paragraph-1">
             <a:extLst xmlns:a="http://schemas.openxmlformats.org/drawingml/2006/main">
               <a:ext uri="{FF2B5EF4-FFF2-40B4-BE49-F238E27FC236}">
-                <a16:creationId xmlns:a16="http://schemas.microsoft.com/office/drawing/2014/main" id="{BCBE8FAA-B548-4B94-A208-1D8BE8D0D2FA}"/>
+                <a16:creationId xmlns:a16="http://schemas.microsoft.com/office/drawing/2014/main" id="{A25BA201-B2BC-4B1C-BEFF-2E7D68ED8A4F}"/>
               </a:ext>
             </a:extLst>
           </p:cNvPr>
@@ -11574,7 +11574,7 @@
           <p:cNvPr id="4" name="disclosure">
             <a:extLst xmlns:a="http://schemas.openxmlformats.org/drawingml/2006/main">
               <a:ext uri="{FF2B5EF4-FFF2-40B4-BE49-F238E27FC236}">
-                <a16:creationId xmlns:a16="http://schemas.microsoft.com/office/drawing/2014/main" id="{99E92BD5-1894-401F-B81F-A19E1F11C056}"/>
+                <a16:creationId xmlns:a16="http://schemas.microsoft.com/office/drawing/2014/main" id="{581AD79C-C1A5-43DB-AE08-B3644D75243F}"/>
               </a:ext>
             </a:extLst>
           </p:cNvPr>
@@ -11640,7 +11640,7 @@
           <p:cNvPr id="5" name="page">
             <a:extLst xmlns:a="http://schemas.openxmlformats.org/drawingml/2006/main">
               <a:ext uri="{FF2B5EF4-FFF2-40B4-BE49-F238E27FC236}">
-                <a16:creationId xmlns:a16="http://schemas.microsoft.com/office/drawing/2014/main" id="{8AFB401A-020E-49D2-8B59-E3F5AA0D85EC}"/>
+                <a16:creationId xmlns:a16="http://schemas.microsoft.com/office/drawing/2014/main" id="{2CB8E65F-A7E5-4EBE-A463-82102A102040}"/>
               </a:ext>
             </a:extLst>
           </p:cNvPr>
@@ -11704,7 +11704,7 @@
     </p:spTree>
     <p:extLst>
       <p:ext uri="{BB962C8B-B14F-4D97-AF65-F5344CB8AC3E}">
-        <p14:creationId xmlns:p14="http://schemas.microsoft.com/office/powerpoint/2010/main" val="1707423026"/>
+        <p14:creationId xmlns:p14="http://schemas.microsoft.com/office/powerpoint/2010/main" val="847386994"/>
       </p:ext>
     </p:extLst>
   </p:cSld>

</xml_diff>

<commit_message>
docs: refresh merged Observatory briefing status and deck notes
</commit_message>
<xml_diff>
--- a/apps/about/public/briefings/detailed.pptx
+++ b/apps/about/public/briefings/detailed.pptx
@@ -2,30 +2,30 @@
 <file path=ppt/presentation.xml><?xml version="1.0" encoding="utf-8"?>
 <p:presentation xmlns:p="http://schemas.openxmlformats.org/presentationml/2006/main">
   <p:sldMasterIdLst>
-    <p:sldMasterId xmlns:r="http://schemas.openxmlformats.org/officeDocument/2006/relationships" id="2147483648" r:id="Re944dc31679045c5"/>
+    <p:sldMasterId xmlns:r="http://schemas.openxmlformats.org/officeDocument/2006/relationships" id="2147483648" r:id="R60fb468687184df3"/>
   </p:sldMasterIdLst>
   <p:notesMasterIdLst>
-    <p:notesMasterId xmlns:r="http://schemas.openxmlformats.org/officeDocument/2006/relationships" r:id="Rc58a2bb543b14c7f"/>
+    <p:notesMasterId xmlns:r="http://schemas.openxmlformats.org/officeDocument/2006/relationships" r:id="Rda92513671534f08"/>
   </p:notesMasterIdLst>
   <p:sldIdLst>
-    <p:sldId xmlns:r="http://schemas.openxmlformats.org/officeDocument/2006/relationships" id="256" r:id="R6735a13901c44299"/>
-    <p:sldId xmlns:r="http://schemas.openxmlformats.org/officeDocument/2006/relationships" id="257" r:id="R9548e21b3ec54ad1"/>
-    <p:sldId xmlns:r="http://schemas.openxmlformats.org/officeDocument/2006/relationships" id="258" r:id="R6acef588172c45e6"/>
-    <p:sldId xmlns:r="http://schemas.openxmlformats.org/officeDocument/2006/relationships" id="259" r:id="Rf5c8a5e1ebf045ab"/>
-    <p:sldId xmlns:r="http://schemas.openxmlformats.org/officeDocument/2006/relationships" id="260" r:id="Rf218c7a52dea4d48"/>
-    <p:sldId xmlns:r="http://schemas.openxmlformats.org/officeDocument/2006/relationships" id="261" r:id="R8538fa1474b1440b"/>
-    <p:sldId xmlns:r="http://schemas.openxmlformats.org/officeDocument/2006/relationships" id="262" r:id="R4aff35547c874489"/>
-    <p:sldId xmlns:r="http://schemas.openxmlformats.org/officeDocument/2006/relationships" id="263" r:id="Rf8be2dde811c41b1"/>
-    <p:sldId xmlns:r="http://schemas.openxmlformats.org/officeDocument/2006/relationships" id="264" r:id="Ra09ddb8152a7415a"/>
-    <p:sldId xmlns:r="http://schemas.openxmlformats.org/officeDocument/2006/relationships" id="265" r:id="R30544b082a004245"/>
-    <p:sldId xmlns:r="http://schemas.openxmlformats.org/officeDocument/2006/relationships" id="266" r:id="Rc19caeaf7ab84701"/>
-    <p:sldId xmlns:r="http://schemas.openxmlformats.org/officeDocument/2006/relationships" id="267" r:id="R1a93b5e35a474d6f"/>
-    <p:sldId xmlns:r="http://schemas.openxmlformats.org/officeDocument/2006/relationships" id="268" r:id="Rdebed9b021d14475"/>
-    <p:sldId xmlns:r="http://schemas.openxmlformats.org/officeDocument/2006/relationships" id="269" r:id="Rc96f9e6eb50443d2"/>
-    <p:sldId xmlns:r="http://schemas.openxmlformats.org/officeDocument/2006/relationships" id="270" r:id="Rd25554d706c44d3e"/>
-    <p:sldId xmlns:r="http://schemas.openxmlformats.org/officeDocument/2006/relationships" id="271" r:id="R0b5bf189d9e54495"/>
-    <p:sldId xmlns:r="http://schemas.openxmlformats.org/officeDocument/2006/relationships" id="272" r:id="R22c822a0407041c4"/>
-    <p:sldId xmlns:r="http://schemas.openxmlformats.org/officeDocument/2006/relationships" id="273" r:id="R540a4724b4d34257"/>
+    <p:sldId xmlns:r="http://schemas.openxmlformats.org/officeDocument/2006/relationships" id="256" r:id="Ra389df82f5f740e7"/>
+    <p:sldId xmlns:r="http://schemas.openxmlformats.org/officeDocument/2006/relationships" id="257" r:id="R02cb974749474795"/>
+    <p:sldId xmlns:r="http://schemas.openxmlformats.org/officeDocument/2006/relationships" id="258" r:id="R97be84eeb488472d"/>
+    <p:sldId xmlns:r="http://schemas.openxmlformats.org/officeDocument/2006/relationships" id="259" r:id="R6d4b363fd69344c1"/>
+    <p:sldId xmlns:r="http://schemas.openxmlformats.org/officeDocument/2006/relationships" id="260" r:id="R9a1b8edc228f4589"/>
+    <p:sldId xmlns:r="http://schemas.openxmlformats.org/officeDocument/2006/relationships" id="261" r:id="Recc3ffc188934ec4"/>
+    <p:sldId xmlns:r="http://schemas.openxmlformats.org/officeDocument/2006/relationships" id="262" r:id="Reb37a1673c994ac3"/>
+    <p:sldId xmlns:r="http://schemas.openxmlformats.org/officeDocument/2006/relationships" id="263" r:id="R92d62f9013474e3a"/>
+    <p:sldId xmlns:r="http://schemas.openxmlformats.org/officeDocument/2006/relationships" id="264" r:id="R8745a775b5884e5b"/>
+    <p:sldId xmlns:r="http://schemas.openxmlformats.org/officeDocument/2006/relationships" id="265" r:id="R75add45bc7314e58"/>
+    <p:sldId xmlns:r="http://schemas.openxmlformats.org/officeDocument/2006/relationships" id="266" r:id="R8f582fba911a4d0a"/>
+    <p:sldId xmlns:r="http://schemas.openxmlformats.org/officeDocument/2006/relationships" id="267" r:id="R3d39eab22af04eb2"/>
+    <p:sldId xmlns:r="http://schemas.openxmlformats.org/officeDocument/2006/relationships" id="268" r:id="R2e9a7e90e9544c30"/>
+    <p:sldId xmlns:r="http://schemas.openxmlformats.org/officeDocument/2006/relationships" id="269" r:id="R33f8422bef8e4cba"/>
+    <p:sldId xmlns:r="http://schemas.openxmlformats.org/officeDocument/2006/relationships" id="270" r:id="R316e2c6d0da4480a"/>
+    <p:sldId xmlns:r="http://schemas.openxmlformats.org/officeDocument/2006/relationships" id="271" r:id="Rf74e253e58824a52"/>
+    <p:sldId xmlns:r="http://schemas.openxmlformats.org/officeDocument/2006/relationships" id="272" r:id="R4a9281684f984a62"/>
+    <p:sldId xmlns:r="http://schemas.openxmlformats.org/officeDocument/2006/relationships" id="273" r:id="R7642145ef6354dd9"/>
   </p:sldIdLst>
   <p:sldSz cx="12192000" cy="6858000"/>
   <p:notesSz cx="6858000" cy="9144000"/>
@@ -459,7 +459,7 @@
           <a:lstStyle xmlns:a="http://schemas.openxmlformats.org/drawingml/2006/main"/>
           <a:p xmlns:a="http://schemas.openxmlformats.org/drawingml/2006/main">
             <a:r>
-              <a:t>This briefing supports a twenty-five to thirty minute discussion after the concept walkthrough. Choose supporting demonstrations according to the audience's questions. The coverage map identifies what the short demonstration leaves out. The source baseline is main 6b4f389, plus explicitly labelled unmerged Observatory work.</a:t>
+              <a:t>This briefing supports a twenty-five to thirty minute discussion after the concept walkthrough. Choose supporting demonstrations according to the audience's questions. The coverage map identifies what the short demonstration leaves out. The original source baseline is main 6b4f389 plus Observatory review work. PRs 109–110 have since merged; the dated screenshot and evidence still describe their recorded revision.</a:t>
             </a:r>
           </a:p>
           <a:p xmlns:a="http://schemas.openxmlformats.org/drawingml/2006/main">
@@ -489,7 +489,7 @@
           </a:p>
           <a:p xmlns:a="http://schemas.openxmlformats.org/drawingml/2006/main">
             <a:r>
-              <a:t>Prepared 10 October 2026. Main baseline 6b4f3895f246cfe9e274059c57e4dc1ea7989650. Observatory PRs 109–110 unmerged at preparation.</a:t>
+              <a:t>Prepared 10 October 2026. Original preparation baseline 6b4f3895f246cfe9e274059c57e4dc1ea7989650. Status refreshed 10 October 2026: Observatory PRs 109–110 merged. Dated evidence remains at its recorded revision.</a:t>
             </a:r>
           </a:p>
         </p:txBody>
@@ -584,7 +584,7 @@
           </a:p>
           <a:p xmlns:a="http://schemas.openxmlformats.org/drawingml/2006/main">
             <a:r>
-              <a:t>Prepared 10 October 2026. Main baseline 6b4f3895f246cfe9e274059c57e4dc1ea7989650. Observatory PRs 109–110 unmerged at preparation.</a:t>
+              <a:t>Prepared 10 October 2026. Original preparation baseline 6b4f3895f246cfe9e274059c57e4dc1ea7989650. Status refreshed 10 October 2026: Observatory PRs 109–110 merged. Dated evidence remains at its recorded revision.</a:t>
             </a:r>
           </a:p>
         </p:txBody>
@@ -684,7 +684,7 @@
           </a:p>
           <a:p xmlns:a="http://schemas.openxmlformats.org/drawingml/2006/main">
             <a:r>
-              <a:t>Prepared 10 October 2026. Main baseline 6b4f3895f246cfe9e274059c57e4dc1ea7989650. Observatory PRs 109–110 unmerged at preparation.</a:t>
+              <a:t>Prepared 10 October 2026. Original preparation baseline 6b4f3895f246cfe9e274059c57e4dc1ea7989650. Status refreshed 10 October 2026: Observatory PRs 109–110 merged. Dated evidence remains at its recorded revision.</a:t>
             </a:r>
           </a:p>
         </p:txBody>
@@ -784,7 +784,7 @@
           </a:p>
           <a:p xmlns:a="http://schemas.openxmlformats.org/drawingml/2006/main">
             <a:r>
-              <a:t>Prepared 10 October 2026. Main baseline 6b4f3895f246cfe9e274059c57e4dc1ea7989650. Observatory PRs 109–110 unmerged at preparation.</a:t>
+              <a:t>Prepared 10 October 2026. Original preparation baseline 6b4f3895f246cfe9e274059c57e4dc1ea7989650. Status refreshed 10 October 2026: Observatory PRs 109–110 merged. Dated evidence remains at its recorded revision.</a:t>
             </a:r>
           </a:p>
         </p:txBody>
@@ -879,7 +879,7 @@
           </a:p>
           <a:p xmlns:a="http://schemas.openxmlformats.org/drawingml/2006/main">
             <a:r>
-              <a:t>Prepared 10 October 2026. Main baseline 6b4f3895f246cfe9e274059c57e4dc1ea7989650. Observatory PRs 109–110 unmerged at preparation.</a:t>
+              <a:t>Prepared 10 October 2026. Original preparation baseline 6b4f3895f246cfe9e274059c57e4dc1ea7989650. Status refreshed 10 October 2026: Observatory PRs 109–110 merged. Dated evidence remains at its recorded revision.</a:t>
             </a:r>
           </a:p>
         </p:txBody>
@@ -964,12 +964,12 @@
           </a:p>
           <a:p xmlns:a="http://schemas.openxmlformats.org/drawingml/2006/main">
             <a:r>
-              <a:t>Observatory dashboard, PR 110, unmerged at preparation: https://github.com/sighmoan1/govuk-delegate-starter/pull/110</a:t>
-            </a:r>
-          </a:p>
-          <a:p xmlns:a="http://schemas.openxmlformats.org/drawingml/2006/main">
-            <a:r>
-              <a:t>Blind classifier contract, PR 109, unmerged at preparation: https://github.com/sighmoan1/govuk-delegate-starter/pull/109</a:t>
+              <a:t>Observatory dashboard, PR 110, merged: https://github.com/sighmoan1/govuk-delegate-starter/pull/110</a:t>
+            </a:r>
+          </a:p>
+          <a:p xmlns:a="http://schemas.openxmlformats.org/drawingml/2006/main">
+            <a:r>
+              <a:t>Blind classifier contract, PR 109, merged: https://github.com/sighmoan1/govuk-delegate-starter/pull/109</a:t>
             </a:r>
           </a:p>
           <a:p xmlns:a="http://schemas.openxmlformats.org/drawingml/2006/main">
@@ -989,7 +989,7 @@
           </a:p>
           <a:p xmlns:a="http://schemas.openxmlformats.org/drawingml/2006/main">
             <a:r>
-              <a:t>Prepared 10 October 2026. Main baseline 6b4f3895f246cfe9e274059c57e4dc1ea7989650. Observatory PRs 109–110 unmerged at preparation.</a:t>
+              <a:t>Prepared 10 October 2026. Original preparation baseline 6b4f3895f246cfe9e274059c57e4dc1ea7989650. Status refreshed 10 October 2026: Observatory PRs 109–110 merged. Dated evidence remains at its recorded revision.</a:t>
             </a:r>
           </a:p>
         </p:txBody>
@@ -1079,7 +1079,7 @@
           </a:p>
           <a:p xmlns:a="http://schemas.openxmlformats.org/drawingml/2006/main">
             <a:r>
-              <a:t>Blind classifier contract, PR 109, unmerged at preparation: https://github.com/sighmoan1/govuk-delegate-starter/pull/109</a:t>
+              <a:t>Blind classifier contract, PR 109, merged: https://github.com/sighmoan1/govuk-delegate-starter/pull/109</a:t>
             </a:r>
           </a:p>
           <a:p xmlns:a="http://schemas.openxmlformats.org/drawingml/2006/main">
@@ -1094,7 +1094,7 @@
           </a:p>
           <a:p xmlns:a="http://schemas.openxmlformats.org/drawingml/2006/main">
             <a:r>
-              <a:t>Prepared 10 October 2026. Main baseline 6b4f3895f246cfe9e274059c57e4dc1ea7989650. Observatory PRs 109–110 unmerged at preparation.</a:t>
+              <a:t>Prepared 10 October 2026. Original preparation baseline 6b4f3895f246cfe9e274059c57e4dc1ea7989650. Status refreshed 10 October 2026: Observatory PRs 109–110 merged. Dated evidence remains at its recorded revision.</a:t>
             </a:r>
           </a:p>
         </p:txBody>
@@ -1194,7 +1194,7 @@
           </a:p>
           <a:p xmlns:a="http://schemas.openxmlformats.org/drawingml/2006/main">
             <a:r>
-              <a:t>Prepared 10 October 2026. Main baseline 6b4f3895f246cfe9e274059c57e4dc1ea7989650. Observatory PRs 109–110 unmerged at preparation.</a:t>
+              <a:t>Prepared 10 October 2026. Original preparation baseline 6b4f3895f246cfe9e274059c57e4dc1ea7989650. Status refreshed 10 October 2026: Observatory PRs 109–110 merged. Dated evidence remains at its recorded revision.</a:t>
             </a:r>
           </a:p>
         </p:txBody>
@@ -1299,7 +1299,7 @@
           </a:p>
           <a:p xmlns:a="http://schemas.openxmlformats.org/drawingml/2006/main">
             <a:r>
-              <a:t>Prepared 10 October 2026. Main baseline 6b4f3895f246cfe9e274059c57e4dc1ea7989650. Observatory PRs 109–110 unmerged at preparation.</a:t>
+              <a:t>Prepared 10 October 2026. Original preparation baseline 6b4f3895f246cfe9e274059c57e4dc1ea7989650. Status refreshed 10 October 2026: Observatory PRs 109–110 merged. Dated evidence remains at its recorded revision.</a:t>
             </a:r>
           </a:p>
         </p:txBody>
@@ -1394,7 +1394,7 @@
           </a:p>
           <a:p xmlns:a="http://schemas.openxmlformats.org/drawingml/2006/main">
             <a:r>
-              <a:t>Prepared 10 October 2026. Main baseline 6b4f3895f246cfe9e274059c57e4dc1ea7989650. Observatory PRs 109–110 unmerged at preparation.</a:t>
+              <a:t>Prepared 10 October 2026. Original preparation baseline 6b4f3895f246cfe9e274059c57e4dc1ea7989650. Status refreshed 10 October 2026: Observatory PRs 109–110 merged. Dated evidence remains at its recorded revision.</a:t>
             </a:r>
           </a:p>
         </p:txBody>
@@ -1494,7 +1494,7 @@
           </a:p>
           <a:p xmlns:a="http://schemas.openxmlformats.org/drawingml/2006/main">
             <a:r>
-              <a:t>Prepared 10 October 2026. Main baseline 6b4f3895f246cfe9e274059c57e4dc1ea7989650. Observatory PRs 109–110 unmerged at preparation.</a:t>
+              <a:t>Prepared 10 October 2026. Original preparation baseline 6b4f3895f246cfe9e274059c57e4dc1ea7989650. Status refreshed 10 October 2026: Observatory PRs 109–110 merged. Dated evidence remains at its recorded revision.</a:t>
             </a:r>
           </a:p>
         </p:txBody>
@@ -1594,7 +1594,7 @@
           </a:p>
           <a:p xmlns:a="http://schemas.openxmlformats.org/drawingml/2006/main">
             <a:r>
-              <a:t>Prepared 10 October 2026. Main baseline 6b4f3895f246cfe9e274059c57e4dc1ea7989650. Observatory PRs 109–110 unmerged at preparation.</a:t>
+              <a:t>Prepared 10 October 2026. Original preparation baseline 6b4f3895f246cfe9e274059c57e4dc1ea7989650. Status refreshed 10 October 2026: Observatory PRs 109–110 merged. Dated evidence remains at its recorded revision.</a:t>
             </a:r>
           </a:p>
         </p:txBody>
@@ -1694,7 +1694,7 @@
           </a:p>
           <a:p xmlns:a="http://schemas.openxmlformats.org/drawingml/2006/main">
             <a:r>
-              <a:t>Prepared 10 October 2026. Main baseline 6b4f3895f246cfe9e274059c57e4dc1ea7989650. Observatory PRs 109–110 unmerged at preparation.</a:t>
+              <a:t>Prepared 10 October 2026. Original preparation baseline 6b4f3895f246cfe9e274059c57e4dc1ea7989650. Status refreshed 10 October 2026: Observatory PRs 109–110 merged. Dated evidence remains at its recorded revision.</a:t>
             </a:r>
           </a:p>
         </p:txBody>
@@ -1789,7 +1789,7 @@
           </a:p>
           <a:p xmlns:a="http://schemas.openxmlformats.org/drawingml/2006/main">
             <a:r>
-              <a:t>Prepared 10 October 2026. Main baseline 6b4f3895f246cfe9e274059c57e4dc1ea7989650. Observatory PRs 109–110 unmerged at preparation.</a:t>
+              <a:t>Prepared 10 October 2026. Original preparation baseline 6b4f3895f246cfe9e274059c57e4dc1ea7989650. Status refreshed 10 October 2026: Observatory PRs 109–110 merged. Dated evidence remains at its recorded revision.</a:t>
             </a:r>
           </a:p>
         </p:txBody>
@@ -1894,7 +1894,7 @@
           </a:p>
           <a:p xmlns:a="http://schemas.openxmlformats.org/drawingml/2006/main">
             <a:r>
-              <a:t>Prepared 10 October 2026. Main baseline 6b4f3895f246cfe9e274059c57e4dc1ea7989650. Observatory PRs 109–110 unmerged at preparation.</a:t>
+              <a:t>Prepared 10 October 2026. Original preparation baseline 6b4f3895f246cfe9e274059c57e4dc1ea7989650. Status refreshed 10 October 2026: Observatory PRs 109–110 merged. Dated evidence remains at its recorded revision.</a:t>
             </a:r>
           </a:p>
         </p:txBody>
@@ -1999,7 +1999,7 @@
           </a:p>
           <a:p xmlns:a="http://schemas.openxmlformats.org/drawingml/2006/main">
             <a:r>
-              <a:t>Prepared 10 October 2026. Main baseline 6b4f3895f246cfe9e274059c57e4dc1ea7989650. Observatory PRs 109–110 unmerged at preparation.</a:t>
+              <a:t>Prepared 10 October 2026. Original preparation baseline 6b4f3895f246cfe9e274059c57e4dc1ea7989650. Status refreshed 10 October 2026: Observatory PRs 109–110 merged. Dated evidence remains at its recorded revision.</a:t>
             </a:r>
           </a:p>
         </p:txBody>
@@ -2099,7 +2099,7 @@
           </a:p>
           <a:p xmlns:a="http://schemas.openxmlformats.org/drawingml/2006/main">
             <a:r>
-              <a:t>Prepared 10 October 2026. Main baseline 6b4f3895f246cfe9e274059c57e4dc1ea7989650. Observatory PRs 109–110 unmerged at preparation.</a:t>
+              <a:t>Prepared 10 October 2026. Original preparation baseline 6b4f3895f246cfe9e274059c57e4dc1ea7989650. Status refreshed 10 October 2026: Observatory PRs 109–110 merged. Dated evidence remains at its recorded revision.</a:t>
             </a:r>
           </a:p>
         </p:txBody>
@@ -2194,7 +2194,7 @@
           </a:p>
           <a:p xmlns:a="http://schemas.openxmlformats.org/drawingml/2006/main">
             <a:r>
-              <a:t>Prepared 10 October 2026. Main baseline 6b4f3895f246cfe9e274059c57e4dc1ea7989650. Observatory PRs 109–110 unmerged at preparation.</a:t>
+              <a:t>Prepared 10 October 2026. Original preparation baseline 6b4f3895f246cfe9e274059c57e4dc1ea7989650. Status refreshed 10 October 2026: Observatory PRs 109–110 merged. Dated evidence remains at its recorded revision.</a:t>
             </a:r>
           </a:p>
         </p:txBody>
@@ -2241,7 +2241,7 @@
           <p:cNvPr id="3" name="Title">
             <a:extLst xmlns:a="http://schemas.openxmlformats.org/drawingml/2006/main">
               <a:ext uri="{FF2B5EF4-FFF2-40B4-BE49-F238E27FC236}">
-                <a16:creationId xmlns:a16="http://schemas.microsoft.com/office/drawing/2014/main" id="{68C17EAC-16B1-496A-9E2B-F5A5D78A72DB}"/>
+                <a16:creationId xmlns:a16="http://schemas.microsoft.com/office/drawing/2014/main" id="{850386D7-9FA5-4FEE-AB8A-2273713E68EF}"/>
               </a:ext>
             </a:extLst>
           </p:cNvPr>
@@ -2398,7 +2398,7 @@
           <p:cNvPr id="2" name="Subtitle">
             <a:extLst xmlns:a="http://schemas.openxmlformats.org/drawingml/2006/main">
               <a:ext uri="{FF2B5EF4-FFF2-40B4-BE49-F238E27FC236}">
-                <a16:creationId xmlns:a16="http://schemas.microsoft.com/office/drawing/2014/main" id="{F5481D1A-3FB3-49DB-9E46-E0C264C15E1C}"/>
+                <a16:creationId xmlns:a16="http://schemas.microsoft.com/office/drawing/2014/main" id="{40344113-ED63-40CE-A44D-F787BB711A7B}"/>
               </a:ext>
             </a:extLst>
           </p:cNvPr>
@@ -2572,7 +2572,7 @@
           <p:cNvPr id="2" name="Section title">
             <a:extLst xmlns:a="http://schemas.openxmlformats.org/drawingml/2006/main">
               <a:ext uri="{FF2B5EF4-FFF2-40B4-BE49-F238E27FC236}">
-                <a16:creationId xmlns:a16="http://schemas.microsoft.com/office/drawing/2014/main" id="{A88597B4-1F4B-4EF1-9263-BD11AB294B34}"/>
+                <a16:creationId xmlns:a16="http://schemas.microsoft.com/office/drawing/2014/main" id="{A89EF8BC-E2F8-477A-B04C-383E6BFC57AE}"/>
               </a:ext>
             </a:extLst>
           </p:cNvPr>
@@ -2746,7 +2746,7 @@
           <p:cNvPr id="3" name="Title">
             <a:extLst xmlns:a="http://schemas.openxmlformats.org/drawingml/2006/main">
               <a:ext uri="{FF2B5EF4-FFF2-40B4-BE49-F238E27FC236}">
-                <a16:creationId xmlns:a16="http://schemas.microsoft.com/office/drawing/2014/main" id="{35E637B2-8FE5-4B79-8796-B2EC10C951FD}"/>
+                <a16:creationId xmlns:a16="http://schemas.microsoft.com/office/drawing/2014/main" id="{53508C06-C3DF-4BC0-B74E-73B72F167C8E}"/>
               </a:ext>
             </a:extLst>
           </p:cNvPr>
@@ -2903,7 +2903,7 @@
           <p:cNvPr id="2" name="Body">
             <a:extLst xmlns:a="http://schemas.openxmlformats.org/drawingml/2006/main">
               <a:ext uri="{FF2B5EF4-FFF2-40B4-BE49-F238E27FC236}">
-                <a16:creationId xmlns:a16="http://schemas.microsoft.com/office/drawing/2014/main" id="{3F4A2870-568C-4A4F-9267-54F3B05E27FF}"/>
+                <a16:creationId xmlns:a16="http://schemas.microsoft.com/office/drawing/2014/main" id="{0B4FE41C-000B-4FE4-B86B-D5C1A510F6A0}"/>
               </a:ext>
             </a:extLst>
           </p:cNvPr>
@@ -3077,7 +3077,7 @@
           <p:cNvPr id="4" name="Title">
             <a:extLst xmlns:a="http://schemas.openxmlformats.org/drawingml/2006/main">
               <a:ext uri="{FF2B5EF4-FFF2-40B4-BE49-F238E27FC236}">
-                <a16:creationId xmlns:a16="http://schemas.microsoft.com/office/drawing/2014/main" id="{E7E48DD3-7149-4B60-9D7B-1C180421E938}"/>
+                <a16:creationId xmlns:a16="http://schemas.microsoft.com/office/drawing/2014/main" id="{3E2C53A0-CC8D-4DE5-8787-6838F2D25893}"/>
               </a:ext>
             </a:extLst>
           </p:cNvPr>
@@ -3234,7 +3234,7 @@
           <p:cNvPr id="2" name="Left column">
             <a:extLst xmlns:a="http://schemas.openxmlformats.org/drawingml/2006/main">
               <a:ext uri="{FF2B5EF4-FFF2-40B4-BE49-F238E27FC236}">
-                <a16:creationId xmlns:a16="http://schemas.microsoft.com/office/drawing/2014/main" id="{E8FF1EB6-6213-4085-8ECE-E06E71342D4B}"/>
+                <a16:creationId xmlns:a16="http://schemas.microsoft.com/office/drawing/2014/main" id="{BA6D36C1-740E-4249-9434-269B54F2959F}"/>
               </a:ext>
             </a:extLst>
           </p:cNvPr>
@@ -3391,7 +3391,7 @@
           <p:cNvPr id="3" name="Right column">
             <a:extLst xmlns:a="http://schemas.openxmlformats.org/drawingml/2006/main">
               <a:ext uri="{FF2B5EF4-FFF2-40B4-BE49-F238E27FC236}">
-                <a16:creationId xmlns:a16="http://schemas.microsoft.com/office/drawing/2014/main" id="{464070F4-D796-444D-A60E-61E786013C16}"/>
+                <a16:creationId xmlns:a16="http://schemas.microsoft.com/office/drawing/2014/main" id="{FBFFB522-5B32-4734-AEE0-2F05D57E6365}"/>
               </a:ext>
             </a:extLst>
           </p:cNvPr>
@@ -3565,7 +3565,7 @@
           <p:cNvPr id="3" name="Title">
             <a:extLst xmlns:a="http://schemas.openxmlformats.org/drawingml/2006/main">
               <a:ext uri="{FF2B5EF4-FFF2-40B4-BE49-F238E27FC236}">
-                <a16:creationId xmlns:a16="http://schemas.microsoft.com/office/drawing/2014/main" id="{4B24F260-5D6D-40FB-9E70-2BDF1BAA9189}"/>
+                <a16:creationId xmlns:a16="http://schemas.microsoft.com/office/drawing/2014/main" id="{2D99FBDF-A049-44E2-86C9-A697DAA0A1BA}"/>
               </a:ext>
             </a:extLst>
           </p:cNvPr>
@@ -3722,7 +3722,7 @@
           <p:cNvPr id="2" name="Left column">
             <a:extLst xmlns:a="http://schemas.openxmlformats.org/drawingml/2006/main">
               <a:ext uri="{FF2B5EF4-FFF2-40B4-BE49-F238E27FC236}">
-                <a16:creationId xmlns:a16="http://schemas.microsoft.com/office/drawing/2014/main" id="{60B493F8-F97E-4F21-B2F1-2EBF467D932B}"/>
+                <a16:creationId xmlns:a16="http://schemas.microsoft.com/office/drawing/2014/main" id="{81BBA128-2005-4CED-B1EB-4F67DDA667FB}"/>
               </a:ext>
             </a:extLst>
           </p:cNvPr>
@@ -3917,12 +3917,12 @@
   </p:cSld>
   <p:clrMap bg1="lt1" tx1="dk1" bg2="lt2" tx2="dk2" accent1="accent1" accent2="accent2" accent3="accent3" accent4="accent4" accent5="accent5" accent6="accent6" hlink="hlink" folHlink="folHlink"/>
   <p:sldLayoutIdLst>
-    <p:sldLayoutId xmlns:r="http://schemas.openxmlformats.org/officeDocument/2006/relationships" id="2147483649" r:id="R567989f058414752"/>
-    <p:sldLayoutId xmlns:r="http://schemas.openxmlformats.org/officeDocument/2006/relationships" id="2147483650" r:id="R0acd1aab72aa44d1"/>
-    <p:sldLayoutId xmlns:r="http://schemas.openxmlformats.org/officeDocument/2006/relationships" id="2147483651" r:id="Rb4bff0f103bf4ff5"/>
-    <p:sldLayoutId xmlns:r="http://schemas.openxmlformats.org/officeDocument/2006/relationships" id="2147483652" r:id="R9635061548ec48db"/>
-    <p:sldLayoutId xmlns:r="http://schemas.openxmlformats.org/officeDocument/2006/relationships" id="2147483653" r:id="Rd60479e84459466a"/>
-    <p:sldLayoutId xmlns:r="http://schemas.openxmlformats.org/officeDocument/2006/relationships" id="2147483654" r:id="Ra8c98c7272944798"/>
+    <p:sldLayoutId xmlns:r="http://schemas.openxmlformats.org/officeDocument/2006/relationships" id="2147483649" r:id="R0467304f55ab44c4"/>
+    <p:sldLayoutId xmlns:r="http://schemas.openxmlformats.org/officeDocument/2006/relationships" id="2147483650" r:id="Rab809b74fe8f4c66"/>
+    <p:sldLayoutId xmlns:r="http://schemas.openxmlformats.org/officeDocument/2006/relationships" id="2147483651" r:id="R89166fff0ff3493a"/>
+    <p:sldLayoutId xmlns:r="http://schemas.openxmlformats.org/officeDocument/2006/relationships" id="2147483652" r:id="R78d36d5b02b4490e"/>
+    <p:sldLayoutId xmlns:r="http://schemas.openxmlformats.org/officeDocument/2006/relationships" id="2147483653" r:id="R1011b7d96f3d41a4"/>
+    <p:sldLayoutId xmlns:r="http://schemas.openxmlformats.org/officeDocument/2006/relationships" id="2147483654" r:id="Reeaab7edb5054776"/>
   </p:sldLayoutIdLst>
   <p:txStyles>
     <p:titleStyle>
@@ -4473,7 +4473,7 @@
           <p:cNvPr id="6" name="title">
             <a:extLst xmlns:a="http://schemas.openxmlformats.org/drawingml/2006/main">
               <a:ext uri="{FF2B5EF4-FFF2-40B4-BE49-F238E27FC236}">
-                <a16:creationId xmlns:a16="http://schemas.microsoft.com/office/drawing/2014/main" id="{7585D801-D1C9-4367-9DD0-C30E823F64B3}"/>
+                <a16:creationId xmlns:a16="http://schemas.microsoft.com/office/drawing/2014/main" id="{49DB0953-1B43-47A7-A0CE-02FCA4F56D8A}"/>
               </a:ext>
             </a:extLst>
           </p:cNvPr>
@@ -4539,7 +4539,7 @@
           <p:cNvPr id="2" name="paragraph-0">
             <a:extLst xmlns:a="http://schemas.openxmlformats.org/drawingml/2006/main">
               <a:ext uri="{FF2B5EF4-FFF2-40B4-BE49-F238E27FC236}">
-                <a16:creationId xmlns:a16="http://schemas.microsoft.com/office/drawing/2014/main" id="{6F92931E-4073-448A-8D91-E798C78D4AF9}"/>
+                <a16:creationId xmlns:a16="http://schemas.microsoft.com/office/drawing/2014/main" id="{D13B1FED-DF0A-45E3-8E45-61ADB4C2BCDF}"/>
               </a:ext>
             </a:extLst>
           </p:cNvPr>
@@ -4605,7 +4605,7 @@
           <p:cNvPr id="3" name="paragraph-1">
             <a:extLst xmlns:a="http://schemas.openxmlformats.org/drawingml/2006/main">
               <a:ext uri="{FF2B5EF4-FFF2-40B4-BE49-F238E27FC236}">
-                <a16:creationId xmlns:a16="http://schemas.microsoft.com/office/drawing/2014/main" id="{435CE23B-2D6C-4C35-BF63-6B3D4F8D7EE8}"/>
+                <a16:creationId xmlns:a16="http://schemas.microsoft.com/office/drawing/2014/main" id="{437B58E4-6A22-431E-942C-5AD82539B36C}"/>
               </a:ext>
             </a:extLst>
           </p:cNvPr>
@@ -4671,7 +4671,7 @@
           <p:cNvPr id="4" name="disclosure">
             <a:extLst xmlns:a="http://schemas.openxmlformats.org/drawingml/2006/main">
               <a:ext uri="{FF2B5EF4-FFF2-40B4-BE49-F238E27FC236}">
-                <a16:creationId xmlns:a16="http://schemas.microsoft.com/office/drawing/2014/main" id="{BB73B43D-E7C5-432A-AF6F-47E26C632E16}"/>
+                <a16:creationId xmlns:a16="http://schemas.microsoft.com/office/drawing/2014/main" id="{397AB371-1B4A-4AE8-A29E-C6C94482DAE3}"/>
               </a:ext>
             </a:extLst>
           </p:cNvPr>
@@ -4737,7 +4737,7 @@
           <p:cNvPr id="5" name="page">
             <a:extLst xmlns:a="http://schemas.openxmlformats.org/drawingml/2006/main">
               <a:ext uri="{FF2B5EF4-FFF2-40B4-BE49-F238E27FC236}">
-                <a16:creationId xmlns:a16="http://schemas.microsoft.com/office/drawing/2014/main" id="{AA922E01-D3E4-43F6-942E-EE7EC9605B50}"/>
+                <a16:creationId xmlns:a16="http://schemas.microsoft.com/office/drawing/2014/main" id="{27555FA3-099C-486C-B17F-68027B684429}"/>
               </a:ext>
             </a:extLst>
           </p:cNvPr>
@@ -4801,7 +4801,7 @@
     </p:spTree>
     <p:extLst>
       <p:ext uri="{BB962C8B-B14F-4D97-AF65-F5344CB8AC3E}">
-        <p14:creationId xmlns:p14="http://schemas.microsoft.com/office/powerpoint/2010/main" val="749129420"/>
+        <p14:creationId xmlns:p14="http://schemas.microsoft.com/office/powerpoint/2010/main" val="2111293077"/>
       </p:ext>
     </p:extLst>
   </p:cSld>
@@ -4832,7 +4832,7 @@
           <p:cNvPr id="6" name="title">
             <a:extLst xmlns:a="http://schemas.openxmlformats.org/drawingml/2006/main">
               <a:ext uri="{FF2B5EF4-FFF2-40B4-BE49-F238E27FC236}">
-                <a16:creationId xmlns:a16="http://schemas.microsoft.com/office/drawing/2014/main" id="{33159F14-3D2C-4B23-8788-BBFD2FD266D5}"/>
+                <a16:creationId xmlns:a16="http://schemas.microsoft.com/office/drawing/2014/main" id="{F988AE99-28C3-48FB-84C2-B53005196539}"/>
               </a:ext>
             </a:extLst>
           </p:cNvPr>
@@ -4898,7 +4898,7 @@
           <p:cNvPr id="2" name="paragraph-0">
             <a:extLst xmlns:a="http://schemas.openxmlformats.org/drawingml/2006/main">
               <a:ext uri="{FF2B5EF4-FFF2-40B4-BE49-F238E27FC236}">
-                <a16:creationId xmlns:a16="http://schemas.microsoft.com/office/drawing/2014/main" id="{C25EE8CB-7677-4B15-9420-B3FEB343FDAB}"/>
+                <a16:creationId xmlns:a16="http://schemas.microsoft.com/office/drawing/2014/main" id="{463A2786-A63F-4D13-A020-2813395F4B3C}"/>
               </a:ext>
             </a:extLst>
           </p:cNvPr>
@@ -4964,7 +4964,7 @@
           <p:cNvPr id="3" name="paragraph-1">
             <a:extLst xmlns:a="http://schemas.openxmlformats.org/drawingml/2006/main">
               <a:ext uri="{FF2B5EF4-FFF2-40B4-BE49-F238E27FC236}">
-                <a16:creationId xmlns:a16="http://schemas.microsoft.com/office/drawing/2014/main" id="{7D604054-821C-415B-96D8-4C038D7AD7D1}"/>
+                <a16:creationId xmlns:a16="http://schemas.microsoft.com/office/drawing/2014/main" id="{A40AA2AA-78D7-4E8B-832E-4F229A183447}"/>
               </a:ext>
             </a:extLst>
           </p:cNvPr>
@@ -5030,7 +5030,7 @@
           <p:cNvPr id="4" name="disclosure">
             <a:extLst xmlns:a="http://schemas.openxmlformats.org/drawingml/2006/main">
               <a:ext uri="{FF2B5EF4-FFF2-40B4-BE49-F238E27FC236}">
-                <a16:creationId xmlns:a16="http://schemas.microsoft.com/office/drawing/2014/main" id="{AB8E0F85-09EE-45F4-A51D-FEAEDFDDCA4C}"/>
+                <a16:creationId xmlns:a16="http://schemas.microsoft.com/office/drawing/2014/main" id="{3513D684-89AA-4B97-B8C4-024D6788522F}"/>
               </a:ext>
             </a:extLst>
           </p:cNvPr>
@@ -5096,7 +5096,7 @@
           <p:cNvPr id="5" name="page">
             <a:extLst xmlns:a="http://schemas.openxmlformats.org/drawingml/2006/main">
               <a:ext uri="{FF2B5EF4-FFF2-40B4-BE49-F238E27FC236}">
-                <a16:creationId xmlns:a16="http://schemas.microsoft.com/office/drawing/2014/main" id="{58D41FF9-9F22-4844-85F8-42E509F7C694}"/>
+                <a16:creationId xmlns:a16="http://schemas.microsoft.com/office/drawing/2014/main" id="{B40E8699-BFC9-4AFB-A5B5-F14E1556B8A2}"/>
               </a:ext>
             </a:extLst>
           </p:cNvPr>
@@ -5160,7 +5160,7 @@
     </p:spTree>
     <p:extLst>
       <p:ext uri="{BB962C8B-B14F-4D97-AF65-F5344CB8AC3E}">
-        <p14:creationId xmlns:p14="http://schemas.microsoft.com/office/powerpoint/2010/main" val="1912771001"/>
+        <p14:creationId xmlns:p14="http://schemas.microsoft.com/office/powerpoint/2010/main" val="270244947"/>
       </p:ext>
     </p:extLst>
   </p:cSld>
@@ -5191,7 +5191,7 @@
           <p:cNvPr id="5" name="title">
             <a:extLst xmlns:a="http://schemas.openxmlformats.org/drawingml/2006/main">
               <a:ext uri="{FF2B5EF4-FFF2-40B4-BE49-F238E27FC236}">
-                <a16:creationId xmlns:a16="http://schemas.microsoft.com/office/drawing/2014/main" id="{9B61C826-9CB5-4346-A5B7-CB9E64F35BC2}"/>
+                <a16:creationId xmlns:a16="http://schemas.microsoft.com/office/drawing/2014/main" id="{55F8D7BA-1B7B-4087-B4E5-E6CA96043094}"/>
               </a:ext>
             </a:extLst>
           </p:cNvPr>
@@ -5257,7 +5257,7 @@
           <p:cNvPr id="2" name="">
             <a:extLst xmlns:a="http://schemas.openxmlformats.org/drawingml/2006/main">
               <a:ext uri="{FF2B5EF4-FFF2-40B4-BE49-F238E27FC236}">
-                <a16:creationId xmlns:a16="http://schemas.microsoft.com/office/drawing/2014/main" id="{5343C74C-C98B-4701-BC1A-7841FD97B8A6}"/>
+                <a16:creationId xmlns:a16="http://schemas.microsoft.com/office/drawing/2014/main" id="{5C80C51C-D508-4243-B8E6-4294C6444751}"/>
               </a:ext>
             </a:extLst>
           </p:cNvPr>
@@ -5585,7 +5585,7 @@
           <p:cNvPr id="3" name="disclosure">
             <a:extLst xmlns:a="http://schemas.openxmlformats.org/drawingml/2006/main">
               <a:ext uri="{FF2B5EF4-FFF2-40B4-BE49-F238E27FC236}">
-                <a16:creationId xmlns:a16="http://schemas.microsoft.com/office/drawing/2014/main" id="{8AC28157-4E82-4B3A-BE30-248CCC3142E6}"/>
+                <a16:creationId xmlns:a16="http://schemas.microsoft.com/office/drawing/2014/main" id="{58D4E341-830B-4099-8CA4-E354220C65A4}"/>
               </a:ext>
             </a:extLst>
           </p:cNvPr>
@@ -5651,7 +5651,7 @@
           <p:cNvPr id="4" name="page">
             <a:extLst xmlns:a="http://schemas.openxmlformats.org/drawingml/2006/main">
               <a:ext uri="{FF2B5EF4-FFF2-40B4-BE49-F238E27FC236}">
-                <a16:creationId xmlns:a16="http://schemas.microsoft.com/office/drawing/2014/main" id="{8BE26EC7-16E5-4BB8-8454-1F53A1415DAE}"/>
+                <a16:creationId xmlns:a16="http://schemas.microsoft.com/office/drawing/2014/main" id="{89DC0117-AB35-4BF0-9D97-ADC54006B6AB}"/>
               </a:ext>
             </a:extLst>
           </p:cNvPr>
@@ -5715,7 +5715,7 @@
     </p:spTree>
     <p:extLst>
       <p:ext uri="{BB962C8B-B14F-4D97-AF65-F5344CB8AC3E}">
-        <p14:creationId xmlns:p14="http://schemas.microsoft.com/office/powerpoint/2010/main" val="2074769525"/>
+        <p14:creationId xmlns:p14="http://schemas.microsoft.com/office/powerpoint/2010/main" val="1446521243"/>
       </p:ext>
     </p:extLst>
   </p:cSld>
@@ -5746,7 +5746,7 @@
           <p:cNvPr id="6" name="title">
             <a:extLst xmlns:a="http://schemas.openxmlformats.org/drawingml/2006/main">
               <a:ext uri="{FF2B5EF4-FFF2-40B4-BE49-F238E27FC236}">
-                <a16:creationId xmlns:a16="http://schemas.microsoft.com/office/drawing/2014/main" id="{49C00C47-0962-4D0E-97C9-42AB9B2021FA}"/>
+                <a16:creationId xmlns:a16="http://schemas.microsoft.com/office/drawing/2014/main" id="{D012151E-9872-480B-A722-5027470C1D06}"/>
               </a:ext>
             </a:extLst>
           </p:cNvPr>
@@ -5812,7 +5812,7 @@
           <p:cNvPr id="2" name="paragraph-0">
             <a:extLst xmlns:a="http://schemas.openxmlformats.org/drawingml/2006/main">
               <a:ext uri="{FF2B5EF4-FFF2-40B4-BE49-F238E27FC236}">
-                <a16:creationId xmlns:a16="http://schemas.microsoft.com/office/drawing/2014/main" id="{914C82BE-6BF3-4C8C-99C3-4A020F3BF3AB}"/>
+                <a16:creationId xmlns:a16="http://schemas.microsoft.com/office/drawing/2014/main" id="{E4EDD16D-7E8C-4D75-B268-6A0AD0F1BCD8}"/>
               </a:ext>
             </a:extLst>
           </p:cNvPr>
@@ -5878,7 +5878,7 @@
           <p:cNvPr id="3" name="paragraph-1">
             <a:extLst xmlns:a="http://schemas.openxmlformats.org/drawingml/2006/main">
               <a:ext uri="{FF2B5EF4-FFF2-40B4-BE49-F238E27FC236}">
-                <a16:creationId xmlns:a16="http://schemas.microsoft.com/office/drawing/2014/main" id="{3503CAEA-DAA5-4070-B8DD-E2DD5FA419E0}"/>
+                <a16:creationId xmlns:a16="http://schemas.microsoft.com/office/drawing/2014/main" id="{8DD46480-081E-4679-AE9A-4137295680A4}"/>
               </a:ext>
             </a:extLst>
           </p:cNvPr>
@@ -5944,7 +5944,7 @@
           <p:cNvPr id="4" name="disclosure">
             <a:extLst xmlns:a="http://schemas.openxmlformats.org/drawingml/2006/main">
               <a:ext uri="{FF2B5EF4-FFF2-40B4-BE49-F238E27FC236}">
-                <a16:creationId xmlns:a16="http://schemas.microsoft.com/office/drawing/2014/main" id="{AC6A68AD-D91E-41DE-B06D-6DDF094DF0F4}"/>
+                <a16:creationId xmlns:a16="http://schemas.microsoft.com/office/drawing/2014/main" id="{F856DDC3-3773-47A1-92C0-DD5094447E34}"/>
               </a:ext>
             </a:extLst>
           </p:cNvPr>
@@ -6010,7 +6010,7 @@
           <p:cNvPr id="5" name="page">
             <a:extLst xmlns:a="http://schemas.openxmlformats.org/drawingml/2006/main">
               <a:ext uri="{FF2B5EF4-FFF2-40B4-BE49-F238E27FC236}">
-                <a16:creationId xmlns:a16="http://schemas.microsoft.com/office/drawing/2014/main" id="{E5DAA9AC-BD58-404F-8A9C-DF18C85F0069}"/>
+                <a16:creationId xmlns:a16="http://schemas.microsoft.com/office/drawing/2014/main" id="{2082874E-5C9E-48DC-9D05-D8634AA79BD4}"/>
               </a:ext>
             </a:extLst>
           </p:cNvPr>
@@ -6074,7 +6074,7 @@
     </p:spTree>
     <p:extLst>
       <p:ext uri="{BB962C8B-B14F-4D97-AF65-F5344CB8AC3E}">
-        <p14:creationId xmlns:p14="http://schemas.microsoft.com/office/powerpoint/2010/main" val="96193816"/>
+        <p14:creationId xmlns:p14="http://schemas.microsoft.com/office/powerpoint/2010/main" val="1768039773"/>
       </p:ext>
     </p:extLst>
   </p:cSld>
@@ -6105,7 +6105,7 @@
           <p:cNvPr id="6" name="title">
             <a:extLst xmlns:a="http://schemas.openxmlformats.org/drawingml/2006/main">
               <a:ext uri="{FF2B5EF4-FFF2-40B4-BE49-F238E27FC236}">
-                <a16:creationId xmlns:a16="http://schemas.microsoft.com/office/drawing/2014/main" id="{29F4E924-17EA-4DC3-ADAD-9799675D23A3}"/>
+                <a16:creationId xmlns:a16="http://schemas.microsoft.com/office/drawing/2014/main" id="{60093482-0175-438F-A785-5E3433BA1A68}"/>
               </a:ext>
             </a:extLst>
           </p:cNvPr>
@@ -6171,7 +6171,7 @@
           <p:cNvPr id="2" name="paragraph-0">
             <a:extLst xmlns:a="http://schemas.openxmlformats.org/drawingml/2006/main">
               <a:ext uri="{FF2B5EF4-FFF2-40B4-BE49-F238E27FC236}">
-                <a16:creationId xmlns:a16="http://schemas.microsoft.com/office/drawing/2014/main" id="{2EA249A3-EBB6-40FD-9C0C-3C20E7597398}"/>
+                <a16:creationId xmlns:a16="http://schemas.microsoft.com/office/drawing/2014/main" id="{982CCFD8-72E4-4A19-B3F4-3472D1E7474D}"/>
               </a:ext>
             </a:extLst>
           </p:cNvPr>
@@ -6237,7 +6237,7 @@
           <p:cNvPr id="3" name="paragraph-1">
             <a:extLst xmlns:a="http://schemas.openxmlformats.org/drawingml/2006/main">
               <a:ext uri="{FF2B5EF4-FFF2-40B4-BE49-F238E27FC236}">
-                <a16:creationId xmlns:a16="http://schemas.microsoft.com/office/drawing/2014/main" id="{42141EA2-D5F2-4231-89A7-95CC020CEE85}"/>
+                <a16:creationId xmlns:a16="http://schemas.microsoft.com/office/drawing/2014/main" id="{EB7BAC7A-2257-4C9C-BB3F-A8FF2F6F6461}"/>
               </a:ext>
             </a:extLst>
           </p:cNvPr>
@@ -6303,7 +6303,7 @@
           <p:cNvPr id="4" name="disclosure">
             <a:extLst xmlns:a="http://schemas.openxmlformats.org/drawingml/2006/main">
               <a:ext uri="{FF2B5EF4-FFF2-40B4-BE49-F238E27FC236}">
-                <a16:creationId xmlns:a16="http://schemas.microsoft.com/office/drawing/2014/main" id="{A3930BCC-99E9-4C7A-995F-5947CFB42F3D}"/>
+                <a16:creationId xmlns:a16="http://schemas.microsoft.com/office/drawing/2014/main" id="{69CE1922-59D7-4F1E-8C04-F1BB5FE3E84B}"/>
               </a:ext>
             </a:extLst>
           </p:cNvPr>
@@ -6369,7 +6369,7 @@
           <p:cNvPr id="5" name="page">
             <a:extLst xmlns:a="http://schemas.openxmlformats.org/drawingml/2006/main">
               <a:ext uri="{FF2B5EF4-FFF2-40B4-BE49-F238E27FC236}">
-                <a16:creationId xmlns:a16="http://schemas.microsoft.com/office/drawing/2014/main" id="{8A339ED0-DE92-42B9-897D-1C390EBCF4AD}"/>
+                <a16:creationId xmlns:a16="http://schemas.microsoft.com/office/drawing/2014/main" id="{7B3FF063-51AC-466C-BB6B-3050A27D9332}"/>
               </a:ext>
             </a:extLst>
           </p:cNvPr>
@@ -6433,7 +6433,7 @@
     </p:spTree>
     <p:extLst>
       <p:ext uri="{BB962C8B-B14F-4D97-AF65-F5344CB8AC3E}">
-        <p14:creationId xmlns:p14="http://schemas.microsoft.com/office/powerpoint/2010/main" val="421444301"/>
+        <p14:creationId xmlns:p14="http://schemas.microsoft.com/office/powerpoint/2010/main" val="1612152765"/>
       </p:ext>
     </p:extLst>
   </p:cSld>
@@ -6464,7 +6464,7 @@
           <p:cNvPr id="5" name="title">
             <a:extLst xmlns:a="http://schemas.openxmlformats.org/drawingml/2006/main">
               <a:ext uri="{FF2B5EF4-FFF2-40B4-BE49-F238E27FC236}">
-                <a16:creationId xmlns:a16="http://schemas.microsoft.com/office/drawing/2014/main" id="{DA3BF1C7-74CB-484A-9B95-F907EF0CBB5C}"/>
+                <a16:creationId xmlns:a16="http://schemas.microsoft.com/office/drawing/2014/main" id="{0AD23910-9182-4488-9813-39A147FE246F}"/>
               </a:ext>
             </a:extLst>
           </p:cNvPr>
@@ -6530,7 +6530,7 @@
           <p:cNvPr id="2" name="">
             <a:extLst xmlns:a="http://schemas.openxmlformats.org/drawingml/2006/main">
               <a:ext uri="{FF2B5EF4-FFF2-40B4-BE49-F238E27FC236}">
-                <a16:creationId xmlns:a16="http://schemas.microsoft.com/office/drawing/2014/main" id="{95C59C16-AA15-4770-B490-A7EFD405D922}"/>
+                <a16:creationId xmlns:a16="http://schemas.microsoft.com/office/drawing/2014/main" id="{02CBE886-37AC-4BE9-9005-D107C63AAB35}"/>
               </a:ext>
             </a:extLst>
           </p:cNvPr>
@@ -6808,7 +6808,7 @@
           <p:cNvPr id="3" name="disclosure">
             <a:extLst xmlns:a="http://schemas.openxmlformats.org/drawingml/2006/main">
               <a:ext uri="{FF2B5EF4-FFF2-40B4-BE49-F238E27FC236}">
-                <a16:creationId xmlns:a16="http://schemas.microsoft.com/office/drawing/2014/main" id="{12EF9DD4-5475-4693-9AE7-C72BFAED1F9C}"/>
+                <a16:creationId xmlns:a16="http://schemas.microsoft.com/office/drawing/2014/main" id="{AC0CC344-A518-410F-BEAC-7258570B884F}"/>
               </a:ext>
             </a:extLst>
           </p:cNvPr>
@@ -6874,7 +6874,7 @@
           <p:cNvPr id="4" name="page">
             <a:extLst xmlns:a="http://schemas.openxmlformats.org/drawingml/2006/main">
               <a:ext uri="{FF2B5EF4-FFF2-40B4-BE49-F238E27FC236}">
-                <a16:creationId xmlns:a16="http://schemas.microsoft.com/office/drawing/2014/main" id="{8A3E1965-8E1A-4E62-A39E-033F304A75F9}"/>
+                <a16:creationId xmlns:a16="http://schemas.microsoft.com/office/drawing/2014/main" id="{BDC7DAA7-40EF-4C27-ACCE-C3E20C067751}"/>
               </a:ext>
             </a:extLst>
           </p:cNvPr>
@@ -6938,7 +6938,7 @@
     </p:spTree>
     <p:extLst>
       <p:ext uri="{BB962C8B-B14F-4D97-AF65-F5344CB8AC3E}">
-        <p14:creationId xmlns:p14="http://schemas.microsoft.com/office/powerpoint/2010/main" val="1928748763"/>
+        <p14:creationId xmlns:p14="http://schemas.microsoft.com/office/powerpoint/2010/main" val="715529799"/>
       </p:ext>
     </p:extLst>
   </p:cSld>
@@ -6969,7 +6969,7 @@
           <p:cNvPr id="6" name="title">
             <a:extLst xmlns:a="http://schemas.openxmlformats.org/drawingml/2006/main">
               <a:ext uri="{FF2B5EF4-FFF2-40B4-BE49-F238E27FC236}">
-                <a16:creationId xmlns:a16="http://schemas.microsoft.com/office/drawing/2014/main" id="{B10C843F-AE93-473F-ABB8-D92A19EE0021}"/>
+                <a16:creationId xmlns:a16="http://schemas.microsoft.com/office/drawing/2014/main" id="{9B0AF08E-0907-44D4-A080-E153C849C37A}"/>
               </a:ext>
             </a:extLst>
           </p:cNvPr>
@@ -7035,7 +7035,7 @@
           <p:cNvPr id="2" name="paragraph-0">
             <a:extLst xmlns:a="http://schemas.openxmlformats.org/drawingml/2006/main">
               <a:ext uri="{FF2B5EF4-FFF2-40B4-BE49-F238E27FC236}">
-                <a16:creationId xmlns:a16="http://schemas.microsoft.com/office/drawing/2014/main" id="{C2DDB330-FAC7-4B12-8FFD-3E87E5926899}"/>
+                <a16:creationId xmlns:a16="http://schemas.microsoft.com/office/drawing/2014/main" id="{6D3F1158-B509-4CFF-997E-D9B2B6D5FEC8}"/>
               </a:ext>
             </a:extLst>
           </p:cNvPr>
@@ -7101,7 +7101,7 @@
           <p:cNvPr id="3" name="paragraph-1">
             <a:extLst xmlns:a="http://schemas.openxmlformats.org/drawingml/2006/main">
               <a:ext uri="{FF2B5EF4-FFF2-40B4-BE49-F238E27FC236}">
-                <a16:creationId xmlns:a16="http://schemas.microsoft.com/office/drawing/2014/main" id="{BEF10A19-CE3D-4F9C-8760-EB122B969469}"/>
+                <a16:creationId xmlns:a16="http://schemas.microsoft.com/office/drawing/2014/main" id="{A6E95FB3-75B5-4E80-82BF-98B857807A79}"/>
               </a:ext>
             </a:extLst>
           </p:cNvPr>
@@ -7167,7 +7167,7 @@
           <p:cNvPr id="4" name="disclosure">
             <a:extLst xmlns:a="http://schemas.openxmlformats.org/drawingml/2006/main">
               <a:ext uri="{FF2B5EF4-FFF2-40B4-BE49-F238E27FC236}">
-                <a16:creationId xmlns:a16="http://schemas.microsoft.com/office/drawing/2014/main" id="{2732A04C-D7E6-4213-B300-551A928347C8}"/>
+                <a16:creationId xmlns:a16="http://schemas.microsoft.com/office/drawing/2014/main" id="{332A66CE-B6F0-4A6D-9DB5-C44F28D76D03}"/>
               </a:ext>
             </a:extLst>
           </p:cNvPr>
@@ -7233,7 +7233,7 @@
           <p:cNvPr id="5" name="page">
             <a:extLst xmlns:a="http://schemas.openxmlformats.org/drawingml/2006/main">
               <a:ext uri="{FF2B5EF4-FFF2-40B4-BE49-F238E27FC236}">
-                <a16:creationId xmlns:a16="http://schemas.microsoft.com/office/drawing/2014/main" id="{DCFB79CE-6EAF-4D9B-849D-8275F960E821}"/>
+                <a16:creationId xmlns:a16="http://schemas.microsoft.com/office/drawing/2014/main" id="{45876628-0119-4BE6-B834-D3194684E39E}"/>
               </a:ext>
             </a:extLst>
           </p:cNvPr>
@@ -7297,7 +7297,7 @@
     </p:spTree>
     <p:extLst>
       <p:ext uri="{BB962C8B-B14F-4D97-AF65-F5344CB8AC3E}">
-        <p14:creationId xmlns:p14="http://schemas.microsoft.com/office/powerpoint/2010/main" val="1298993996"/>
+        <p14:creationId xmlns:p14="http://schemas.microsoft.com/office/powerpoint/2010/main" val="2035900774"/>
       </p:ext>
     </p:extLst>
   </p:cSld>
@@ -7328,7 +7328,7 @@
           <p:cNvPr id="5" name="title">
             <a:extLst xmlns:a="http://schemas.openxmlformats.org/drawingml/2006/main">
               <a:ext uri="{FF2B5EF4-FFF2-40B4-BE49-F238E27FC236}">
-                <a16:creationId xmlns:a16="http://schemas.microsoft.com/office/drawing/2014/main" id="{A58F8667-4131-43EB-BFD3-B40E0502AEF5}"/>
+                <a16:creationId xmlns:a16="http://schemas.microsoft.com/office/drawing/2014/main" id="{8C765F3B-6550-4D9B-9978-E1E473DB2A50}"/>
               </a:ext>
             </a:extLst>
           </p:cNvPr>
@@ -7394,7 +7394,7 @@
           <p:cNvPr id="2" name="">
             <a:extLst xmlns:a="http://schemas.openxmlformats.org/drawingml/2006/main">
               <a:ext uri="{FF2B5EF4-FFF2-40B4-BE49-F238E27FC236}">
-                <a16:creationId xmlns:a16="http://schemas.microsoft.com/office/drawing/2014/main" id="{2E99A7AF-7BD4-43A7-A6EC-05D3251624F8}"/>
+                <a16:creationId xmlns:a16="http://schemas.microsoft.com/office/drawing/2014/main" id="{30E4BB1C-B4A6-4173-9D22-917F7028340A}"/>
               </a:ext>
             </a:extLst>
           </p:cNvPr>
@@ -7722,7 +7722,7 @@
           <p:cNvPr id="3" name="disclosure">
             <a:extLst xmlns:a="http://schemas.openxmlformats.org/drawingml/2006/main">
               <a:ext uri="{FF2B5EF4-FFF2-40B4-BE49-F238E27FC236}">
-                <a16:creationId xmlns:a16="http://schemas.microsoft.com/office/drawing/2014/main" id="{AABB7608-B6EC-4650-960E-366D8D4F9AA5}"/>
+                <a16:creationId xmlns:a16="http://schemas.microsoft.com/office/drawing/2014/main" id="{12F8B675-C621-4C9F-9898-E79B677ADF11}"/>
               </a:ext>
             </a:extLst>
           </p:cNvPr>
@@ -7788,7 +7788,7 @@
           <p:cNvPr id="4" name="page">
             <a:extLst xmlns:a="http://schemas.openxmlformats.org/drawingml/2006/main">
               <a:ext uri="{FF2B5EF4-FFF2-40B4-BE49-F238E27FC236}">
-                <a16:creationId xmlns:a16="http://schemas.microsoft.com/office/drawing/2014/main" id="{9E8A2E90-726B-4578-91FF-008B94D0B726}"/>
+                <a16:creationId xmlns:a16="http://schemas.microsoft.com/office/drawing/2014/main" id="{9E1CC219-DA88-4758-A884-7E1ED5F5D20F}"/>
               </a:ext>
             </a:extLst>
           </p:cNvPr>
@@ -7852,7 +7852,7 @@
     </p:spTree>
     <p:extLst>
       <p:ext uri="{BB962C8B-B14F-4D97-AF65-F5344CB8AC3E}">
-        <p14:creationId xmlns:p14="http://schemas.microsoft.com/office/powerpoint/2010/main" val="865125911"/>
+        <p14:creationId xmlns:p14="http://schemas.microsoft.com/office/powerpoint/2010/main" val="1891684165"/>
       </p:ext>
     </p:extLst>
   </p:cSld>
@@ -7883,7 +7883,7 @@
           <p:cNvPr id="6" name="title">
             <a:extLst xmlns:a="http://schemas.openxmlformats.org/drawingml/2006/main">
               <a:ext uri="{FF2B5EF4-FFF2-40B4-BE49-F238E27FC236}">
-                <a16:creationId xmlns:a16="http://schemas.microsoft.com/office/drawing/2014/main" id="{B0F5FF6C-658F-4E33-BE5E-767892F62B4B}"/>
+                <a16:creationId xmlns:a16="http://schemas.microsoft.com/office/drawing/2014/main" id="{68229DAF-87AD-45B4-B885-0D73B0FD7C2B}"/>
               </a:ext>
             </a:extLst>
           </p:cNvPr>
@@ -7949,7 +7949,7 @@
           <p:cNvPr id="2" name="paragraph-0">
             <a:extLst xmlns:a="http://schemas.openxmlformats.org/drawingml/2006/main">
               <a:ext uri="{FF2B5EF4-FFF2-40B4-BE49-F238E27FC236}">
-                <a16:creationId xmlns:a16="http://schemas.microsoft.com/office/drawing/2014/main" id="{594F7785-0DE3-4262-B139-11CF02347A68}"/>
+                <a16:creationId xmlns:a16="http://schemas.microsoft.com/office/drawing/2014/main" id="{176EA17E-B22F-4641-AD38-434009025D2F}"/>
               </a:ext>
             </a:extLst>
           </p:cNvPr>
@@ -8015,7 +8015,7 @@
           <p:cNvPr id="3" name="paragraph-1">
             <a:extLst xmlns:a="http://schemas.openxmlformats.org/drawingml/2006/main">
               <a:ext uri="{FF2B5EF4-FFF2-40B4-BE49-F238E27FC236}">
-                <a16:creationId xmlns:a16="http://schemas.microsoft.com/office/drawing/2014/main" id="{7C87B84B-EA9C-40CA-9788-81B0D35FAA02}"/>
+                <a16:creationId xmlns:a16="http://schemas.microsoft.com/office/drawing/2014/main" id="{79478BDB-15EA-4D15-B407-E2C54BDD9E7D}"/>
               </a:ext>
             </a:extLst>
           </p:cNvPr>
@@ -8081,7 +8081,7 @@
           <p:cNvPr id="4" name="disclosure">
             <a:extLst xmlns:a="http://schemas.openxmlformats.org/drawingml/2006/main">
               <a:ext uri="{FF2B5EF4-FFF2-40B4-BE49-F238E27FC236}">
-                <a16:creationId xmlns:a16="http://schemas.microsoft.com/office/drawing/2014/main" id="{FFDE583E-5EE3-4F11-9337-94CFC981BF6B}"/>
+                <a16:creationId xmlns:a16="http://schemas.microsoft.com/office/drawing/2014/main" id="{A5AE98F0-4535-4112-A98C-188E202A6EB3}"/>
               </a:ext>
             </a:extLst>
           </p:cNvPr>
@@ -8147,7 +8147,7 @@
           <p:cNvPr id="5" name="page">
             <a:extLst xmlns:a="http://schemas.openxmlformats.org/drawingml/2006/main">
               <a:ext uri="{FF2B5EF4-FFF2-40B4-BE49-F238E27FC236}">
-                <a16:creationId xmlns:a16="http://schemas.microsoft.com/office/drawing/2014/main" id="{696DF8CA-B1ED-46FC-BABE-740DF424539C}"/>
+                <a16:creationId xmlns:a16="http://schemas.microsoft.com/office/drawing/2014/main" id="{B8530A93-E807-4478-BBE4-BC33E3DE71DE}"/>
               </a:ext>
             </a:extLst>
           </p:cNvPr>
@@ -8211,7 +8211,7 @@
     </p:spTree>
     <p:extLst>
       <p:ext uri="{BB962C8B-B14F-4D97-AF65-F5344CB8AC3E}">
-        <p14:creationId xmlns:p14="http://schemas.microsoft.com/office/powerpoint/2010/main" val="492604871"/>
+        <p14:creationId xmlns:p14="http://schemas.microsoft.com/office/powerpoint/2010/main" val="160740096"/>
       </p:ext>
     </p:extLst>
   </p:cSld>
@@ -8242,7 +8242,7 @@
           <p:cNvPr id="7" name="title">
             <a:extLst xmlns:a="http://schemas.openxmlformats.org/drawingml/2006/main">
               <a:ext uri="{FF2B5EF4-FFF2-40B4-BE49-F238E27FC236}">
-                <a16:creationId xmlns:a16="http://schemas.microsoft.com/office/drawing/2014/main" id="{900897DF-C0E7-4BB2-9611-9DB6B5B91B63}"/>
+                <a16:creationId xmlns:a16="http://schemas.microsoft.com/office/drawing/2014/main" id="{9CD36E25-F4BD-4127-B40F-E19AE1323E9B}"/>
               </a:ext>
             </a:extLst>
           </p:cNvPr>
@@ -8308,7 +8308,7 @@
           <p:cNvPr id="2" name="paragraph-0">
             <a:extLst xmlns:a="http://schemas.openxmlformats.org/drawingml/2006/main">
               <a:ext uri="{FF2B5EF4-FFF2-40B4-BE49-F238E27FC236}">
-                <a16:creationId xmlns:a16="http://schemas.microsoft.com/office/drawing/2014/main" id="{7403DA04-C869-40CE-ACDC-EDB5B1554F91}"/>
+                <a16:creationId xmlns:a16="http://schemas.microsoft.com/office/drawing/2014/main" id="{C6A51ADC-BDAD-44A7-905C-4B927A97BB09}"/>
               </a:ext>
             </a:extLst>
           </p:cNvPr>
@@ -8374,7 +8374,7 @@
           <p:cNvPr id="3" name="paragraph-1">
             <a:extLst xmlns:a="http://schemas.openxmlformats.org/drawingml/2006/main">
               <a:ext uri="{FF2B5EF4-FFF2-40B4-BE49-F238E27FC236}">
-                <a16:creationId xmlns:a16="http://schemas.microsoft.com/office/drawing/2014/main" id="{6CB47771-8C20-48D2-8041-9C4E863A91BC}"/>
+                <a16:creationId xmlns:a16="http://schemas.microsoft.com/office/drawing/2014/main" id="{194E610F-65DB-4B12-B8E8-C4220A2D7824}"/>
               </a:ext>
             </a:extLst>
           </p:cNvPr>
@@ -8440,7 +8440,7 @@
           <p:cNvPr id="4" name="paragraph-2">
             <a:extLst xmlns:a="http://schemas.openxmlformats.org/drawingml/2006/main">
               <a:ext uri="{FF2B5EF4-FFF2-40B4-BE49-F238E27FC236}">
-                <a16:creationId xmlns:a16="http://schemas.microsoft.com/office/drawing/2014/main" id="{A9A31F17-54B5-4E3E-BBEC-C16BB63BC6CB}"/>
+                <a16:creationId xmlns:a16="http://schemas.microsoft.com/office/drawing/2014/main" id="{C2FA5A7E-CC4D-480E-9891-8A04C35AC966}"/>
               </a:ext>
             </a:extLst>
           </p:cNvPr>
@@ -8506,7 +8506,7 @@
           <p:cNvPr id="5" name="disclosure">
             <a:extLst xmlns:a="http://schemas.openxmlformats.org/drawingml/2006/main">
               <a:ext uri="{FF2B5EF4-FFF2-40B4-BE49-F238E27FC236}">
-                <a16:creationId xmlns:a16="http://schemas.microsoft.com/office/drawing/2014/main" id="{8C3F7545-1DAE-486B-94B6-86A3905CC3D8}"/>
+                <a16:creationId xmlns:a16="http://schemas.microsoft.com/office/drawing/2014/main" id="{3AE8FB8A-3DD2-4568-9D78-736C4DB5A01C}"/>
               </a:ext>
             </a:extLst>
           </p:cNvPr>
@@ -8572,7 +8572,7 @@
           <p:cNvPr id="6" name="page">
             <a:extLst xmlns:a="http://schemas.openxmlformats.org/drawingml/2006/main">
               <a:ext uri="{FF2B5EF4-FFF2-40B4-BE49-F238E27FC236}">
-                <a16:creationId xmlns:a16="http://schemas.microsoft.com/office/drawing/2014/main" id="{7B57F6AB-2121-4275-86F1-9BC2C0B09CF2}"/>
+                <a16:creationId xmlns:a16="http://schemas.microsoft.com/office/drawing/2014/main" id="{47EBF130-1A52-4763-9C8D-0FB0A215F50D}"/>
               </a:ext>
             </a:extLst>
           </p:cNvPr>
@@ -8636,7 +8636,7 @@
     </p:spTree>
     <p:extLst>
       <p:ext uri="{BB962C8B-B14F-4D97-AF65-F5344CB8AC3E}">
-        <p14:creationId xmlns:p14="http://schemas.microsoft.com/office/powerpoint/2010/main" val="868135226"/>
+        <p14:creationId xmlns:p14="http://schemas.microsoft.com/office/powerpoint/2010/main" val="1092406640"/>
       </p:ext>
     </p:extLst>
   </p:cSld>
@@ -8667,7 +8667,7 @@
           <p:cNvPr id="5" name="title">
             <a:extLst xmlns:a="http://schemas.openxmlformats.org/drawingml/2006/main">
               <a:ext uri="{FF2B5EF4-FFF2-40B4-BE49-F238E27FC236}">
-                <a16:creationId xmlns:a16="http://schemas.microsoft.com/office/drawing/2014/main" id="{F9627987-531D-421C-A177-4005D744A731}"/>
+                <a16:creationId xmlns:a16="http://schemas.microsoft.com/office/drawing/2014/main" id="{8EE1A831-A7FB-4849-BB56-17BC0C433D13}"/>
               </a:ext>
             </a:extLst>
           </p:cNvPr>
@@ -8733,7 +8733,7 @@
           <p:cNvPr id="2" name="">
             <a:extLst xmlns:a="http://schemas.openxmlformats.org/drawingml/2006/main">
               <a:ext uri="{FF2B5EF4-FFF2-40B4-BE49-F238E27FC236}">
-                <a16:creationId xmlns:a16="http://schemas.microsoft.com/office/drawing/2014/main" id="{D025CB52-CF56-43DA-8AE9-8C81E951AD19}"/>
+                <a16:creationId xmlns:a16="http://schemas.microsoft.com/office/drawing/2014/main" id="{A5575712-665B-4F7B-B426-505F2FB3EF8B}"/>
               </a:ext>
             </a:extLst>
           </p:cNvPr>
@@ -9061,7 +9061,7 @@
           <p:cNvPr id="3" name="disclosure">
             <a:extLst xmlns:a="http://schemas.openxmlformats.org/drawingml/2006/main">
               <a:ext uri="{FF2B5EF4-FFF2-40B4-BE49-F238E27FC236}">
-                <a16:creationId xmlns:a16="http://schemas.microsoft.com/office/drawing/2014/main" id="{F50CCBA7-B519-4545-B7F8-DBAE3FA27B1C}"/>
+                <a16:creationId xmlns:a16="http://schemas.microsoft.com/office/drawing/2014/main" id="{DDD9D5AC-3866-4CE6-A346-BFFA424E49C2}"/>
               </a:ext>
             </a:extLst>
           </p:cNvPr>
@@ -9127,7 +9127,7 @@
           <p:cNvPr id="4" name="page">
             <a:extLst xmlns:a="http://schemas.openxmlformats.org/drawingml/2006/main">
               <a:ext uri="{FF2B5EF4-FFF2-40B4-BE49-F238E27FC236}">
-                <a16:creationId xmlns:a16="http://schemas.microsoft.com/office/drawing/2014/main" id="{410E11F3-4D41-4F62-A20F-6CFD20C963F6}"/>
+                <a16:creationId xmlns:a16="http://schemas.microsoft.com/office/drawing/2014/main" id="{5231042C-CDA3-4D7F-A183-35B95428A9B9}"/>
               </a:ext>
             </a:extLst>
           </p:cNvPr>
@@ -9191,7 +9191,7 @@
     </p:spTree>
     <p:extLst>
       <p:ext uri="{BB962C8B-B14F-4D97-AF65-F5344CB8AC3E}">
-        <p14:creationId xmlns:p14="http://schemas.microsoft.com/office/powerpoint/2010/main" val="1867979891"/>
+        <p14:creationId xmlns:p14="http://schemas.microsoft.com/office/powerpoint/2010/main" val="402560623"/>
       </p:ext>
     </p:extLst>
   </p:cSld>
@@ -9222,7 +9222,7 @@
           <p:cNvPr id="6" name="title">
             <a:extLst xmlns:a="http://schemas.openxmlformats.org/drawingml/2006/main">
               <a:ext uri="{FF2B5EF4-FFF2-40B4-BE49-F238E27FC236}">
-                <a16:creationId xmlns:a16="http://schemas.microsoft.com/office/drawing/2014/main" id="{5C051568-C577-40CC-9294-88983617A038}"/>
+                <a16:creationId xmlns:a16="http://schemas.microsoft.com/office/drawing/2014/main" id="{9EB5660A-C09B-4B6F-AF2A-BECB9C060328}"/>
               </a:ext>
             </a:extLst>
           </p:cNvPr>
@@ -9288,7 +9288,7 @@
           <p:cNvPr id="2" name="paragraph-0">
             <a:extLst xmlns:a="http://schemas.openxmlformats.org/drawingml/2006/main">
               <a:ext uri="{FF2B5EF4-FFF2-40B4-BE49-F238E27FC236}">
-                <a16:creationId xmlns:a16="http://schemas.microsoft.com/office/drawing/2014/main" id="{3C1BFE94-B9D1-48FD-9509-CACABDDDF94A}"/>
+                <a16:creationId xmlns:a16="http://schemas.microsoft.com/office/drawing/2014/main" id="{EDB693DC-ED90-46BF-924B-518346FA85EA}"/>
               </a:ext>
             </a:extLst>
           </p:cNvPr>
@@ -9354,7 +9354,7 @@
           <p:cNvPr id="3" name="paragraph-1">
             <a:extLst xmlns:a="http://schemas.openxmlformats.org/drawingml/2006/main">
               <a:ext uri="{FF2B5EF4-FFF2-40B4-BE49-F238E27FC236}">
-                <a16:creationId xmlns:a16="http://schemas.microsoft.com/office/drawing/2014/main" id="{04A191F2-10EC-443E-953E-E83C6A9A37F3}"/>
+                <a16:creationId xmlns:a16="http://schemas.microsoft.com/office/drawing/2014/main" id="{F6814E29-7E22-450F-BD3B-C77CBC191200}"/>
               </a:ext>
             </a:extLst>
           </p:cNvPr>
@@ -9420,7 +9420,7 @@
           <p:cNvPr id="4" name="disclosure">
             <a:extLst xmlns:a="http://schemas.openxmlformats.org/drawingml/2006/main">
               <a:ext uri="{FF2B5EF4-FFF2-40B4-BE49-F238E27FC236}">
-                <a16:creationId xmlns:a16="http://schemas.microsoft.com/office/drawing/2014/main" id="{13AE2923-79E1-409A-928B-1CCED60C01F0}"/>
+                <a16:creationId xmlns:a16="http://schemas.microsoft.com/office/drawing/2014/main" id="{BED73317-AA71-460D-B19D-CA56D00425A8}"/>
               </a:ext>
             </a:extLst>
           </p:cNvPr>
@@ -9486,7 +9486,7 @@
           <p:cNvPr id="5" name="page">
             <a:extLst xmlns:a="http://schemas.openxmlformats.org/drawingml/2006/main">
               <a:ext uri="{FF2B5EF4-FFF2-40B4-BE49-F238E27FC236}">
-                <a16:creationId xmlns:a16="http://schemas.microsoft.com/office/drawing/2014/main" id="{0EB5D30B-BA05-41A5-BCC2-F21C19F3E90A}"/>
+                <a16:creationId xmlns:a16="http://schemas.microsoft.com/office/drawing/2014/main" id="{72C38A0D-5AC5-4FF5-8FF7-7BCA5C25998A}"/>
               </a:ext>
             </a:extLst>
           </p:cNvPr>
@@ -9550,7 +9550,7 @@
     </p:spTree>
     <p:extLst>
       <p:ext uri="{BB962C8B-B14F-4D97-AF65-F5344CB8AC3E}">
-        <p14:creationId xmlns:p14="http://schemas.microsoft.com/office/powerpoint/2010/main" val="2104267900"/>
+        <p14:creationId xmlns:p14="http://schemas.microsoft.com/office/powerpoint/2010/main" val="634923679"/>
       </p:ext>
     </p:extLst>
   </p:cSld>
@@ -9581,7 +9581,7 @@
           <p:cNvPr id="6" name="title">
             <a:extLst xmlns:a="http://schemas.openxmlformats.org/drawingml/2006/main">
               <a:ext uri="{FF2B5EF4-FFF2-40B4-BE49-F238E27FC236}">
-                <a16:creationId xmlns:a16="http://schemas.microsoft.com/office/drawing/2014/main" id="{EF2141E8-7163-447B-B612-5A913614E114}"/>
+                <a16:creationId xmlns:a16="http://schemas.microsoft.com/office/drawing/2014/main" id="{C9CDF601-E6CE-4230-82AC-B86232119D81}"/>
               </a:ext>
             </a:extLst>
           </p:cNvPr>
@@ -9647,7 +9647,7 @@
           <p:cNvPr id="2" name="paragraph-0">
             <a:extLst xmlns:a="http://schemas.openxmlformats.org/drawingml/2006/main">
               <a:ext uri="{FF2B5EF4-FFF2-40B4-BE49-F238E27FC236}">
-                <a16:creationId xmlns:a16="http://schemas.microsoft.com/office/drawing/2014/main" id="{42182328-A21C-4B4F-BFD6-BC5384DD7A07}"/>
+                <a16:creationId xmlns:a16="http://schemas.microsoft.com/office/drawing/2014/main" id="{C45A4EDC-0E1D-4BB6-BF54-5F246EA48C7F}"/>
               </a:ext>
             </a:extLst>
           </p:cNvPr>
@@ -9713,7 +9713,7 @@
           <p:cNvPr id="3" name="paragraph-1">
             <a:extLst xmlns:a="http://schemas.openxmlformats.org/drawingml/2006/main">
               <a:ext uri="{FF2B5EF4-FFF2-40B4-BE49-F238E27FC236}">
-                <a16:creationId xmlns:a16="http://schemas.microsoft.com/office/drawing/2014/main" id="{7E14474F-74B0-4FEF-97C7-FB8C1DC96A8B}"/>
+                <a16:creationId xmlns:a16="http://schemas.microsoft.com/office/drawing/2014/main" id="{C488E4DE-E91A-4289-9BE2-EF3CBF85DCAB}"/>
               </a:ext>
             </a:extLst>
           </p:cNvPr>
@@ -9779,7 +9779,7 @@
           <p:cNvPr id="4" name="disclosure">
             <a:extLst xmlns:a="http://schemas.openxmlformats.org/drawingml/2006/main">
               <a:ext uri="{FF2B5EF4-FFF2-40B4-BE49-F238E27FC236}">
-                <a16:creationId xmlns:a16="http://schemas.microsoft.com/office/drawing/2014/main" id="{F0BB4B32-00B8-4CCC-AC16-B4F70BE3E45D}"/>
+                <a16:creationId xmlns:a16="http://schemas.microsoft.com/office/drawing/2014/main" id="{39176F0C-9058-460F-86A7-E78DD64ED55A}"/>
               </a:ext>
             </a:extLst>
           </p:cNvPr>
@@ -9845,7 +9845,7 @@
           <p:cNvPr id="5" name="page">
             <a:extLst xmlns:a="http://schemas.openxmlformats.org/drawingml/2006/main">
               <a:ext uri="{FF2B5EF4-FFF2-40B4-BE49-F238E27FC236}">
-                <a16:creationId xmlns:a16="http://schemas.microsoft.com/office/drawing/2014/main" id="{EAB70EF7-6F90-4D72-BFC2-B3AEE65E7268}"/>
+                <a16:creationId xmlns:a16="http://schemas.microsoft.com/office/drawing/2014/main" id="{6C4821A3-E0C3-4B84-A4AC-2ACEBB7DD677}"/>
               </a:ext>
             </a:extLst>
           </p:cNvPr>
@@ -9909,7 +9909,7 @@
     </p:spTree>
     <p:extLst>
       <p:ext uri="{BB962C8B-B14F-4D97-AF65-F5344CB8AC3E}">
-        <p14:creationId xmlns:p14="http://schemas.microsoft.com/office/powerpoint/2010/main" val="967767638"/>
+        <p14:creationId xmlns:p14="http://schemas.microsoft.com/office/powerpoint/2010/main" val="1751272627"/>
       </p:ext>
     </p:extLst>
   </p:cSld>
@@ -9940,7 +9940,7 @@
           <p:cNvPr id="6" name="title">
             <a:extLst xmlns:a="http://schemas.openxmlformats.org/drawingml/2006/main">
               <a:ext uri="{FF2B5EF4-FFF2-40B4-BE49-F238E27FC236}">
-                <a16:creationId xmlns:a16="http://schemas.microsoft.com/office/drawing/2014/main" id="{64D1DA3A-B01C-4660-9376-6C9A3A09585F}"/>
+                <a16:creationId xmlns:a16="http://schemas.microsoft.com/office/drawing/2014/main" id="{EB715F0B-B89B-4F74-8FA7-F1844CAC8AF4}"/>
               </a:ext>
             </a:extLst>
           </p:cNvPr>
@@ -10006,7 +10006,7 @@
           <p:cNvPr id="2" name="paragraph-0">
             <a:extLst xmlns:a="http://schemas.openxmlformats.org/drawingml/2006/main">
               <a:ext uri="{FF2B5EF4-FFF2-40B4-BE49-F238E27FC236}">
-                <a16:creationId xmlns:a16="http://schemas.microsoft.com/office/drawing/2014/main" id="{2D75815E-9039-4B1F-B78B-2FD4F3A40F7A}"/>
+                <a16:creationId xmlns:a16="http://schemas.microsoft.com/office/drawing/2014/main" id="{2A74E181-509A-496C-8A7D-E6FE64CD55DD}"/>
               </a:ext>
             </a:extLst>
           </p:cNvPr>
@@ -10072,7 +10072,7 @@
           <p:cNvPr id="3" name="paragraph-1">
             <a:extLst xmlns:a="http://schemas.openxmlformats.org/drawingml/2006/main">
               <a:ext uri="{FF2B5EF4-FFF2-40B4-BE49-F238E27FC236}">
-                <a16:creationId xmlns:a16="http://schemas.microsoft.com/office/drawing/2014/main" id="{10A5D74E-D45D-480F-B1AF-AF8076574FCA}"/>
+                <a16:creationId xmlns:a16="http://schemas.microsoft.com/office/drawing/2014/main" id="{41EE5158-AC20-4389-AA49-3F3BB749604F}"/>
               </a:ext>
             </a:extLst>
           </p:cNvPr>
@@ -10138,7 +10138,7 @@
           <p:cNvPr id="4" name="disclosure">
             <a:extLst xmlns:a="http://schemas.openxmlformats.org/drawingml/2006/main">
               <a:ext uri="{FF2B5EF4-FFF2-40B4-BE49-F238E27FC236}">
-                <a16:creationId xmlns:a16="http://schemas.microsoft.com/office/drawing/2014/main" id="{E9E6902B-F6FE-4662-B1B2-DACAD8A17D92}"/>
+                <a16:creationId xmlns:a16="http://schemas.microsoft.com/office/drawing/2014/main" id="{81D970AC-B6AB-46A0-A4FB-F8901D00B81F}"/>
               </a:ext>
             </a:extLst>
           </p:cNvPr>
@@ -10204,7 +10204,7 @@
           <p:cNvPr id="5" name="page">
             <a:extLst xmlns:a="http://schemas.openxmlformats.org/drawingml/2006/main">
               <a:ext uri="{FF2B5EF4-FFF2-40B4-BE49-F238E27FC236}">
-                <a16:creationId xmlns:a16="http://schemas.microsoft.com/office/drawing/2014/main" id="{6234D84C-8DCB-4F11-B795-20CA2C0886DC}"/>
+                <a16:creationId xmlns:a16="http://schemas.microsoft.com/office/drawing/2014/main" id="{A8435E98-5B69-4FA6-9EE9-B886E950C0E1}"/>
               </a:ext>
             </a:extLst>
           </p:cNvPr>
@@ -10268,7 +10268,7 @@
     </p:spTree>
     <p:extLst>
       <p:ext uri="{BB962C8B-B14F-4D97-AF65-F5344CB8AC3E}">
-        <p14:creationId xmlns:p14="http://schemas.microsoft.com/office/powerpoint/2010/main" val="402397853"/>
+        <p14:creationId xmlns:p14="http://schemas.microsoft.com/office/powerpoint/2010/main" val="1867948978"/>
       </p:ext>
     </p:extLst>
   </p:cSld>
@@ -10299,7 +10299,7 @@
           <p:cNvPr id="6" name="title">
             <a:extLst xmlns:a="http://schemas.openxmlformats.org/drawingml/2006/main">
               <a:ext uri="{FF2B5EF4-FFF2-40B4-BE49-F238E27FC236}">
-                <a16:creationId xmlns:a16="http://schemas.microsoft.com/office/drawing/2014/main" id="{7803692B-CB12-4A44-8782-776A8FCCFBAF}"/>
+                <a16:creationId xmlns:a16="http://schemas.microsoft.com/office/drawing/2014/main" id="{1978C53D-D3BC-4A10-9580-34C119F674B3}"/>
               </a:ext>
             </a:extLst>
           </p:cNvPr>
@@ -10365,7 +10365,7 @@
           <p:cNvPr id="2" name="paragraph-0">
             <a:extLst xmlns:a="http://schemas.openxmlformats.org/drawingml/2006/main">
               <a:ext uri="{FF2B5EF4-FFF2-40B4-BE49-F238E27FC236}">
-                <a16:creationId xmlns:a16="http://schemas.microsoft.com/office/drawing/2014/main" id="{FFD0F9A2-6859-4494-9656-9FCF8D930C84}"/>
+                <a16:creationId xmlns:a16="http://schemas.microsoft.com/office/drawing/2014/main" id="{7F97B16E-C986-4C93-A4B0-980E1CC8747D}"/>
               </a:ext>
             </a:extLst>
           </p:cNvPr>
@@ -10431,7 +10431,7 @@
           <p:cNvPr id="3" name="paragraph-1">
             <a:extLst xmlns:a="http://schemas.openxmlformats.org/drawingml/2006/main">
               <a:ext uri="{FF2B5EF4-FFF2-40B4-BE49-F238E27FC236}">
-                <a16:creationId xmlns:a16="http://schemas.microsoft.com/office/drawing/2014/main" id="{0C2F2BC6-AFD1-473C-B162-57A9AF68BF83}"/>
+                <a16:creationId xmlns:a16="http://schemas.microsoft.com/office/drawing/2014/main" id="{B9358ACA-2E33-4EAE-96F3-D781981E0074}"/>
               </a:ext>
             </a:extLst>
           </p:cNvPr>
@@ -10497,7 +10497,7 @@
           <p:cNvPr id="4" name="disclosure">
             <a:extLst xmlns:a="http://schemas.openxmlformats.org/drawingml/2006/main">
               <a:ext uri="{FF2B5EF4-FFF2-40B4-BE49-F238E27FC236}">
-                <a16:creationId xmlns:a16="http://schemas.microsoft.com/office/drawing/2014/main" id="{FDE0C100-CD68-4D2F-97B4-30EAF5AD887F}"/>
+                <a16:creationId xmlns:a16="http://schemas.microsoft.com/office/drawing/2014/main" id="{B519395A-CB30-4B16-9F20-AC13FECD2C84}"/>
               </a:ext>
             </a:extLst>
           </p:cNvPr>
@@ -10563,7 +10563,7 @@
           <p:cNvPr id="5" name="page">
             <a:extLst xmlns:a="http://schemas.openxmlformats.org/drawingml/2006/main">
               <a:ext uri="{FF2B5EF4-FFF2-40B4-BE49-F238E27FC236}">
-                <a16:creationId xmlns:a16="http://schemas.microsoft.com/office/drawing/2014/main" id="{9B488156-5258-42C4-BAAA-1C6086CEEC97}"/>
+                <a16:creationId xmlns:a16="http://schemas.microsoft.com/office/drawing/2014/main" id="{68524EC7-5738-4FC0-BA9D-F846EF4789D2}"/>
               </a:ext>
             </a:extLst>
           </p:cNvPr>
@@ -10627,7 +10627,7 @@
     </p:spTree>
     <p:extLst>
       <p:ext uri="{BB962C8B-B14F-4D97-AF65-F5344CB8AC3E}">
-        <p14:creationId xmlns:p14="http://schemas.microsoft.com/office/powerpoint/2010/main" val="158332202"/>
+        <p14:creationId xmlns:p14="http://schemas.microsoft.com/office/powerpoint/2010/main" val="1030210754"/>
       </p:ext>
     </p:extLst>
   </p:cSld>
@@ -10658,7 +10658,7 @@
           <p:cNvPr id="6" name="title">
             <a:extLst xmlns:a="http://schemas.openxmlformats.org/drawingml/2006/main">
               <a:ext uri="{FF2B5EF4-FFF2-40B4-BE49-F238E27FC236}">
-                <a16:creationId xmlns:a16="http://schemas.microsoft.com/office/drawing/2014/main" id="{6739CEBE-FEB7-4F9C-8516-3CA60971F7A8}"/>
+                <a16:creationId xmlns:a16="http://schemas.microsoft.com/office/drawing/2014/main" id="{BC90FFDD-6437-40D1-A94C-6FC69D96F1D3}"/>
               </a:ext>
             </a:extLst>
           </p:cNvPr>
@@ -10724,7 +10724,7 @@
           <p:cNvPr id="2" name="paragraph-0">
             <a:extLst xmlns:a="http://schemas.openxmlformats.org/drawingml/2006/main">
               <a:ext uri="{FF2B5EF4-FFF2-40B4-BE49-F238E27FC236}">
-                <a16:creationId xmlns:a16="http://schemas.microsoft.com/office/drawing/2014/main" id="{E17C1B41-4613-44C0-AA1D-16F1802BEAFC}"/>
+                <a16:creationId xmlns:a16="http://schemas.microsoft.com/office/drawing/2014/main" id="{FD203543-9FBC-43C9-9599-20371C0C6403}"/>
               </a:ext>
             </a:extLst>
           </p:cNvPr>
@@ -10790,7 +10790,7 @@
           <p:cNvPr id="3" name="paragraph-1">
             <a:extLst xmlns:a="http://schemas.openxmlformats.org/drawingml/2006/main">
               <a:ext uri="{FF2B5EF4-FFF2-40B4-BE49-F238E27FC236}">
-                <a16:creationId xmlns:a16="http://schemas.microsoft.com/office/drawing/2014/main" id="{D116EBC7-6E33-4A7C-9FC2-8F81E5387BA5}"/>
+                <a16:creationId xmlns:a16="http://schemas.microsoft.com/office/drawing/2014/main" id="{A9EE1C42-760E-4824-8F0C-86E3C733340C}"/>
               </a:ext>
             </a:extLst>
           </p:cNvPr>
@@ -10856,7 +10856,7 @@
           <p:cNvPr id="4" name="disclosure">
             <a:extLst xmlns:a="http://schemas.openxmlformats.org/drawingml/2006/main">
               <a:ext uri="{FF2B5EF4-FFF2-40B4-BE49-F238E27FC236}">
-                <a16:creationId xmlns:a16="http://schemas.microsoft.com/office/drawing/2014/main" id="{4DDF73D3-3239-4AAA-826A-3BD57EDFEFC1}"/>
+                <a16:creationId xmlns:a16="http://schemas.microsoft.com/office/drawing/2014/main" id="{62E726EC-7FA1-4B9C-B122-69FD663EA098}"/>
               </a:ext>
             </a:extLst>
           </p:cNvPr>
@@ -10922,7 +10922,7 @@
           <p:cNvPr id="5" name="page">
             <a:extLst xmlns:a="http://schemas.openxmlformats.org/drawingml/2006/main">
               <a:ext uri="{FF2B5EF4-FFF2-40B4-BE49-F238E27FC236}">
-                <a16:creationId xmlns:a16="http://schemas.microsoft.com/office/drawing/2014/main" id="{00DF35E9-B97A-4E85-8F22-AFBA9EC8010C}"/>
+                <a16:creationId xmlns:a16="http://schemas.microsoft.com/office/drawing/2014/main" id="{95D3C285-8E14-44A8-8B58-AE8F76220B92}"/>
               </a:ext>
             </a:extLst>
           </p:cNvPr>
@@ -10986,7 +10986,7 @@
     </p:spTree>
     <p:extLst>
       <p:ext uri="{BB962C8B-B14F-4D97-AF65-F5344CB8AC3E}">
-        <p14:creationId xmlns:p14="http://schemas.microsoft.com/office/powerpoint/2010/main" val="377406481"/>
+        <p14:creationId xmlns:p14="http://schemas.microsoft.com/office/powerpoint/2010/main" val="292379014"/>
       </p:ext>
     </p:extLst>
   </p:cSld>
@@ -11017,7 +11017,7 @@
           <p:cNvPr id="6" name="title">
             <a:extLst xmlns:a="http://schemas.openxmlformats.org/drawingml/2006/main">
               <a:ext uri="{FF2B5EF4-FFF2-40B4-BE49-F238E27FC236}">
-                <a16:creationId xmlns:a16="http://schemas.microsoft.com/office/drawing/2014/main" id="{7FF79744-3DAE-4EE9-B06D-B38C4209A98F}"/>
+                <a16:creationId xmlns:a16="http://schemas.microsoft.com/office/drawing/2014/main" id="{DB934038-B39E-4682-B0B8-75BF5CEA6A32}"/>
               </a:ext>
             </a:extLst>
           </p:cNvPr>
@@ -11083,7 +11083,7 @@
           <p:cNvPr id="2" name="paragraph-0">
             <a:extLst xmlns:a="http://schemas.openxmlformats.org/drawingml/2006/main">
               <a:ext uri="{FF2B5EF4-FFF2-40B4-BE49-F238E27FC236}">
-                <a16:creationId xmlns:a16="http://schemas.microsoft.com/office/drawing/2014/main" id="{8A3EB54F-D8D8-460E-8289-28D3D426D488}"/>
+                <a16:creationId xmlns:a16="http://schemas.microsoft.com/office/drawing/2014/main" id="{1ACD3111-A9CA-4117-9F45-968E3CA2037B}"/>
               </a:ext>
             </a:extLst>
           </p:cNvPr>
@@ -11149,7 +11149,7 @@
           <p:cNvPr id="3" name="paragraph-1">
             <a:extLst xmlns:a="http://schemas.openxmlformats.org/drawingml/2006/main">
               <a:ext uri="{FF2B5EF4-FFF2-40B4-BE49-F238E27FC236}">
-                <a16:creationId xmlns:a16="http://schemas.microsoft.com/office/drawing/2014/main" id="{4E66DD04-0EB5-46A5-B5CC-F9429D554CC8}"/>
+                <a16:creationId xmlns:a16="http://schemas.microsoft.com/office/drawing/2014/main" id="{13541858-F1B1-4B69-B2EB-92B98FF823EB}"/>
               </a:ext>
             </a:extLst>
           </p:cNvPr>
@@ -11215,7 +11215,7 @@
           <p:cNvPr id="4" name="disclosure">
             <a:extLst xmlns:a="http://schemas.openxmlformats.org/drawingml/2006/main">
               <a:ext uri="{FF2B5EF4-FFF2-40B4-BE49-F238E27FC236}">
-                <a16:creationId xmlns:a16="http://schemas.microsoft.com/office/drawing/2014/main" id="{FC1310BD-6168-4427-96B5-84A7C1DFBA62}"/>
+                <a16:creationId xmlns:a16="http://schemas.microsoft.com/office/drawing/2014/main" id="{07E0B714-1F08-4BD5-8BC1-557929D6ED6A}"/>
               </a:ext>
             </a:extLst>
           </p:cNvPr>
@@ -11281,7 +11281,7 @@
           <p:cNvPr id="5" name="page">
             <a:extLst xmlns:a="http://schemas.openxmlformats.org/drawingml/2006/main">
               <a:ext uri="{FF2B5EF4-FFF2-40B4-BE49-F238E27FC236}">
-                <a16:creationId xmlns:a16="http://schemas.microsoft.com/office/drawing/2014/main" id="{36B5E9D7-B39E-474C-B7E4-C6C776DFF1D5}"/>
+                <a16:creationId xmlns:a16="http://schemas.microsoft.com/office/drawing/2014/main" id="{E5F33A8F-D552-4DCB-9612-C05E55CDD376}"/>
               </a:ext>
             </a:extLst>
           </p:cNvPr>
@@ -11345,7 +11345,7 @@
     </p:spTree>
     <p:extLst>
       <p:ext uri="{BB962C8B-B14F-4D97-AF65-F5344CB8AC3E}">
-        <p14:creationId xmlns:p14="http://schemas.microsoft.com/office/powerpoint/2010/main" val="498000133"/>
+        <p14:creationId xmlns:p14="http://schemas.microsoft.com/office/powerpoint/2010/main" val="841121083"/>
       </p:ext>
     </p:extLst>
   </p:cSld>
@@ -11376,7 +11376,7 @@
           <p:cNvPr id="6" name="title">
             <a:extLst xmlns:a="http://schemas.openxmlformats.org/drawingml/2006/main">
               <a:ext uri="{FF2B5EF4-FFF2-40B4-BE49-F238E27FC236}">
-                <a16:creationId xmlns:a16="http://schemas.microsoft.com/office/drawing/2014/main" id="{5808B7F0-E13D-48B8-870A-8C62A73B60E9}"/>
+                <a16:creationId xmlns:a16="http://schemas.microsoft.com/office/drawing/2014/main" id="{539CE949-B690-47B0-80FE-D11D990334E3}"/>
               </a:ext>
             </a:extLst>
           </p:cNvPr>
@@ -11442,7 +11442,7 @@
           <p:cNvPr id="2" name="paragraph-0">
             <a:extLst xmlns:a="http://schemas.openxmlformats.org/drawingml/2006/main">
               <a:ext uri="{FF2B5EF4-FFF2-40B4-BE49-F238E27FC236}">
-                <a16:creationId xmlns:a16="http://schemas.microsoft.com/office/drawing/2014/main" id="{1ABCE30F-50DB-4BA3-A047-1A2B60854A2C}"/>
+                <a16:creationId xmlns:a16="http://schemas.microsoft.com/office/drawing/2014/main" id="{3F8EF423-7340-4B84-B849-5E90FEC5EC4F}"/>
               </a:ext>
             </a:extLst>
           </p:cNvPr>
@@ -11508,7 +11508,7 @@
           <p:cNvPr id="3" name="paragraph-1">
             <a:extLst xmlns:a="http://schemas.openxmlformats.org/drawingml/2006/main">
               <a:ext uri="{FF2B5EF4-FFF2-40B4-BE49-F238E27FC236}">
-                <a16:creationId xmlns:a16="http://schemas.microsoft.com/office/drawing/2014/main" id="{A25BA201-B2BC-4B1C-BEFF-2E7D68ED8A4F}"/>
+                <a16:creationId xmlns:a16="http://schemas.microsoft.com/office/drawing/2014/main" id="{081ACC03-F751-426F-8507-DCD0D6DFFCAC}"/>
               </a:ext>
             </a:extLst>
           </p:cNvPr>
@@ -11574,7 +11574,7 @@
           <p:cNvPr id="4" name="disclosure">
             <a:extLst xmlns:a="http://schemas.openxmlformats.org/drawingml/2006/main">
               <a:ext uri="{FF2B5EF4-FFF2-40B4-BE49-F238E27FC236}">
-                <a16:creationId xmlns:a16="http://schemas.microsoft.com/office/drawing/2014/main" id="{581AD79C-C1A5-43DB-AE08-B3644D75243F}"/>
+                <a16:creationId xmlns:a16="http://schemas.microsoft.com/office/drawing/2014/main" id="{5740F6AB-3EB6-4B24-BB7A-C25430B5892C}"/>
               </a:ext>
             </a:extLst>
           </p:cNvPr>
@@ -11640,7 +11640,7 @@
           <p:cNvPr id="5" name="page">
             <a:extLst xmlns:a="http://schemas.openxmlformats.org/drawingml/2006/main">
               <a:ext uri="{FF2B5EF4-FFF2-40B4-BE49-F238E27FC236}">
-                <a16:creationId xmlns:a16="http://schemas.microsoft.com/office/drawing/2014/main" id="{2CB8E65F-A7E5-4EBE-A463-82102A102040}"/>
+                <a16:creationId xmlns:a16="http://schemas.microsoft.com/office/drawing/2014/main" id="{BA11229D-5595-461C-A581-6B6B66ED6889}"/>
               </a:ext>
             </a:extLst>
           </p:cNvPr>
@@ -11704,7 +11704,7 @@
     </p:spTree>
     <p:extLst>
       <p:ext uri="{BB962C8B-B14F-4D97-AF65-F5344CB8AC3E}">
-        <p14:creationId xmlns:p14="http://schemas.microsoft.com/office/powerpoint/2010/main" val="847386994"/>
+        <p14:creationId xmlns:p14="http://schemas.microsoft.com/office/powerpoint/2010/main" val="200671057"/>
       </p:ext>
     </p:extLst>
   </p:cSld>

</xml_diff>